<commit_message>
Add knowledge base: knowledge_entries table, model, schema, service, route (CRUD per character)
</commit_message>
<xml_diff>
--- a/outputs/manual-aichat-ppt-test/presentations/aichat-process-manager/output/AIChatProcessManager-course-defense.pptx
+++ b/outputs/manual-aichat-ppt-test/presentations/aichat-process-manager/output/AIChatProcessManager-course-defense.pptx
@@ -2,23 +2,23 @@
 <file path=ppt/presentation.xml><?xml version="1.0" encoding="utf-8"?>
 <p:presentation xmlns:p="http://schemas.openxmlformats.org/presentationml/2006/main">
   <p:sldMasterIdLst>
-    <p:sldMasterId xmlns:r="http://schemas.openxmlformats.org/officeDocument/2006/relationships" id="2147483648" r:id="R5b3a15e7cc2a4b9a"/>
+    <p:sldMasterId xmlns:r="http://schemas.openxmlformats.org/officeDocument/2006/relationships" id="2147483648" r:id="Rd4d48361785e4e22"/>
   </p:sldMasterIdLst>
   <p:notesMasterIdLst>
-    <p:notesMasterId xmlns:r="http://schemas.openxmlformats.org/officeDocument/2006/relationships" r:id="Re25a3c971e384450"/>
+    <p:notesMasterId xmlns:r="http://schemas.openxmlformats.org/officeDocument/2006/relationships" r:id="Rc700fa2675f14f9c"/>
   </p:notesMasterIdLst>
   <p:sldIdLst>
-    <p:sldId xmlns:r="http://schemas.openxmlformats.org/officeDocument/2006/relationships" id="256" r:id="R00ddb5e439e84a85"/>
-    <p:sldId xmlns:r="http://schemas.openxmlformats.org/officeDocument/2006/relationships" id="257" r:id="Rfb128dfc885d4c41"/>
-    <p:sldId xmlns:r="http://schemas.openxmlformats.org/officeDocument/2006/relationships" id="258" r:id="R2602a5a68a5e4aff"/>
-    <p:sldId xmlns:r="http://schemas.openxmlformats.org/officeDocument/2006/relationships" id="259" r:id="R5de37bad167c4f7c"/>
-    <p:sldId xmlns:r="http://schemas.openxmlformats.org/officeDocument/2006/relationships" id="260" r:id="R6a7b266b3ff44d7e"/>
-    <p:sldId xmlns:r="http://schemas.openxmlformats.org/officeDocument/2006/relationships" id="261" r:id="R4a06ecae37ea4e1e"/>
-    <p:sldId xmlns:r="http://schemas.openxmlformats.org/officeDocument/2006/relationships" id="262" r:id="R7bae81dd56624a39"/>
-    <p:sldId xmlns:r="http://schemas.openxmlformats.org/officeDocument/2006/relationships" id="263" r:id="Rbde758c9fef04dd1"/>
-    <p:sldId xmlns:r="http://schemas.openxmlformats.org/officeDocument/2006/relationships" id="264" r:id="Rd1081fd12e694e46"/>
-    <p:sldId xmlns:r="http://schemas.openxmlformats.org/officeDocument/2006/relationships" id="265" r:id="Rd0e38d7419ae4010"/>
-    <p:sldId xmlns:r="http://schemas.openxmlformats.org/officeDocument/2006/relationships" id="266" r:id="Rf94d545e00d54310"/>
+    <p:sldId xmlns:r="http://schemas.openxmlformats.org/officeDocument/2006/relationships" id="256" r:id="R4adba9da46f34f2e"/>
+    <p:sldId xmlns:r="http://schemas.openxmlformats.org/officeDocument/2006/relationships" id="257" r:id="Rf3cc5b3ea1b04a9a"/>
+    <p:sldId xmlns:r="http://schemas.openxmlformats.org/officeDocument/2006/relationships" id="258" r:id="R6c96b1a9dc9e423a"/>
+    <p:sldId xmlns:r="http://schemas.openxmlformats.org/officeDocument/2006/relationships" id="259" r:id="Rf6978cd351d647ee"/>
+    <p:sldId xmlns:r="http://schemas.openxmlformats.org/officeDocument/2006/relationships" id="260" r:id="R7fcf6ea906b74477"/>
+    <p:sldId xmlns:r="http://schemas.openxmlformats.org/officeDocument/2006/relationships" id="261" r:id="R68eabd7d20d24cd6"/>
+    <p:sldId xmlns:r="http://schemas.openxmlformats.org/officeDocument/2006/relationships" id="262" r:id="R1f149ea9dbb143ba"/>
+    <p:sldId xmlns:r="http://schemas.openxmlformats.org/officeDocument/2006/relationships" id="263" r:id="R496d9852157640c7"/>
+    <p:sldId xmlns:r="http://schemas.openxmlformats.org/officeDocument/2006/relationships" id="264" r:id="Rc6a257a63d594e80"/>
+    <p:sldId xmlns:r="http://schemas.openxmlformats.org/officeDocument/2006/relationships" id="265" r:id="Rcf8b1b17108d4ab8"/>
+    <p:sldId xmlns:r="http://schemas.openxmlformats.org/officeDocument/2006/relationships" id="266" r:id="R6d18cabcb5774e02"/>
   </p:sldIdLst>
   <p:sldSz cx="12192000" cy="6858000"/>
   <p:notesSz cx="6858000" cy="9144000"/>
@@ -1225,7 +1225,7 @@
   </p:cSld>
   <p:clrMap bg1="lt1" tx1="dk1" bg2="lt2" tx2="dk2" accent1="accent1" accent2="accent2" accent3="accent3" accent4="accent4" accent5="accent5" accent6="accent6" hlink="hlink" folHlink="folHlink"/>
   <p:sldLayoutIdLst>
-    <p:sldLayoutId xmlns:r="http://schemas.openxmlformats.org/officeDocument/2006/relationships" id="2147483649" r:id="Rb14a6593253c4070"/>
+    <p:sldLayoutId xmlns:r="http://schemas.openxmlformats.org/officeDocument/2006/relationships" id="2147483649" r:id="R8d90d25dd4e94128"/>
   </p:sldLayoutIdLst>
   <p:txStyles>
     <p:titleStyle>
@@ -1723,7 +1723,7 @@
           <p:cNvPr id="1" name="">
             <a:extLst xmlns:a="http://schemas.openxmlformats.org/drawingml/2006/main">
               <a:ext uri="{FF2B5EF4-FFF2-40B4-BE49-F238E27FC236}">
-                <a16:creationId xmlns:a16="http://schemas.microsoft.com/office/drawing/2014/main" id="{B0DBD202-AB7B-47EC-9842-7D7CF9186CD0}"/>
+                <a16:creationId xmlns:a16="http://schemas.microsoft.com/office/drawing/2014/main" id="{76C15838-6DFB-4306-871A-092565EAC9CD}"/>
               </a:ext>
             </a:extLst>
           </p:cNvPr>
@@ -1758,7 +1758,7 @@
           <p:cNvPr id="2" name="">
             <a:extLst xmlns:a="http://schemas.openxmlformats.org/drawingml/2006/main">
               <a:ext uri="{FF2B5EF4-FFF2-40B4-BE49-F238E27FC236}">
-                <a16:creationId xmlns:a16="http://schemas.microsoft.com/office/drawing/2014/main" id="{F382EA46-FA2C-42A9-A244-FE4B8EDA3FD1}"/>
+                <a16:creationId xmlns:a16="http://schemas.microsoft.com/office/drawing/2014/main" id="{922D91B2-EC8D-4F66-A9B6-C3B28741A932}"/>
               </a:ext>
             </a:extLst>
           </p:cNvPr>
@@ -1793,7 +1793,7 @@
           <p:cNvPr id="3" name="">
             <a:extLst xmlns:a="http://schemas.openxmlformats.org/drawingml/2006/main">
               <a:ext uri="{FF2B5EF4-FFF2-40B4-BE49-F238E27FC236}">
-                <a16:creationId xmlns:a16="http://schemas.microsoft.com/office/drawing/2014/main" id="{407962BC-EDC3-4752-A2FE-CB75ECE0C589}"/>
+                <a16:creationId xmlns:a16="http://schemas.microsoft.com/office/drawing/2014/main" id="{C1DD77C0-FB4D-448F-A014-7F7BDFCA994B}"/>
               </a:ext>
             </a:extLst>
           </p:cNvPr>
@@ -1828,7 +1828,7 @@
           <p:cNvPr id="4" name="">
             <a:extLst xmlns:a="http://schemas.openxmlformats.org/drawingml/2006/main">
               <a:ext uri="{FF2B5EF4-FFF2-40B4-BE49-F238E27FC236}">
-                <a16:creationId xmlns:a16="http://schemas.microsoft.com/office/drawing/2014/main" id="{6A393B03-CD37-4743-BC06-B62C17407F80}"/>
+                <a16:creationId xmlns:a16="http://schemas.microsoft.com/office/drawing/2014/main" id="{7D98E884-D200-46EE-A447-0D78C97B9707}"/>
               </a:ext>
             </a:extLst>
           </p:cNvPr>
@@ -1863,7 +1863,7 @@
           <p:cNvPr id="5" name="">
             <a:extLst xmlns:a="http://schemas.openxmlformats.org/drawingml/2006/main">
               <a:ext uri="{FF2B5EF4-FFF2-40B4-BE49-F238E27FC236}">
-                <a16:creationId xmlns:a16="http://schemas.microsoft.com/office/drawing/2014/main" id="{6ADDFD8D-2191-4FC4-B5DD-85BE4B65A319}"/>
+                <a16:creationId xmlns:a16="http://schemas.microsoft.com/office/drawing/2014/main" id="{52E22073-47BD-4444-9013-9F0139F4D621}"/>
               </a:ext>
             </a:extLst>
           </p:cNvPr>
@@ -1927,7 +1927,7 @@
           <p:cNvPr id="6" name="">
             <a:extLst xmlns:a="http://schemas.openxmlformats.org/drawingml/2006/main">
               <a:ext uri="{FF2B5EF4-FFF2-40B4-BE49-F238E27FC236}">
-                <a16:creationId xmlns:a16="http://schemas.microsoft.com/office/drawing/2014/main" id="{CDC46731-2269-4BAE-A230-F273CF74739F}"/>
+                <a16:creationId xmlns:a16="http://schemas.microsoft.com/office/drawing/2014/main" id="{E8A64026-83AE-4FBA-810B-7947C881EE0E}"/>
               </a:ext>
             </a:extLst>
           </p:cNvPr>
@@ -1991,7 +1991,7 @@
           <p:cNvPr id="7" name="">
             <a:extLst xmlns:a="http://schemas.openxmlformats.org/drawingml/2006/main">
               <a:ext uri="{FF2B5EF4-FFF2-40B4-BE49-F238E27FC236}">
-                <a16:creationId xmlns:a16="http://schemas.microsoft.com/office/drawing/2014/main" id="{87A70A4F-64E8-4426-A1BE-9BB849A44163}"/>
+                <a16:creationId xmlns:a16="http://schemas.microsoft.com/office/drawing/2014/main" id="{05A5C640-7040-406E-B467-06D50DD88CF3}"/>
               </a:ext>
             </a:extLst>
           </p:cNvPr>
@@ -2055,7 +2055,7 @@
           <p:cNvPr id="8" name="">
             <a:extLst xmlns:a="http://schemas.openxmlformats.org/drawingml/2006/main">
               <a:ext uri="{FF2B5EF4-FFF2-40B4-BE49-F238E27FC236}">
-                <a16:creationId xmlns:a16="http://schemas.microsoft.com/office/drawing/2014/main" id="{87492129-2717-4730-8D8A-A0F5E6815278}"/>
+                <a16:creationId xmlns:a16="http://schemas.microsoft.com/office/drawing/2014/main" id="{13E377A1-5A49-486E-B4D4-6BCDCCF72731}"/>
               </a:ext>
             </a:extLst>
           </p:cNvPr>
@@ -2119,7 +2119,7 @@
           <p:cNvPr id="9" name="">
             <a:extLst xmlns:a="http://schemas.openxmlformats.org/drawingml/2006/main">
               <a:ext uri="{FF2B5EF4-FFF2-40B4-BE49-F238E27FC236}">
-                <a16:creationId xmlns:a16="http://schemas.microsoft.com/office/drawing/2014/main" id="{F4859829-1C8A-4C33-8D78-F4637245D8F6}"/>
+                <a16:creationId xmlns:a16="http://schemas.microsoft.com/office/drawing/2014/main" id="{2989DB11-3445-4825-BD48-BD3D69F46717}"/>
               </a:ext>
             </a:extLst>
           </p:cNvPr>
@@ -2156,7 +2156,7 @@
           <p:cNvPr id="10" name="">
             <a:extLst xmlns:a="http://schemas.openxmlformats.org/drawingml/2006/main">
               <a:ext uri="{FF2B5EF4-FFF2-40B4-BE49-F238E27FC236}">
-                <a16:creationId xmlns:a16="http://schemas.microsoft.com/office/drawing/2014/main" id="{71EC8D09-C1BE-4F59-985F-9AB7B411808D}"/>
+                <a16:creationId xmlns:a16="http://schemas.microsoft.com/office/drawing/2014/main" id="{EE2438CE-E69F-4B18-AF03-C5950BDD67B2}"/>
               </a:ext>
             </a:extLst>
           </p:cNvPr>
@@ -2220,7 +2220,7 @@
           <p:cNvPr id="11" name="">
             <a:extLst xmlns:a="http://schemas.openxmlformats.org/drawingml/2006/main">
               <a:ext uri="{FF2B5EF4-FFF2-40B4-BE49-F238E27FC236}">
-                <a16:creationId xmlns:a16="http://schemas.microsoft.com/office/drawing/2014/main" id="{B9816800-4D60-49FE-9538-7DBAFCEA2AF6}"/>
+                <a16:creationId xmlns:a16="http://schemas.microsoft.com/office/drawing/2014/main" id="{ADC1A19A-9E53-4287-B755-B0E50B2C9F3F}"/>
               </a:ext>
             </a:extLst>
           </p:cNvPr>
@@ -2284,7 +2284,7 @@
           <p:cNvPr id="12" name="">
             <a:extLst xmlns:a="http://schemas.openxmlformats.org/drawingml/2006/main">
               <a:ext uri="{FF2B5EF4-FFF2-40B4-BE49-F238E27FC236}">
-                <a16:creationId xmlns:a16="http://schemas.microsoft.com/office/drawing/2014/main" id="{4F5C8921-B2B8-40FF-9F57-A837C9E957CA}"/>
+                <a16:creationId xmlns:a16="http://schemas.microsoft.com/office/drawing/2014/main" id="{A21CCC0F-5CFC-48A6-B51B-DF89DA7056C2}"/>
               </a:ext>
             </a:extLst>
           </p:cNvPr>
@@ -2338,7 +2338,7 @@
                 <a:ea typeface="PingFang SC"/>
                 <a:cs typeface="PingFang SC"/>
               </a:rPr>
-              <a:t>3</a:t>
+              <a:t>2</a:t>
             </a:r>
           </a:p>
         </p:txBody>
@@ -2348,7 +2348,7 @@
           <p:cNvPr id="13" name="">
             <a:extLst xmlns:a="http://schemas.openxmlformats.org/drawingml/2006/main">
               <a:ext uri="{FF2B5EF4-FFF2-40B4-BE49-F238E27FC236}">
-                <a16:creationId xmlns:a16="http://schemas.microsoft.com/office/drawing/2014/main" id="{CD20E777-CCEA-4552-9BF8-4CE8909C863A}"/>
+                <a16:creationId xmlns:a16="http://schemas.microsoft.com/office/drawing/2014/main" id="{6B86AA82-AC96-4D5B-97F1-63038A5D9955}"/>
               </a:ext>
             </a:extLst>
           </p:cNvPr>
@@ -2402,7 +2402,7 @@
                 <a:ea typeface="PingFang SC"/>
                 <a:cs typeface="PingFang SC"/>
               </a:rPr>
-              <a:t>业务角色</a:t>
+              <a:t>用户角色</a:t>
             </a:r>
           </a:p>
         </p:txBody>
@@ -2412,7 +2412,7 @@
           <p:cNvPr id="14" name="">
             <a:extLst xmlns:a="http://schemas.openxmlformats.org/drawingml/2006/main">
               <a:ext uri="{FF2B5EF4-FFF2-40B4-BE49-F238E27FC236}">
-                <a16:creationId xmlns:a16="http://schemas.microsoft.com/office/drawing/2014/main" id="{A21DD1B9-8424-4EDC-A234-95385CD75544}"/>
+                <a16:creationId xmlns:a16="http://schemas.microsoft.com/office/drawing/2014/main" id="{47C87701-5B34-45B1-9BFA-A97B454B8940}"/>
               </a:ext>
             </a:extLst>
           </p:cNvPr>
@@ -2476,7 +2476,7 @@
           <p:cNvPr id="15" name="">
             <a:extLst xmlns:a="http://schemas.openxmlformats.org/drawingml/2006/main">
               <a:ext uri="{FF2B5EF4-FFF2-40B4-BE49-F238E27FC236}">
-                <a16:creationId xmlns:a16="http://schemas.microsoft.com/office/drawing/2014/main" id="{CD574ED6-65BC-4541-90E8-C2C3A30CF341}"/>
+                <a16:creationId xmlns:a16="http://schemas.microsoft.com/office/drawing/2014/main" id="{38F54F53-093D-4A45-9EDB-F8D9F6161330}"/>
               </a:ext>
             </a:extLst>
           </p:cNvPr>
@@ -2540,7 +2540,7 @@
           <p:cNvPr id="16" name="">
             <a:extLst xmlns:a="http://schemas.openxmlformats.org/drawingml/2006/main">
               <a:ext uri="{FF2B5EF4-FFF2-40B4-BE49-F238E27FC236}">
-                <a16:creationId xmlns:a16="http://schemas.microsoft.com/office/drawing/2014/main" id="{DFF9FE4A-1611-46E1-852D-73108ED499BA}"/>
+                <a16:creationId xmlns:a16="http://schemas.microsoft.com/office/drawing/2014/main" id="{28CF4243-C087-4DE9-BA89-A403B7E21F1B}"/>
               </a:ext>
             </a:extLst>
           </p:cNvPr>
@@ -2604,7 +2604,7 @@
           <p:cNvPr id="17" name="">
             <a:extLst xmlns:a="http://schemas.openxmlformats.org/drawingml/2006/main">
               <a:ext uri="{FF2B5EF4-FFF2-40B4-BE49-F238E27FC236}">
-                <a16:creationId xmlns:a16="http://schemas.microsoft.com/office/drawing/2014/main" id="{FA5A0AC3-8427-43F0-82C8-E5AFC1E9D362}"/>
+                <a16:creationId xmlns:a16="http://schemas.microsoft.com/office/drawing/2014/main" id="{C33A1DE4-A57F-4122-9CB6-7C3866F2991F}"/>
               </a:ext>
             </a:extLst>
           </p:cNvPr>
@@ -2668,7 +2668,7 @@
           <p:cNvPr id="18" name="">
             <a:extLst xmlns:a="http://schemas.openxmlformats.org/drawingml/2006/main">
               <a:ext uri="{FF2B5EF4-FFF2-40B4-BE49-F238E27FC236}">
-                <a16:creationId xmlns:a16="http://schemas.microsoft.com/office/drawing/2014/main" id="{D2CA741F-C0E2-43F3-8633-5B20C715E116}"/>
+                <a16:creationId xmlns:a16="http://schemas.microsoft.com/office/drawing/2014/main" id="{45A800C6-437E-438C-8D77-80BE672DFADF}"/>
               </a:ext>
             </a:extLst>
           </p:cNvPr>
@@ -2732,7 +2732,7 @@
           <p:cNvPr id="19" name="">
             <a:extLst xmlns:a="http://schemas.openxmlformats.org/drawingml/2006/main">
               <a:ext uri="{FF2B5EF4-FFF2-40B4-BE49-F238E27FC236}">
-                <a16:creationId xmlns:a16="http://schemas.microsoft.com/office/drawing/2014/main" id="{B5294C11-8CAD-4073-84C3-6EB1827B0395}"/>
+                <a16:creationId xmlns:a16="http://schemas.microsoft.com/office/drawing/2014/main" id="{D56AE375-51E2-472A-ABAE-ABC47021A5D5}"/>
               </a:ext>
             </a:extLst>
           </p:cNvPr>
@@ -2794,7 +2794,7 @@
     </p:spTree>
     <p:extLst>
       <p:ext uri="{BB962C8B-B14F-4D97-AF65-F5344CB8AC3E}">
-        <p14:creationId xmlns:p14="http://schemas.microsoft.com/office/powerpoint/2010/main" val="1377102391"/>
+        <p14:creationId xmlns:p14="http://schemas.microsoft.com/office/powerpoint/2010/main" val="301527293"/>
       </p:ext>
     </p:extLst>
   </p:cSld>
@@ -2818,7 +2818,7 @@
           <p:cNvPr id="1" name="">
             <a:extLst xmlns:a="http://schemas.openxmlformats.org/drawingml/2006/main">
               <a:ext uri="{FF2B5EF4-FFF2-40B4-BE49-F238E27FC236}">
-                <a16:creationId xmlns:a16="http://schemas.microsoft.com/office/drawing/2014/main" id="{7846964B-DAF2-4BC9-8181-7BB739BB51E3}"/>
+                <a16:creationId xmlns:a16="http://schemas.microsoft.com/office/drawing/2014/main" id="{2CD2EEEC-EF65-4395-8E7E-28FD5F1FD704}"/>
               </a:ext>
             </a:extLst>
           </p:cNvPr>
@@ -2853,7 +2853,7 @@
           <p:cNvPr id="2" name="">
             <a:extLst xmlns:a="http://schemas.openxmlformats.org/drawingml/2006/main">
               <a:ext uri="{FF2B5EF4-FFF2-40B4-BE49-F238E27FC236}">
-                <a16:creationId xmlns:a16="http://schemas.microsoft.com/office/drawing/2014/main" id="{363D9861-D4AC-4BF1-88AA-FF88506450C0}"/>
+                <a16:creationId xmlns:a16="http://schemas.microsoft.com/office/drawing/2014/main" id="{C1942D0C-53CB-4012-AEC6-6695B1E46995}"/>
               </a:ext>
             </a:extLst>
           </p:cNvPr>
@@ -2888,7 +2888,7 @@
           <p:cNvPr id="3" name="">
             <a:extLst xmlns:a="http://schemas.openxmlformats.org/drawingml/2006/main">
               <a:ext uri="{FF2B5EF4-FFF2-40B4-BE49-F238E27FC236}">
-                <a16:creationId xmlns:a16="http://schemas.microsoft.com/office/drawing/2014/main" id="{9B908D21-7AB9-4A69-908D-5554643C8776}"/>
+                <a16:creationId xmlns:a16="http://schemas.microsoft.com/office/drawing/2014/main" id="{4D608273-DE03-4E46-A27A-94F52179132A}"/>
               </a:ext>
             </a:extLst>
           </p:cNvPr>
@@ -2923,7 +2923,7 @@
           <p:cNvPr id="4" name="">
             <a:extLst xmlns:a="http://schemas.openxmlformats.org/drawingml/2006/main">
               <a:ext uri="{FF2B5EF4-FFF2-40B4-BE49-F238E27FC236}">
-                <a16:creationId xmlns:a16="http://schemas.microsoft.com/office/drawing/2014/main" id="{42AB80E6-79F6-4C98-B4E4-812AD4C3A14C}"/>
+                <a16:creationId xmlns:a16="http://schemas.microsoft.com/office/drawing/2014/main" id="{E59443AB-49B6-443E-BEE7-2B2C3827C10C}"/>
               </a:ext>
             </a:extLst>
           </p:cNvPr>
@@ -2987,7 +2987,7 @@
           <p:cNvPr id="5" name="">
             <a:extLst xmlns:a="http://schemas.openxmlformats.org/drawingml/2006/main">
               <a:ext uri="{FF2B5EF4-FFF2-40B4-BE49-F238E27FC236}">
-                <a16:creationId xmlns:a16="http://schemas.microsoft.com/office/drawing/2014/main" id="{0C777D3F-2421-40CF-8DAE-80C9723C89B5}"/>
+                <a16:creationId xmlns:a16="http://schemas.microsoft.com/office/drawing/2014/main" id="{54FBCB1E-F91D-4CA4-92A7-202778FD8180}"/>
               </a:ext>
             </a:extLst>
           </p:cNvPr>
@@ -3051,7 +3051,7 @@
           <p:cNvPr id="6" name="">
             <a:extLst xmlns:a="http://schemas.openxmlformats.org/drawingml/2006/main">
               <a:ext uri="{FF2B5EF4-FFF2-40B4-BE49-F238E27FC236}">
-                <a16:creationId xmlns:a16="http://schemas.microsoft.com/office/drawing/2014/main" id="{FD8E6D58-7017-4E10-B78C-E1C5B67E6620}"/>
+                <a16:creationId xmlns:a16="http://schemas.microsoft.com/office/drawing/2014/main" id="{ACA2A945-1621-4E95-9BF9-EDB403CF5D9C}"/>
               </a:ext>
             </a:extLst>
           </p:cNvPr>
@@ -3084,7 +3084,7 @@
           <p:cNvPr id="7" name="">
             <a:extLst xmlns:a="http://schemas.openxmlformats.org/drawingml/2006/main">
               <a:ext uri="{FF2B5EF4-FFF2-40B4-BE49-F238E27FC236}">
-                <a16:creationId xmlns:a16="http://schemas.microsoft.com/office/drawing/2014/main" id="{2674BEFB-2AA3-420E-89BB-79859F3F697B}"/>
+                <a16:creationId xmlns:a16="http://schemas.microsoft.com/office/drawing/2014/main" id="{C0E382A0-0857-4643-BED2-110F7FDBD899}"/>
               </a:ext>
             </a:extLst>
           </p:cNvPr>
@@ -3119,7 +3119,7 @@
           <p:cNvPr id="8" name="">
             <a:extLst xmlns:a="http://schemas.openxmlformats.org/drawingml/2006/main">
               <a:ext uri="{FF2B5EF4-FFF2-40B4-BE49-F238E27FC236}">
-                <a16:creationId xmlns:a16="http://schemas.microsoft.com/office/drawing/2014/main" id="{A4EBD1FA-5B8D-46BA-8971-845AE1BC75CA}"/>
+                <a16:creationId xmlns:a16="http://schemas.microsoft.com/office/drawing/2014/main" id="{3284156F-910E-47AA-A9C9-E545449D2D22}"/>
               </a:ext>
             </a:extLst>
           </p:cNvPr>
@@ -3183,7 +3183,7 @@
           <p:cNvPr id="9" name="">
             <a:extLst xmlns:a="http://schemas.openxmlformats.org/drawingml/2006/main">
               <a:ext uri="{FF2B5EF4-FFF2-40B4-BE49-F238E27FC236}">
-                <a16:creationId xmlns:a16="http://schemas.microsoft.com/office/drawing/2014/main" id="{B9B734E3-11F8-455B-9C0B-823168D7246E}"/>
+                <a16:creationId xmlns:a16="http://schemas.microsoft.com/office/drawing/2014/main" id="{47BA7C51-71BF-4727-8DCE-A872D958FAA4}"/>
               </a:ext>
             </a:extLst>
           </p:cNvPr>
@@ -3247,7 +3247,7 @@
           <p:cNvPr id="10" name="">
             <a:extLst xmlns:a="http://schemas.openxmlformats.org/drawingml/2006/main">
               <a:ext uri="{FF2B5EF4-FFF2-40B4-BE49-F238E27FC236}">
-                <a16:creationId xmlns:a16="http://schemas.microsoft.com/office/drawing/2014/main" id="{0FDD1DD8-EE15-4409-A128-1D2029ABBFF1}"/>
+                <a16:creationId xmlns:a16="http://schemas.microsoft.com/office/drawing/2014/main" id="{C840F565-96CF-4742-BE12-9E56DCE80BA8}"/>
               </a:ext>
             </a:extLst>
           </p:cNvPr>
@@ -3282,7 +3282,7 @@
           <p:cNvPr id="11" name="">
             <a:extLst xmlns:a="http://schemas.openxmlformats.org/drawingml/2006/main">
               <a:ext uri="{FF2B5EF4-FFF2-40B4-BE49-F238E27FC236}">
-                <a16:creationId xmlns:a16="http://schemas.microsoft.com/office/drawing/2014/main" id="{C50C2209-0452-4387-870A-37D52E1D4DE8}"/>
+                <a16:creationId xmlns:a16="http://schemas.microsoft.com/office/drawing/2014/main" id="{2C80056A-E1E7-4970-8612-807DCB282D9F}"/>
               </a:ext>
             </a:extLst>
           </p:cNvPr>
@@ -3315,7 +3315,7 @@
           <p:cNvPr id="12" name="">
             <a:extLst xmlns:a="http://schemas.openxmlformats.org/drawingml/2006/main">
               <a:ext uri="{FF2B5EF4-FFF2-40B4-BE49-F238E27FC236}">
-                <a16:creationId xmlns:a16="http://schemas.microsoft.com/office/drawing/2014/main" id="{B11ED011-C472-41DC-A1D0-F4206349C42F}"/>
+                <a16:creationId xmlns:a16="http://schemas.microsoft.com/office/drawing/2014/main" id="{8592CD3D-6803-49C8-89B4-F20C86EF36FE}"/>
               </a:ext>
             </a:extLst>
           </p:cNvPr>
@@ -3348,7 +3348,7 @@
           <p:cNvPr id="13" name="">
             <a:extLst xmlns:a="http://schemas.openxmlformats.org/drawingml/2006/main">
               <a:ext uri="{FF2B5EF4-FFF2-40B4-BE49-F238E27FC236}">
-                <a16:creationId xmlns:a16="http://schemas.microsoft.com/office/drawing/2014/main" id="{4FF3097B-C0CA-429C-AF86-AEDC0382F030}"/>
+                <a16:creationId xmlns:a16="http://schemas.microsoft.com/office/drawing/2014/main" id="{5ECD716C-BCD1-4AE5-A8FE-67624A4853FE}"/>
               </a:ext>
             </a:extLst>
           </p:cNvPr>
@@ -3383,7 +3383,7 @@
           <p:cNvPr id="14" name="">
             <a:extLst xmlns:a="http://schemas.openxmlformats.org/drawingml/2006/main">
               <a:ext uri="{FF2B5EF4-FFF2-40B4-BE49-F238E27FC236}">
-                <a16:creationId xmlns:a16="http://schemas.microsoft.com/office/drawing/2014/main" id="{045E7BC9-87C7-482B-AF93-87D2BC2FB690}"/>
+                <a16:creationId xmlns:a16="http://schemas.microsoft.com/office/drawing/2014/main" id="{AEBDFEF5-3081-4765-95E0-9EC303CEC114}"/>
               </a:ext>
             </a:extLst>
           </p:cNvPr>
@@ -3447,7 +3447,7 @@
           <p:cNvPr id="15" name="">
             <a:extLst xmlns:a="http://schemas.openxmlformats.org/drawingml/2006/main">
               <a:ext uri="{FF2B5EF4-FFF2-40B4-BE49-F238E27FC236}">
-                <a16:creationId xmlns:a16="http://schemas.microsoft.com/office/drawing/2014/main" id="{4A88BFD7-5667-41D6-B643-F3EFAADDCEE1}"/>
+                <a16:creationId xmlns:a16="http://schemas.microsoft.com/office/drawing/2014/main" id="{CB080FB9-3A06-43DC-A314-FFEFB67DCAC8}"/>
               </a:ext>
             </a:extLst>
           </p:cNvPr>
@@ -3511,7 +3511,7 @@
           <p:cNvPr id="16" name="">
             <a:extLst xmlns:a="http://schemas.openxmlformats.org/drawingml/2006/main">
               <a:ext uri="{FF2B5EF4-FFF2-40B4-BE49-F238E27FC236}">
-                <a16:creationId xmlns:a16="http://schemas.microsoft.com/office/drawing/2014/main" id="{3CD662C7-1167-4A13-93C8-E6D13E566C28}"/>
+                <a16:creationId xmlns:a16="http://schemas.microsoft.com/office/drawing/2014/main" id="{ECB35A90-9F03-42AC-9B98-0867CF576FDB}"/>
               </a:ext>
             </a:extLst>
           </p:cNvPr>
@@ -3546,7 +3546,7 @@
           <p:cNvPr id="17" name="">
             <a:extLst xmlns:a="http://schemas.openxmlformats.org/drawingml/2006/main">
               <a:ext uri="{FF2B5EF4-FFF2-40B4-BE49-F238E27FC236}">
-                <a16:creationId xmlns:a16="http://schemas.microsoft.com/office/drawing/2014/main" id="{312E56C9-C03D-4461-B19A-3B07626C06D7}"/>
+                <a16:creationId xmlns:a16="http://schemas.microsoft.com/office/drawing/2014/main" id="{2D75AA73-D997-4338-B08E-64FFA5F8096D}"/>
               </a:ext>
             </a:extLst>
           </p:cNvPr>
@@ -3579,7 +3579,7 @@
           <p:cNvPr id="18" name="">
             <a:extLst xmlns:a="http://schemas.openxmlformats.org/drawingml/2006/main">
               <a:ext uri="{FF2B5EF4-FFF2-40B4-BE49-F238E27FC236}">
-                <a16:creationId xmlns:a16="http://schemas.microsoft.com/office/drawing/2014/main" id="{A54D3FAD-D862-4B21-83A6-0A8693C6F8A4}"/>
+                <a16:creationId xmlns:a16="http://schemas.microsoft.com/office/drawing/2014/main" id="{E0F37E8E-5D24-4855-8AC9-4481AD61B2F3}"/>
               </a:ext>
             </a:extLst>
           </p:cNvPr>
@@ -3612,7 +3612,7 @@
           <p:cNvPr id="19" name="">
             <a:extLst xmlns:a="http://schemas.openxmlformats.org/drawingml/2006/main">
               <a:ext uri="{FF2B5EF4-FFF2-40B4-BE49-F238E27FC236}">
-                <a16:creationId xmlns:a16="http://schemas.microsoft.com/office/drawing/2014/main" id="{D6A3BD2B-A09A-4F7C-9E70-A9AF6D215048}"/>
+                <a16:creationId xmlns:a16="http://schemas.microsoft.com/office/drawing/2014/main" id="{30BA22CB-8079-4EB6-A8F7-C2940E3D12E2}"/>
               </a:ext>
             </a:extLst>
           </p:cNvPr>
@@ -3647,7 +3647,7 @@
           <p:cNvPr id="20" name="">
             <a:extLst xmlns:a="http://schemas.openxmlformats.org/drawingml/2006/main">
               <a:ext uri="{FF2B5EF4-FFF2-40B4-BE49-F238E27FC236}">
-                <a16:creationId xmlns:a16="http://schemas.microsoft.com/office/drawing/2014/main" id="{9702C1A5-A3F4-4176-92E9-A648040D76C3}"/>
+                <a16:creationId xmlns:a16="http://schemas.microsoft.com/office/drawing/2014/main" id="{2DC4DD0F-65BE-4926-A49E-823C09E240E5}"/>
               </a:ext>
             </a:extLst>
           </p:cNvPr>
@@ -3711,7 +3711,7 @@
           <p:cNvPr id="21" name="">
             <a:extLst xmlns:a="http://schemas.openxmlformats.org/drawingml/2006/main">
               <a:ext uri="{FF2B5EF4-FFF2-40B4-BE49-F238E27FC236}">
-                <a16:creationId xmlns:a16="http://schemas.microsoft.com/office/drawing/2014/main" id="{3F0FE4FE-1A7F-4E97-96B6-62A2AADDD95B}"/>
+                <a16:creationId xmlns:a16="http://schemas.microsoft.com/office/drawing/2014/main" id="{4414F2D5-572A-405A-82C2-FFCA636EB0E2}"/>
               </a:ext>
             </a:extLst>
           </p:cNvPr>
@@ -3775,7 +3775,7 @@
           <p:cNvPr id="22" name="">
             <a:extLst xmlns:a="http://schemas.openxmlformats.org/drawingml/2006/main">
               <a:ext uri="{FF2B5EF4-FFF2-40B4-BE49-F238E27FC236}">
-                <a16:creationId xmlns:a16="http://schemas.microsoft.com/office/drawing/2014/main" id="{6579BE34-C617-40DD-A919-D86E419DF455}"/>
+                <a16:creationId xmlns:a16="http://schemas.microsoft.com/office/drawing/2014/main" id="{5FD70646-C4F6-409D-9EA9-1ECEE4B3B06A}"/>
               </a:ext>
             </a:extLst>
           </p:cNvPr>
@@ -3810,7 +3810,7 @@
           <p:cNvPr id="23" name="">
             <a:extLst xmlns:a="http://schemas.openxmlformats.org/drawingml/2006/main">
               <a:ext uri="{FF2B5EF4-FFF2-40B4-BE49-F238E27FC236}">
-                <a16:creationId xmlns:a16="http://schemas.microsoft.com/office/drawing/2014/main" id="{9C51E024-4766-4B0E-A135-D7CE8C9AD282}"/>
+                <a16:creationId xmlns:a16="http://schemas.microsoft.com/office/drawing/2014/main" id="{E3F2217F-4749-403E-BBE2-90B23978E1E9}"/>
               </a:ext>
             </a:extLst>
           </p:cNvPr>
@@ -3843,7 +3843,7 @@
           <p:cNvPr id="24" name="">
             <a:extLst xmlns:a="http://schemas.openxmlformats.org/drawingml/2006/main">
               <a:ext uri="{FF2B5EF4-FFF2-40B4-BE49-F238E27FC236}">
-                <a16:creationId xmlns:a16="http://schemas.microsoft.com/office/drawing/2014/main" id="{3FA2537D-6E01-41F3-B379-E70C7DCA0156}"/>
+                <a16:creationId xmlns:a16="http://schemas.microsoft.com/office/drawing/2014/main" id="{3B96A2C0-A42E-4D41-8DDE-F32AF87E9203}"/>
               </a:ext>
             </a:extLst>
           </p:cNvPr>
@@ -3876,7 +3876,7 @@
           <p:cNvPr id="25" name="">
             <a:extLst xmlns:a="http://schemas.openxmlformats.org/drawingml/2006/main">
               <a:ext uri="{FF2B5EF4-FFF2-40B4-BE49-F238E27FC236}">
-                <a16:creationId xmlns:a16="http://schemas.microsoft.com/office/drawing/2014/main" id="{6BC2CD9B-20E3-4BC4-84BA-D01AD4B52275}"/>
+                <a16:creationId xmlns:a16="http://schemas.microsoft.com/office/drawing/2014/main" id="{25850875-0C72-4EDC-BF8E-8B9B8F2A75FA}"/>
               </a:ext>
             </a:extLst>
           </p:cNvPr>
@@ -3911,7 +3911,7 @@
           <p:cNvPr id="26" name="">
             <a:extLst xmlns:a="http://schemas.openxmlformats.org/drawingml/2006/main">
               <a:ext uri="{FF2B5EF4-FFF2-40B4-BE49-F238E27FC236}">
-                <a16:creationId xmlns:a16="http://schemas.microsoft.com/office/drawing/2014/main" id="{585689C2-BC08-4CBF-974C-2605462B711D}"/>
+                <a16:creationId xmlns:a16="http://schemas.microsoft.com/office/drawing/2014/main" id="{B9711D9F-0625-4C8B-AF79-2767CF1D328A}"/>
               </a:ext>
             </a:extLst>
           </p:cNvPr>
@@ -3975,7 +3975,7 @@
           <p:cNvPr id="27" name="">
             <a:extLst xmlns:a="http://schemas.openxmlformats.org/drawingml/2006/main">
               <a:ext uri="{FF2B5EF4-FFF2-40B4-BE49-F238E27FC236}">
-                <a16:creationId xmlns:a16="http://schemas.microsoft.com/office/drawing/2014/main" id="{E801A3EA-7B56-4067-8FE6-E5D46C48CF67}"/>
+                <a16:creationId xmlns:a16="http://schemas.microsoft.com/office/drawing/2014/main" id="{BE1FE5F6-1D21-4D9A-99B9-DD939EE7DF0F}"/>
               </a:ext>
             </a:extLst>
           </p:cNvPr>
@@ -4039,7 +4039,7 @@
           <p:cNvPr id="28" name="">
             <a:extLst xmlns:a="http://schemas.openxmlformats.org/drawingml/2006/main">
               <a:ext uri="{FF2B5EF4-FFF2-40B4-BE49-F238E27FC236}">
-                <a16:creationId xmlns:a16="http://schemas.microsoft.com/office/drawing/2014/main" id="{BA9BE5C1-4C0E-491C-A47B-7F752E9E49BD}"/>
+                <a16:creationId xmlns:a16="http://schemas.microsoft.com/office/drawing/2014/main" id="{FA631BB6-9EBF-4C91-A0D9-7EBB5700DC5E}"/>
               </a:ext>
             </a:extLst>
           </p:cNvPr>
@@ -4072,7 +4072,7 @@
           <p:cNvPr id="29" name="">
             <a:extLst xmlns:a="http://schemas.openxmlformats.org/drawingml/2006/main">
               <a:ext uri="{FF2B5EF4-FFF2-40B4-BE49-F238E27FC236}">
-                <a16:creationId xmlns:a16="http://schemas.microsoft.com/office/drawing/2014/main" id="{EE76EE96-C3AC-451E-B931-585305695B9F}"/>
+                <a16:creationId xmlns:a16="http://schemas.microsoft.com/office/drawing/2014/main" id="{DE3F5E0B-53A3-4F6C-A025-17D96BEDC84F}"/>
               </a:ext>
             </a:extLst>
           </p:cNvPr>
@@ -4136,7 +4136,7 @@
           <p:cNvPr id="30" name="">
             <a:extLst xmlns:a="http://schemas.openxmlformats.org/drawingml/2006/main">
               <a:ext uri="{FF2B5EF4-FFF2-40B4-BE49-F238E27FC236}">
-                <a16:creationId xmlns:a16="http://schemas.microsoft.com/office/drawing/2014/main" id="{E40C8ED6-F257-4525-9EC1-23F3A2B61E5A}"/>
+                <a16:creationId xmlns:a16="http://schemas.microsoft.com/office/drawing/2014/main" id="{670B5AA5-4DF7-4143-82AF-56A2DEC53E21}"/>
               </a:ext>
             </a:extLst>
           </p:cNvPr>
@@ -4190,7 +4190,7 @@
                 <a:ea typeface="PingFang SC"/>
                 <a:cs typeface="PingFang SC"/>
               </a:rPr>
-              <a:t>进入管理后台，依次展示用户管理、角色管理、消息管理、反馈管理、系统日志和统计页面，说明管理员与角色维护者的权限差异。</a:t>
+              <a:t>进入管理后台，依次展示用户管理、角色管理、消息管理、反馈管理、系统日志和统计页面，说明管理员负责平台治理，普通用户负责自己的会话与角色。</a:t>
             </a:r>
           </a:p>
         </p:txBody>
@@ -4200,7 +4200,7 @@
           <p:cNvPr id="31" name="">
             <a:extLst xmlns:a="http://schemas.openxmlformats.org/drawingml/2006/main">
               <a:ext uri="{FF2B5EF4-FFF2-40B4-BE49-F238E27FC236}">
-                <a16:creationId xmlns:a16="http://schemas.microsoft.com/office/drawing/2014/main" id="{29BBAD47-9765-41FC-8251-79343CA94D5E}"/>
+                <a16:creationId xmlns:a16="http://schemas.microsoft.com/office/drawing/2014/main" id="{67E42937-67C2-4C95-B4FB-A9CD395D4762}"/>
               </a:ext>
             </a:extLst>
           </p:cNvPr>
@@ -4264,7 +4264,7 @@
           <p:cNvPr id="32" name="">
             <a:extLst xmlns:a="http://schemas.openxmlformats.org/drawingml/2006/main">
               <a:ext uri="{FF2B5EF4-FFF2-40B4-BE49-F238E27FC236}">
-                <a16:creationId xmlns:a16="http://schemas.microsoft.com/office/drawing/2014/main" id="{39819A6A-B4DF-4F5F-A43F-2876B46322EA}"/>
+                <a16:creationId xmlns:a16="http://schemas.microsoft.com/office/drawing/2014/main" id="{A97E0DC1-90C0-4BFA-A031-3B927BB3D4F8}"/>
               </a:ext>
             </a:extLst>
           </p:cNvPr>
@@ -4326,7 +4326,7 @@
     </p:spTree>
     <p:extLst>
       <p:ext uri="{BB962C8B-B14F-4D97-AF65-F5344CB8AC3E}">
-        <p14:creationId xmlns:p14="http://schemas.microsoft.com/office/powerpoint/2010/main" val="764231353"/>
+        <p14:creationId xmlns:p14="http://schemas.microsoft.com/office/powerpoint/2010/main" val="579046862"/>
       </p:ext>
     </p:extLst>
   </p:cSld>
@@ -4350,7 +4350,7 @@
           <p:cNvPr id="1" name="">
             <a:extLst xmlns:a="http://schemas.openxmlformats.org/drawingml/2006/main">
               <a:ext uri="{FF2B5EF4-FFF2-40B4-BE49-F238E27FC236}">
-                <a16:creationId xmlns:a16="http://schemas.microsoft.com/office/drawing/2014/main" id="{C18C123D-A7A7-4FBA-B8B4-9D31180B1436}"/>
+                <a16:creationId xmlns:a16="http://schemas.microsoft.com/office/drawing/2014/main" id="{0B921FAA-A7EA-4DE3-9E0E-49799CB250D2}"/>
               </a:ext>
             </a:extLst>
           </p:cNvPr>
@@ -4385,7 +4385,7 @@
           <p:cNvPr id="2" name="">
             <a:extLst xmlns:a="http://schemas.openxmlformats.org/drawingml/2006/main">
               <a:ext uri="{FF2B5EF4-FFF2-40B4-BE49-F238E27FC236}">
-                <a16:creationId xmlns:a16="http://schemas.microsoft.com/office/drawing/2014/main" id="{2D633A70-3E15-47EC-A439-436C4DC0040D}"/>
+                <a16:creationId xmlns:a16="http://schemas.microsoft.com/office/drawing/2014/main" id="{F3E3BACD-6517-4AD1-8BD3-E8B1A54BDB0F}"/>
               </a:ext>
             </a:extLst>
           </p:cNvPr>
@@ -4420,7 +4420,7 @@
           <p:cNvPr id="3" name="">
             <a:extLst xmlns:a="http://schemas.openxmlformats.org/drawingml/2006/main">
               <a:ext uri="{FF2B5EF4-FFF2-40B4-BE49-F238E27FC236}">
-                <a16:creationId xmlns:a16="http://schemas.microsoft.com/office/drawing/2014/main" id="{82531B1E-BF55-4533-9CC9-D7D9C3BFE320}"/>
+                <a16:creationId xmlns:a16="http://schemas.microsoft.com/office/drawing/2014/main" id="{B279862B-72DF-4C1B-BACF-7F8C7AF3D9DF}"/>
               </a:ext>
             </a:extLst>
           </p:cNvPr>
@@ -4484,7 +4484,7 @@
           <p:cNvPr id="4" name="">
             <a:extLst xmlns:a="http://schemas.openxmlformats.org/drawingml/2006/main">
               <a:ext uri="{FF2B5EF4-FFF2-40B4-BE49-F238E27FC236}">
-                <a16:creationId xmlns:a16="http://schemas.microsoft.com/office/drawing/2014/main" id="{8D6F6329-338B-473D-BC26-7A723522E117}"/>
+                <a16:creationId xmlns:a16="http://schemas.microsoft.com/office/drawing/2014/main" id="{3E69C9B9-7C11-447A-97E1-C5FCCCA8EC63}"/>
               </a:ext>
             </a:extLst>
           </p:cNvPr>
@@ -4548,7 +4548,7 @@
           <p:cNvPr id="5" name="">
             <a:extLst xmlns:a="http://schemas.openxmlformats.org/drawingml/2006/main">
               <a:ext uri="{FF2B5EF4-FFF2-40B4-BE49-F238E27FC236}">
-                <a16:creationId xmlns:a16="http://schemas.microsoft.com/office/drawing/2014/main" id="{FD8B354C-5E0F-4F35-91B7-3D4DA01DEBC6}"/>
+                <a16:creationId xmlns:a16="http://schemas.microsoft.com/office/drawing/2014/main" id="{E8C4F9A9-3CD4-432A-824A-5E674A9DAA9B}"/>
               </a:ext>
             </a:extLst>
           </p:cNvPr>
@@ -4602,7 +4602,7 @@
                 <a:ea typeface="PingFang SC"/>
                 <a:cs typeface="PingFang SC"/>
               </a:rPr>
-              <a:t>第一阶段已经完成核心模型、前后台页面、权限边界与可运行核验。</a:t>
+              <a:t>第一阶段已经完成核心模型、前后台页面、两级权限边界与可运行核验。</a:t>
             </a:r>
           </a:p>
         </p:txBody>
@@ -4612,7 +4612,7 @@
           <p:cNvPr id="6" name="">
             <a:extLst xmlns:a="http://schemas.openxmlformats.org/drawingml/2006/main">
               <a:ext uri="{FF2B5EF4-FFF2-40B4-BE49-F238E27FC236}">
-                <a16:creationId xmlns:a16="http://schemas.microsoft.com/office/drawing/2014/main" id="{1464BB31-0042-4548-B4A1-B2C3254E7483}"/>
+                <a16:creationId xmlns:a16="http://schemas.microsoft.com/office/drawing/2014/main" id="{920826EC-0545-46A0-8161-B537A3596F8B}"/>
               </a:ext>
             </a:extLst>
           </p:cNvPr>
@@ -4645,7 +4645,7 @@
           <p:cNvPr id="7" name="">
             <a:extLst xmlns:a="http://schemas.openxmlformats.org/drawingml/2006/main">
               <a:ext uri="{FF2B5EF4-FFF2-40B4-BE49-F238E27FC236}">
-                <a16:creationId xmlns:a16="http://schemas.microsoft.com/office/drawing/2014/main" id="{4EF723C3-F02F-4DB4-A5BB-68E1D9D6C13C}"/>
+                <a16:creationId xmlns:a16="http://schemas.microsoft.com/office/drawing/2014/main" id="{E9E4D770-5A3C-49C1-9545-1672658F09DF}"/>
               </a:ext>
             </a:extLst>
           </p:cNvPr>
@@ -4680,7 +4680,7 @@
           <p:cNvPr id="8" name="">
             <a:extLst xmlns:a="http://schemas.openxmlformats.org/drawingml/2006/main">
               <a:ext uri="{FF2B5EF4-FFF2-40B4-BE49-F238E27FC236}">
-                <a16:creationId xmlns:a16="http://schemas.microsoft.com/office/drawing/2014/main" id="{65174CC8-A3BC-4630-8EC9-EF396B9D388C}"/>
+                <a16:creationId xmlns:a16="http://schemas.microsoft.com/office/drawing/2014/main" id="{C85CBC0F-89EF-45F9-B37C-2CE3374515A7}"/>
               </a:ext>
             </a:extLst>
           </p:cNvPr>
@@ -4744,7 +4744,7 @@
           <p:cNvPr id="9" name="">
             <a:extLst xmlns:a="http://schemas.openxmlformats.org/drawingml/2006/main">
               <a:ext uri="{FF2B5EF4-FFF2-40B4-BE49-F238E27FC236}">
-                <a16:creationId xmlns:a16="http://schemas.microsoft.com/office/drawing/2014/main" id="{38C312D5-061A-46E7-BEAB-4F9C3425B93C}"/>
+                <a16:creationId xmlns:a16="http://schemas.microsoft.com/office/drawing/2014/main" id="{AA16DC9F-2885-4B71-B885-B1328E00BF6B}"/>
               </a:ext>
             </a:extLst>
           </p:cNvPr>
@@ -4808,7 +4808,7 @@
           <p:cNvPr id="10" name="">
             <a:extLst xmlns:a="http://schemas.openxmlformats.org/drawingml/2006/main">
               <a:ext uri="{FF2B5EF4-FFF2-40B4-BE49-F238E27FC236}">
-                <a16:creationId xmlns:a16="http://schemas.microsoft.com/office/drawing/2014/main" id="{23618B4F-5AEC-4953-A119-C42DC0283E83}"/>
+                <a16:creationId xmlns:a16="http://schemas.microsoft.com/office/drawing/2014/main" id="{562ADD4F-C759-4020-84CD-9E256CBB313B}"/>
               </a:ext>
             </a:extLst>
           </p:cNvPr>
@@ -4841,7 +4841,7 @@
           <p:cNvPr id="11" name="">
             <a:extLst xmlns:a="http://schemas.openxmlformats.org/drawingml/2006/main">
               <a:ext uri="{FF2B5EF4-FFF2-40B4-BE49-F238E27FC236}">
-                <a16:creationId xmlns:a16="http://schemas.microsoft.com/office/drawing/2014/main" id="{FAF0B092-D191-4BAB-AEFE-D6A88CE1BEE7}"/>
+                <a16:creationId xmlns:a16="http://schemas.microsoft.com/office/drawing/2014/main" id="{280715B9-68FA-41FA-A9F5-7DC60776B4F2}"/>
               </a:ext>
             </a:extLst>
           </p:cNvPr>
@@ -4876,7 +4876,7 @@
           <p:cNvPr id="12" name="">
             <a:extLst xmlns:a="http://schemas.openxmlformats.org/drawingml/2006/main">
               <a:ext uri="{FF2B5EF4-FFF2-40B4-BE49-F238E27FC236}">
-                <a16:creationId xmlns:a16="http://schemas.microsoft.com/office/drawing/2014/main" id="{F67166D8-B876-4995-8337-08FBF8868CFB}"/>
+                <a16:creationId xmlns:a16="http://schemas.microsoft.com/office/drawing/2014/main" id="{30F16C4A-7468-4B2C-8430-1D8015DB15FC}"/>
               </a:ext>
             </a:extLst>
           </p:cNvPr>
@@ -4940,7 +4940,7 @@
           <p:cNvPr id="13" name="">
             <a:extLst xmlns:a="http://schemas.openxmlformats.org/drawingml/2006/main">
               <a:ext uri="{FF2B5EF4-FFF2-40B4-BE49-F238E27FC236}">
-                <a16:creationId xmlns:a16="http://schemas.microsoft.com/office/drawing/2014/main" id="{EBA13532-5E62-49D0-819E-E437B62AE7ED}"/>
+                <a16:creationId xmlns:a16="http://schemas.microsoft.com/office/drawing/2014/main" id="{E1E723C0-60B8-4E41-9DBA-6C6618F56E80}"/>
               </a:ext>
             </a:extLst>
           </p:cNvPr>
@@ -4994,7 +4994,7 @@
                 <a:ea typeface="PingFang SC"/>
                 <a:cs typeface="PingFang SC"/>
               </a:rPr>
-              <a:t>不是普通聊天应用，而是把 AI 回复过程作为可管理数据资产沉淀下来。</a:t>
+              <a:t>不是普通聊天应用，而是把 AI 回复过程和用户自定义角色作为可管理数据资产沉淀下来。</a:t>
             </a:r>
           </a:p>
         </p:txBody>
@@ -5004,7 +5004,7 @@
           <p:cNvPr id="14" name="">
             <a:extLst xmlns:a="http://schemas.openxmlformats.org/drawingml/2006/main">
               <a:ext uri="{FF2B5EF4-FFF2-40B4-BE49-F238E27FC236}">
-                <a16:creationId xmlns:a16="http://schemas.microsoft.com/office/drawing/2014/main" id="{0CEF5600-2197-4E8E-9792-732E54EF689B}"/>
+                <a16:creationId xmlns:a16="http://schemas.microsoft.com/office/drawing/2014/main" id="{491821C8-7D50-4E7F-BD22-55AF914A0DC4}"/>
               </a:ext>
             </a:extLst>
           </p:cNvPr>
@@ -5037,7 +5037,7 @@
           <p:cNvPr id="15" name="">
             <a:extLst xmlns:a="http://schemas.openxmlformats.org/drawingml/2006/main">
               <a:ext uri="{FF2B5EF4-FFF2-40B4-BE49-F238E27FC236}">
-                <a16:creationId xmlns:a16="http://schemas.microsoft.com/office/drawing/2014/main" id="{C0A3A289-3D3D-475B-8A5E-8C6ED204F195}"/>
+                <a16:creationId xmlns:a16="http://schemas.microsoft.com/office/drawing/2014/main" id="{C4071BAE-E7A7-4E64-9BD4-521856657A7E}"/>
               </a:ext>
             </a:extLst>
           </p:cNvPr>
@@ -5072,7 +5072,7 @@
           <p:cNvPr id="16" name="">
             <a:extLst xmlns:a="http://schemas.openxmlformats.org/drawingml/2006/main">
               <a:ext uri="{FF2B5EF4-FFF2-40B4-BE49-F238E27FC236}">
-                <a16:creationId xmlns:a16="http://schemas.microsoft.com/office/drawing/2014/main" id="{1ED7D456-44D8-4877-B504-64ED6901DAD9}"/>
+                <a16:creationId xmlns:a16="http://schemas.microsoft.com/office/drawing/2014/main" id="{19072DB4-7477-44C9-8E9D-CE9384EBCB2A}"/>
               </a:ext>
             </a:extLst>
           </p:cNvPr>
@@ -5136,7 +5136,7 @@
           <p:cNvPr id="17" name="">
             <a:extLst xmlns:a="http://schemas.openxmlformats.org/drawingml/2006/main">
               <a:ext uri="{FF2B5EF4-FFF2-40B4-BE49-F238E27FC236}">
-                <a16:creationId xmlns:a16="http://schemas.microsoft.com/office/drawing/2014/main" id="{E65D4E26-7CD0-4BEA-8D7C-7EA4B612ED7E}"/>
+                <a16:creationId xmlns:a16="http://schemas.microsoft.com/office/drawing/2014/main" id="{BDF60008-21D3-4AEC-8A77-0BF4A3CA17D4}"/>
               </a:ext>
             </a:extLst>
           </p:cNvPr>
@@ -5200,7 +5200,7 @@
           <p:cNvPr id="18" name="">
             <a:extLst xmlns:a="http://schemas.openxmlformats.org/drawingml/2006/main">
               <a:ext uri="{FF2B5EF4-FFF2-40B4-BE49-F238E27FC236}">
-                <a16:creationId xmlns:a16="http://schemas.microsoft.com/office/drawing/2014/main" id="{5883539B-C1E5-4422-AAC4-DD6BA5D6CDB8}"/>
+                <a16:creationId xmlns:a16="http://schemas.microsoft.com/office/drawing/2014/main" id="{72FE16F9-1C4F-493A-A728-E17928BAE5D2}"/>
               </a:ext>
             </a:extLst>
           </p:cNvPr>
@@ -5264,7 +5264,7 @@
           <p:cNvPr id="19" name="">
             <a:extLst xmlns:a="http://schemas.openxmlformats.org/drawingml/2006/main">
               <a:ext uri="{FF2B5EF4-FFF2-40B4-BE49-F238E27FC236}">
-                <a16:creationId xmlns:a16="http://schemas.microsoft.com/office/drawing/2014/main" id="{B6F9BD91-F626-43E9-A9B0-049CA7787A3A}"/>
+                <a16:creationId xmlns:a16="http://schemas.microsoft.com/office/drawing/2014/main" id="{31404E5B-650E-4229-88C8-FDB14D2F7EAE}"/>
               </a:ext>
             </a:extLst>
           </p:cNvPr>
@@ -5326,7 +5326,7 @@
     </p:spTree>
     <p:extLst>
       <p:ext uri="{BB962C8B-B14F-4D97-AF65-F5344CB8AC3E}">
-        <p14:creationId xmlns:p14="http://schemas.microsoft.com/office/powerpoint/2010/main" val="405886876"/>
+        <p14:creationId xmlns:p14="http://schemas.microsoft.com/office/powerpoint/2010/main" val="779815871"/>
       </p:ext>
     </p:extLst>
   </p:cSld>
@@ -5350,7 +5350,7 @@
           <p:cNvPr id="1" name="">
             <a:extLst xmlns:a="http://schemas.openxmlformats.org/drawingml/2006/main">
               <a:ext uri="{FF2B5EF4-FFF2-40B4-BE49-F238E27FC236}">
-                <a16:creationId xmlns:a16="http://schemas.microsoft.com/office/drawing/2014/main" id="{D2EC6B5C-0591-4A81-BF74-354B661B8A7B}"/>
+                <a16:creationId xmlns:a16="http://schemas.microsoft.com/office/drawing/2014/main" id="{5F39AE71-3792-49E7-8859-FFC4D676BC0A}"/>
               </a:ext>
             </a:extLst>
           </p:cNvPr>
@@ -5385,7 +5385,7 @@
           <p:cNvPr id="2" name="">
             <a:extLst xmlns:a="http://schemas.openxmlformats.org/drawingml/2006/main">
               <a:ext uri="{FF2B5EF4-FFF2-40B4-BE49-F238E27FC236}">
-                <a16:creationId xmlns:a16="http://schemas.microsoft.com/office/drawing/2014/main" id="{C014A5D4-115D-434B-BA6D-92B2973B600D}"/>
+                <a16:creationId xmlns:a16="http://schemas.microsoft.com/office/drawing/2014/main" id="{CC644778-8106-44B8-B177-96745898C95F}"/>
               </a:ext>
             </a:extLst>
           </p:cNvPr>
@@ -5420,7 +5420,7 @@
           <p:cNvPr id="3" name="">
             <a:extLst xmlns:a="http://schemas.openxmlformats.org/drawingml/2006/main">
               <a:ext uri="{FF2B5EF4-FFF2-40B4-BE49-F238E27FC236}">
-                <a16:creationId xmlns:a16="http://schemas.microsoft.com/office/drawing/2014/main" id="{203865B9-E12B-4826-AF18-F0B65E17D810}"/>
+                <a16:creationId xmlns:a16="http://schemas.microsoft.com/office/drawing/2014/main" id="{9DBDA6C1-C8E8-4F03-848C-468B1FB54179}"/>
               </a:ext>
             </a:extLst>
           </p:cNvPr>
@@ -5455,7 +5455,7 @@
           <p:cNvPr id="4" name="">
             <a:extLst xmlns:a="http://schemas.openxmlformats.org/drawingml/2006/main">
               <a:ext uri="{FF2B5EF4-FFF2-40B4-BE49-F238E27FC236}">
-                <a16:creationId xmlns:a16="http://schemas.microsoft.com/office/drawing/2014/main" id="{3F28FF69-B46B-4D78-90B1-48D5E5FEF1BD}"/>
+                <a16:creationId xmlns:a16="http://schemas.microsoft.com/office/drawing/2014/main" id="{A70C19DA-021A-411A-AFA1-1FE8AFAF73A5}"/>
               </a:ext>
             </a:extLst>
           </p:cNvPr>
@@ -5519,7 +5519,7 @@
           <p:cNvPr id="5" name="">
             <a:extLst xmlns:a="http://schemas.openxmlformats.org/drawingml/2006/main">
               <a:ext uri="{FF2B5EF4-FFF2-40B4-BE49-F238E27FC236}">
-                <a16:creationId xmlns:a16="http://schemas.microsoft.com/office/drawing/2014/main" id="{042FB15E-6059-43C8-AEEE-912D2982310B}"/>
+                <a16:creationId xmlns:a16="http://schemas.microsoft.com/office/drawing/2014/main" id="{EEF1B856-BAAA-4072-82BC-CCF443C2457A}"/>
               </a:ext>
             </a:extLst>
           </p:cNvPr>
@@ -5583,7 +5583,7 @@
           <p:cNvPr id="6" name="">
             <a:extLst xmlns:a="http://schemas.openxmlformats.org/drawingml/2006/main">
               <a:ext uri="{FF2B5EF4-FFF2-40B4-BE49-F238E27FC236}">
-                <a16:creationId xmlns:a16="http://schemas.microsoft.com/office/drawing/2014/main" id="{D7E5E97C-2829-42F1-B2FE-83D1C35A366C}"/>
+                <a16:creationId xmlns:a16="http://schemas.microsoft.com/office/drawing/2014/main" id="{B182C6EE-E559-4AB7-BBD0-2634FCF5EE71}"/>
               </a:ext>
             </a:extLst>
           </p:cNvPr>
@@ -5616,7 +5616,7 @@
           <p:cNvPr id="7" name="">
             <a:extLst xmlns:a="http://schemas.openxmlformats.org/drawingml/2006/main">
               <a:ext uri="{FF2B5EF4-FFF2-40B4-BE49-F238E27FC236}">
-                <a16:creationId xmlns:a16="http://schemas.microsoft.com/office/drawing/2014/main" id="{CC4F5BDA-A22F-42E2-A083-B8C99D31D83D}"/>
+                <a16:creationId xmlns:a16="http://schemas.microsoft.com/office/drawing/2014/main" id="{8128F20F-A167-46EF-AFF9-3BB595F5E26D}"/>
               </a:ext>
             </a:extLst>
           </p:cNvPr>
@@ -5651,7 +5651,7 @@
           <p:cNvPr id="8" name="">
             <a:extLst xmlns:a="http://schemas.openxmlformats.org/drawingml/2006/main">
               <a:ext uri="{FF2B5EF4-FFF2-40B4-BE49-F238E27FC236}">
-                <a16:creationId xmlns:a16="http://schemas.microsoft.com/office/drawing/2014/main" id="{3CD35B85-495F-45AF-B562-E43390767044}"/>
+                <a16:creationId xmlns:a16="http://schemas.microsoft.com/office/drawing/2014/main" id="{EBEE9171-7313-4CB6-8064-AFFFBFB88927}"/>
               </a:ext>
             </a:extLst>
           </p:cNvPr>
@@ -5715,7 +5715,7 @@
           <p:cNvPr id="9" name="">
             <a:extLst xmlns:a="http://schemas.openxmlformats.org/drawingml/2006/main">
               <a:ext uri="{FF2B5EF4-FFF2-40B4-BE49-F238E27FC236}">
-                <a16:creationId xmlns:a16="http://schemas.microsoft.com/office/drawing/2014/main" id="{314D1A52-6900-49B6-B5FF-CE7404D02D0A}"/>
+                <a16:creationId xmlns:a16="http://schemas.microsoft.com/office/drawing/2014/main" id="{287DB699-D38A-4008-BA91-F2AEC1ED409F}"/>
               </a:ext>
             </a:extLst>
           </p:cNvPr>
@@ -5779,7 +5779,7 @@
           <p:cNvPr id="10" name="">
             <a:extLst xmlns:a="http://schemas.openxmlformats.org/drawingml/2006/main">
               <a:ext uri="{FF2B5EF4-FFF2-40B4-BE49-F238E27FC236}">
-                <a16:creationId xmlns:a16="http://schemas.microsoft.com/office/drawing/2014/main" id="{2B221FB1-B253-476D-BF5E-7B0739AE0882}"/>
+                <a16:creationId xmlns:a16="http://schemas.microsoft.com/office/drawing/2014/main" id="{97C264AA-A853-47B2-9F2C-1D55A8FBD21B}"/>
               </a:ext>
             </a:extLst>
           </p:cNvPr>
@@ -5812,7 +5812,7 @@
           <p:cNvPr id="11" name="">
             <a:extLst xmlns:a="http://schemas.openxmlformats.org/drawingml/2006/main">
               <a:ext uri="{FF2B5EF4-FFF2-40B4-BE49-F238E27FC236}">
-                <a16:creationId xmlns:a16="http://schemas.microsoft.com/office/drawing/2014/main" id="{A276DDD6-7F2B-4529-A6A4-0D95167BA1DF}"/>
+                <a16:creationId xmlns:a16="http://schemas.microsoft.com/office/drawing/2014/main" id="{089694E8-DAB7-4769-A7E3-66A80E989BDF}"/>
               </a:ext>
             </a:extLst>
           </p:cNvPr>
@@ -5847,7 +5847,7 @@
           <p:cNvPr id="12" name="">
             <a:extLst xmlns:a="http://schemas.openxmlformats.org/drawingml/2006/main">
               <a:ext uri="{FF2B5EF4-FFF2-40B4-BE49-F238E27FC236}">
-                <a16:creationId xmlns:a16="http://schemas.microsoft.com/office/drawing/2014/main" id="{E945DB31-626E-4F49-9448-122E41405E0A}"/>
+                <a16:creationId xmlns:a16="http://schemas.microsoft.com/office/drawing/2014/main" id="{AC7D8F79-9DAF-4071-8190-0010873EA4AB}"/>
               </a:ext>
             </a:extLst>
           </p:cNvPr>
@@ -5911,7 +5911,7 @@
           <p:cNvPr id="13" name="">
             <a:extLst xmlns:a="http://schemas.openxmlformats.org/drawingml/2006/main">
               <a:ext uri="{FF2B5EF4-FFF2-40B4-BE49-F238E27FC236}">
-                <a16:creationId xmlns:a16="http://schemas.microsoft.com/office/drawing/2014/main" id="{35583136-96AA-45A9-8EDC-85E10697B865}"/>
+                <a16:creationId xmlns:a16="http://schemas.microsoft.com/office/drawing/2014/main" id="{5D102662-2516-45D5-9087-4DC0BD60DCB1}"/>
               </a:ext>
             </a:extLst>
           </p:cNvPr>
@@ -5975,7 +5975,7 @@
           <p:cNvPr id="14" name="">
             <a:extLst xmlns:a="http://schemas.openxmlformats.org/drawingml/2006/main">
               <a:ext uri="{FF2B5EF4-FFF2-40B4-BE49-F238E27FC236}">
-                <a16:creationId xmlns:a16="http://schemas.microsoft.com/office/drawing/2014/main" id="{37BC138A-B590-4466-9110-A534C4138F58}"/>
+                <a16:creationId xmlns:a16="http://schemas.microsoft.com/office/drawing/2014/main" id="{6D491CD0-F161-4FF1-8216-501381C39643}"/>
               </a:ext>
             </a:extLst>
           </p:cNvPr>
@@ -6008,7 +6008,7 @@
           <p:cNvPr id="15" name="">
             <a:extLst xmlns:a="http://schemas.openxmlformats.org/drawingml/2006/main">
               <a:ext uri="{FF2B5EF4-FFF2-40B4-BE49-F238E27FC236}">
-                <a16:creationId xmlns:a16="http://schemas.microsoft.com/office/drawing/2014/main" id="{5BAFBCD4-F36A-4989-9455-DB62B94546A4}"/>
+                <a16:creationId xmlns:a16="http://schemas.microsoft.com/office/drawing/2014/main" id="{59DA9CB4-989A-434F-86D0-3FD8E6920784}"/>
               </a:ext>
             </a:extLst>
           </p:cNvPr>
@@ -6043,7 +6043,7 @@
           <p:cNvPr id="16" name="">
             <a:extLst xmlns:a="http://schemas.openxmlformats.org/drawingml/2006/main">
               <a:ext uri="{FF2B5EF4-FFF2-40B4-BE49-F238E27FC236}">
-                <a16:creationId xmlns:a16="http://schemas.microsoft.com/office/drawing/2014/main" id="{0572CC2A-2F20-4E85-80C7-1BFA6BCF9A2F}"/>
+                <a16:creationId xmlns:a16="http://schemas.microsoft.com/office/drawing/2014/main" id="{DF0FCC1B-7085-4C85-A010-F85910C238FC}"/>
               </a:ext>
             </a:extLst>
           </p:cNvPr>
@@ -6107,7 +6107,7 @@
           <p:cNvPr id="17" name="">
             <a:extLst xmlns:a="http://schemas.openxmlformats.org/drawingml/2006/main">
               <a:ext uri="{FF2B5EF4-FFF2-40B4-BE49-F238E27FC236}">
-                <a16:creationId xmlns:a16="http://schemas.microsoft.com/office/drawing/2014/main" id="{71D6D86A-32BA-4FBB-B1C1-03360848DDD1}"/>
+                <a16:creationId xmlns:a16="http://schemas.microsoft.com/office/drawing/2014/main" id="{3345BAB0-DB4B-45B2-988B-D1C6ACCD4B97}"/>
               </a:ext>
             </a:extLst>
           </p:cNvPr>
@@ -6161,7 +6161,7 @@
                 <a:ea typeface="PingFang SC"/>
                 <a:cs typeface="PingFang SC"/>
               </a:rPr>
-              <a:t>管理员可以查看用户、角色、消息、反馈和日志；角色维护者专注维护 AI 角色，不碰系统级权限。</a:t>
+              <a:t>普通用户管理自己的 AI 角色与会话；管理员负责用户、角色状态、消息、反馈、日志和统计治理。</a:t>
             </a:r>
           </a:p>
         </p:txBody>
@@ -6171,7 +6171,7 @@
           <p:cNvPr id="18" name="">
             <a:extLst xmlns:a="http://schemas.openxmlformats.org/drawingml/2006/main">
               <a:ext uri="{FF2B5EF4-FFF2-40B4-BE49-F238E27FC236}">
-                <a16:creationId xmlns:a16="http://schemas.microsoft.com/office/drawing/2014/main" id="{8CE28279-8196-4EC7-84CE-3A737F34316A}"/>
+                <a16:creationId xmlns:a16="http://schemas.microsoft.com/office/drawing/2014/main" id="{76937030-B9CD-4C12-8CBA-BDA4B6B08BB5}"/>
               </a:ext>
             </a:extLst>
           </p:cNvPr>
@@ -6206,7 +6206,7 @@
           <p:cNvPr id="19" name="">
             <a:extLst xmlns:a="http://schemas.openxmlformats.org/drawingml/2006/main">
               <a:ext uri="{FF2B5EF4-FFF2-40B4-BE49-F238E27FC236}">
-                <a16:creationId xmlns:a16="http://schemas.microsoft.com/office/drawing/2014/main" id="{4C27A332-8104-47BD-98A4-B9A634356964}"/>
+                <a16:creationId xmlns:a16="http://schemas.microsoft.com/office/drawing/2014/main" id="{29AC6414-A630-4A2F-B793-979D5EC8DED4}"/>
               </a:ext>
             </a:extLst>
           </p:cNvPr>
@@ -6270,7 +6270,7 @@
           <p:cNvPr id="20" name="">
             <a:extLst xmlns:a="http://schemas.openxmlformats.org/drawingml/2006/main">
               <a:ext uri="{FF2B5EF4-FFF2-40B4-BE49-F238E27FC236}">
-                <a16:creationId xmlns:a16="http://schemas.microsoft.com/office/drawing/2014/main" id="{785A663D-EAED-48AF-A797-434276BF2E29}"/>
+                <a16:creationId xmlns:a16="http://schemas.microsoft.com/office/drawing/2014/main" id="{7FF86D3A-1035-49AA-A763-DD7792E1F5EF}"/>
               </a:ext>
             </a:extLst>
           </p:cNvPr>
@@ -6305,7 +6305,7 @@
           <p:cNvPr id="21" name="">
             <a:extLst xmlns:a="http://schemas.openxmlformats.org/drawingml/2006/main">
               <a:ext uri="{FF2B5EF4-FFF2-40B4-BE49-F238E27FC236}">
-                <a16:creationId xmlns:a16="http://schemas.microsoft.com/office/drawing/2014/main" id="{35412E94-6959-46C7-AE27-740E045439D4}"/>
+                <a16:creationId xmlns:a16="http://schemas.microsoft.com/office/drawing/2014/main" id="{EF0418F3-98E3-409A-8EBE-1CCE95678A38}"/>
               </a:ext>
             </a:extLst>
           </p:cNvPr>
@@ -6369,7 +6369,7 @@
           <p:cNvPr id="22" name="">
             <a:extLst xmlns:a="http://schemas.openxmlformats.org/drawingml/2006/main">
               <a:ext uri="{FF2B5EF4-FFF2-40B4-BE49-F238E27FC236}">
-                <a16:creationId xmlns:a16="http://schemas.microsoft.com/office/drawing/2014/main" id="{9048EC70-9FEB-48FC-BCE8-989402C81CC6}"/>
+                <a16:creationId xmlns:a16="http://schemas.microsoft.com/office/drawing/2014/main" id="{8562B695-B758-44EE-BE2A-7D273387D804}"/>
               </a:ext>
             </a:extLst>
           </p:cNvPr>
@@ -6404,7 +6404,7 @@
           <p:cNvPr id="23" name="">
             <a:extLst xmlns:a="http://schemas.openxmlformats.org/drawingml/2006/main">
               <a:ext uri="{FF2B5EF4-FFF2-40B4-BE49-F238E27FC236}">
-                <a16:creationId xmlns:a16="http://schemas.microsoft.com/office/drawing/2014/main" id="{2DE5ADCC-C1F5-4D16-A6F0-70865FD37C9D}"/>
+                <a16:creationId xmlns:a16="http://schemas.microsoft.com/office/drawing/2014/main" id="{1B5B2B9A-3943-4018-A39B-D7273E1FBBBF}"/>
               </a:ext>
             </a:extLst>
           </p:cNvPr>
@@ -6468,7 +6468,7 @@
           <p:cNvPr id="24" name="">
             <a:extLst xmlns:a="http://schemas.openxmlformats.org/drawingml/2006/main">
               <a:ext uri="{FF2B5EF4-FFF2-40B4-BE49-F238E27FC236}">
-                <a16:creationId xmlns:a16="http://schemas.microsoft.com/office/drawing/2014/main" id="{040D67BA-706E-45CD-82DB-3BCE1B57DA49}"/>
+                <a16:creationId xmlns:a16="http://schemas.microsoft.com/office/drawing/2014/main" id="{8C61356A-D5F5-4F0A-B8E5-63B56F79A09B}"/>
               </a:ext>
             </a:extLst>
           </p:cNvPr>
@@ -6532,7 +6532,7 @@
           <p:cNvPr id="25" name="">
             <a:extLst xmlns:a="http://schemas.openxmlformats.org/drawingml/2006/main">
               <a:ext uri="{FF2B5EF4-FFF2-40B4-BE49-F238E27FC236}">
-                <a16:creationId xmlns:a16="http://schemas.microsoft.com/office/drawing/2014/main" id="{1873EABD-C2D7-4A52-8952-AEA7B883C9FA}"/>
+                <a16:creationId xmlns:a16="http://schemas.microsoft.com/office/drawing/2014/main" id="{2296B03F-919C-4357-A115-5C4852A26364}"/>
               </a:ext>
             </a:extLst>
           </p:cNvPr>
@@ -6594,7 +6594,7 @@
     </p:spTree>
     <p:extLst>
       <p:ext uri="{BB962C8B-B14F-4D97-AF65-F5344CB8AC3E}">
-        <p14:creationId xmlns:p14="http://schemas.microsoft.com/office/powerpoint/2010/main" val="1539384122"/>
+        <p14:creationId xmlns:p14="http://schemas.microsoft.com/office/powerpoint/2010/main" val="1390460914"/>
       </p:ext>
     </p:extLst>
   </p:cSld>
@@ -6618,7 +6618,7 @@
           <p:cNvPr id="1" name="">
             <a:extLst xmlns:a="http://schemas.openxmlformats.org/drawingml/2006/main">
               <a:ext uri="{FF2B5EF4-FFF2-40B4-BE49-F238E27FC236}">
-                <a16:creationId xmlns:a16="http://schemas.microsoft.com/office/drawing/2014/main" id="{466E71D6-5665-4697-A8B5-63E9EC1A08E3}"/>
+                <a16:creationId xmlns:a16="http://schemas.microsoft.com/office/drawing/2014/main" id="{E0BE822A-38E1-403B-9299-26BB1C030891}"/>
               </a:ext>
             </a:extLst>
           </p:cNvPr>
@@ -6653,7 +6653,7 @@
           <p:cNvPr id="2" name="">
             <a:extLst xmlns:a="http://schemas.openxmlformats.org/drawingml/2006/main">
               <a:ext uri="{FF2B5EF4-FFF2-40B4-BE49-F238E27FC236}">
-                <a16:creationId xmlns:a16="http://schemas.microsoft.com/office/drawing/2014/main" id="{FB6F83DA-D1B9-47E7-AFDF-8B956BC492F6}"/>
+                <a16:creationId xmlns:a16="http://schemas.microsoft.com/office/drawing/2014/main" id="{88E92CC2-6BE3-4B4B-AA88-5EC9BE29C689}"/>
               </a:ext>
             </a:extLst>
           </p:cNvPr>
@@ -6688,7 +6688,7 @@
           <p:cNvPr id="3" name="">
             <a:extLst xmlns:a="http://schemas.openxmlformats.org/drawingml/2006/main">
               <a:ext uri="{FF2B5EF4-FFF2-40B4-BE49-F238E27FC236}">
-                <a16:creationId xmlns:a16="http://schemas.microsoft.com/office/drawing/2014/main" id="{EBCA1F39-81B8-4F90-A3DE-F02E49FC14FE}"/>
+                <a16:creationId xmlns:a16="http://schemas.microsoft.com/office/drawing/2014/main" id="{2F5FD5AD-EFF9-4466-BD95-2AAE71E90A65}"/>
               </a:ext>
             </a:extLst>
           </p:cNvPr>
@@ -6723,7 +6723,7 @@
           <p:cNvPr id="4" name="">
             <a:extLst xmlns:a="http://schemas.openxmlformats.org/drawingml/2006/main">
               <a:ext uri="{FF2B5EF4-FFF2-40B4-BE49-F238E27FC236}">
-                <a16:creationId xmlns:a16="http://schemas.microsoft.com/office/drawing/2014/main" id="{3C7CF318-4066-44B7-BABB-7D905FEADAC1}"/>
+                <a16:creationId xmlns:a16="http://schemas.microsoft.com/office/drawing/2014/main" id="{B2C6F764-C39B-4C59-8B82-04BDC361059D}"/>
               </a:ext>
             </a:extLst>
           </p:cNvPr>
@@ -6787,7 +6787,7 @@
           <p:cNvPr id="5" name="">
             <a:extLst xmlns:a="http://schemas.openxmlformats.org/drawingml/2006/main">
               <a:ext uri="{FF2B5EF4-FFF2-40B4-BE49-F238E27FC236}">
-                <a16:creationId xmlns:a16="http://schemas.microsoft.com/office/drawing/2014/main" id="{6BDEA267-0207-477C-B235-51F06B749D1C}"/>
+                <a16:creationId xmlns:a16="http://schemas.microsoft.com/office/drawing/2014/main" id="{9A04C9AB-988C-459D-9A07-6290D7BC94ED}"/>
               </a:ext>
             </a:extLst>
           </p:cNvPr>
@@ -6841,7 +6841,7 @@
                 <a:ea typeface="PingFang SC"/>
                 <a:cs typeface="PingFang SC"/>
               </a:rPr>
-              <a:t>三类角色与权限边界</a:t>
+              <a:t>两类用户角色与权限边界</a:t>
             </a:r>
           </a:p>
         </p:txBody>
@@ -6851,19 +6851,19 @@
           <p:cNvPr id="6" name="">
             <a:extLst xmlns:a="http://schemas.openxmlformats.org/drawingml/2006/main">
               <a:ext uri="{FF2B5EF4-FFF2-40B4-BE49-F238E27FC236}">
-                <a16:creationId xmlns:a16="http://schemas.microsoft.com/office/drawing/2014/main" id="{C0AA7679-1DB9-4F62-BB90-C57F812F2FB5}"/>
-              </a:ext>
-            </a:extLst>
-          </p:cNvPr>
-          <p:cNvSpPr>
-            <a:spLocks xmlns:a="http://schemas.openxmlformats.org/drawingml/2006/main" noGrp="1"/>
-          </p:cNvSpPr>
-          <p:nvPr/>
-        </p:nvSpPr>
-        <p:spPr>
-          <a:xfrm xmlns:a="http://schemas.openxmlformats.org/drawingml/2006/main">
-            <a:off x="904875" y="2047875"/>
-            <a:ext cx="2714625" cy="1619250"/>
+                <a16:creationId xmlns:a16="http://schemas.microsoft.com/office/drawing/2014/main" id="{CC8213A5-8ED6-4A1A-833E-BA8D6F03DD14}"/>
+              </a:ext>
+            </a:extLst>
+          </p:cNvPr>
+          <p:cNvSpPr>
+            <a:spLocks xmlns:a="http://schemas.openxmlformats.org/drawingml/2006/main" noGrp="1"/>
+          </p:cNvSpPr>
+          <p:nvPr/>
+        </p:nvSpPr>
+        <p:spPr>
+          <a:xfrm xmlns:a="http://schemas.openxmlformats.org/drawingml/2006/main">
+            <a:off x="1619250" y="2095500"/>
+            <a:ext cx="3048000" cy="2000250"/>
           </a:xfrm>
           <a:prstGeom xmlns:a="http://schemas.openxmlformats.org/drawingml/2006/main" prst="rect">
             <a:avLst/>
@@ -6884,19 +6884,19 @@
           <p:cNvPr id="7" name="">
             <a:extLst xmlns:a="http://schemas.openxmlformats.org/drawingml/2006/main">
               <a:ext uri="{FF2B5EF4-FFF2-40B4-BE49-F238E27FC236}">
-                <a16:creationId xmlns:a16="http://schemas.microsoft.com/office/drawing/2014/main" id="{63C0924E-7114-42EC-A397-D9260712A00E}"/>
-              </a:ext>
-            </a:extLst>
-          </p:cNvPr>
-          <p:cNvSpPr>
-            <a:spLocks xmlns:a="http://schemas.openxmlformats.org/drawingml/2006/main" noGrp="1"/>
-          </p:cNvSpPr>
-          <p:nvPr/>
-        </p:nvSpPr>
-        <p:spPr>
-          <a:xfrm xmlns:a="http://schemas.openxmlformats.org/drawingml/2006/main">
-            <a:off x="904875" y="2047875"/>
-            <a:ext cx="2714625" cy="66675"/>
+                <a16:creationId xmlns:a16="http://schemas.microsoft.com/office/drawing/2014/main" id="{76EE3AE4-66B2-4EEE-B8B4-2DF2FAB3A8D3}"/>
+              </a:ext>
+            </a:extLst>
+          </p:cNvPr>
+          <p:cNvSpPr>
+            <a:spLocks xmlns:a="http://schemas.openxmlformats.org/drawingml/2006/main" noGrp="1"/>
+          </p:cNvSpPr>
+          <p:nvPr/>
+        </p:nvSpPr>
+        <p:spPr>
+          <a:xfrm xmlns:a="http://schemas.openxmlformats.org/drawingml/2006/main">
+            <a:off x="1619250" y="2095500"/>
+            <a:ext cx="3048000" cy="66675"/>
           </a:xfrm>
           <a:prstGeom xmlns:a="http://schemas.openxmlformats.org/drawingml/2006/main" prst="rect">
             <a:avLst/>
@@ -6919,19 +6919,19 @@
           <p:cNvPr id="8" name="">
             <a:extLst xmlns:a="http://schemas.openxmlformats.org/drawingml/2006/main">
               <a:ext uri="{FF2B5EF4-FFF2-40B4-BE49-F238E27FC236}">
-                <a16:creationId xmlns:a16="http://schemas.microsoft.com/office/drawing/2014/main" id="{0FF77697-88C6-404B-B3D5-78A18D6A0064}"/>
-              </a:ext>
-            </a:extLst>
-          </p:cNvPr>
-          <p:cNvSpPr>
-            <a:spLocks xmlns:a="http://schemas.openxmlformats.org/drawingml/2006/main" noGrp="1"/>
-          </p:cNvSpPr>
-          <p:nvPr/>
-        </p:nvSpPr>
-        <p:spPr>
-          <a:xfrm xmlns:a="http://schemas.openxmlformats.org/drawingml/2006/main">
-            <a:off x="1038225" y="2257425"/>
-            <a:ext cx="2447925" cy="266700"/>
+                <a16:creationId xmlns:a16="http://schemas.microsoft.com/office/drawing/2014/main" id="{A0AACEDF-293E-4739-A01F-108208FC6A4F}"/>
+              </a:ext>
+            </a:extLst>
+          </p:cNvPr>
+          <p:cNvSpPr>
+            <a:spLocks xmlns:a="http://schemas.openxmlformats.org/drawingml/2006/main" noGrp="1"/>
+          </p:cNvSpPr>
+          <p:nvPr/>
+        </p:nvSpPr>
+        <p:spPr>
+          <a:xfrm xmlns:a="http://schemas.openxmlformats.org/drawingml/2006/main">
+            <a:off x="1752600" y="2305050"/>
+            <a:ext cx="2781300" cy="266700"/>
           </a:xfrm>
           <a:prstGeom xmlns:a="http://schemas.openxmlformats.org/drawingml/2006/main" prst="rect">
             <a:avLst/>
@@ -6983,19 +6983,19 @@
           <p:cNvPr id="9" name="">
             <a:extLst xmlns:a="http://schemas.openxmlformats.org/drawingml/2006/main">
               <a:ext uri="{FF2B5EF4-FFF2-40B4-BE49-F238E27FC236}">
-                <a16:creationId xmlns:a16="http://schemas.microsoft.com/office/drawing/2014/main" id="{F76AFCF1-C345-40B2-8F19-C47BA6720A78}"/>
-              </a:ext>
-            </a:extLst>
-          </p:cNvPr>
-          <p:cNvSpPr>
-            <a:spLocks xmlns:a="http://schemas.openxmlformats.org/drawingml/2006/main" noGrp="1"/>
-          </p:cNvSpPr>
-          <p:nvPr/>
-        </p:nvSpPr>
-        <p:spPr>
-          <a:xfrm xmlns:a="http://schemas.openxmlformats.org/drawingml/2006/main">
-            <a:off x="1076325" y="2600325"/>
-            <a:ext cx="2371725" cy="990600"/>
+                <a16:creationId xmlns:a16="http://schemas.microsoft.com/office/drawing/2014/main" id="{071F6167-333E-4224-8593-0273A3A89857}"/>
+              </a:ext>
+            </a:extLst>
+          </p:cNvPr>
+          <p:cNvSpPr>
+            <a:spLocks xmlns:a="http://schemas.openxmlformats.org/drawingml/2006/main" noGrp="1"/>
+          </p:cNvSpPr>
+          <p:nvPr/>
+        </p:nvSpPr>
+        <p:spPr>
+          <a:xfrm xmlns:a="http://schemas.openxmlformats.org/drawingml/2006/main">
+            <a:off x="1790700" y="2647950"/>
+            <a:ext cx="2705100" cy="1371600"/>
           </a:xfrm>
           <a:prstGeom xmlns:a="http://schemas.openxmlformats.org/drawingml/2006/main" prst="rect">
             <a:avLst/>
@@ -7037,9 +7037,101 @@
                 <a:ea typeface="PingFang SC"/>
                 <a:cs typeface="PingFang SC"/>
               </a:rPr>
-              <a:t>发起会话、查看消息过程、收藏消息、提交反馈</a:t>
+              <a:t>聊天会话</a:t>
             </a:r>
           </a:p>
+          <a:p xmlns:a="http://schemas.openxmlformats.org/drawingml/2006/main">
+            <a:pPr algn="ctr">
+              <a:defRPr sz="975" b="0">
+                <a:solidFill>
+                  <a:srgbClr val="64748B"/>
+                </a:solidFill>
+                <a:latin typeface="PingFang SC"/>
+                <a:ea typeface="PingFang SC"/>
+                <a:cs typeface="PingFang SC"/>
+              </a:defRPr>
+            </a:pPr>
+            <a:r>
+              <a:rPr sz="975" b="0">
+                <a:solidFill>
+                  <a:srgbClr val="64748B"/>
+                </a:solidFill>
+                <a:latin typeface="PingFang SC"/>
+                <a:ea typeface="PingFang SC"/>
+                <a:cs typeface="PingFang SC"/>
+              </a:rPr>
+              <a:t>自定义 AI 角色</a:t>
+            </a:r>
+          </a:p>
+          <a:p xmlns:a="http://schemas.openxmlformats.org/drawingml/2006/main">
+            <a:pPr algn="ctr">
+              <a:defRPr sz="975" b="0">
+                <a:solidFill>
+                  <a:srgbClr val="64748B"/>
+                </a:solidFill>
+                <a:latin typeface="PingFang SC"/>
+                <a:ea typeface="PingFang SC"/>
+                <a:cs typeface="PingFang SC"/>
+              </a:defRPr>
+            </a:pPr>
+            <a:r>
+              <a:rPr sz="975" b="0">
+                <a:solidFill>
+                  <a:srgbClr val="64748B"/>
+                </a:solidFill>
+                <a:latin typeface="PingFang SC"/>
+                <a:ea typeface="PingFang SC"/>
+                <a:cs typeface="PingFang SC"/>
+              </a:rPr>
+              <a:t>收藏消息</a:t>
+            </a:r>
+          </a:p>
+          <a:p xmlns:a="http://schemas.openxmlformats.org/drawingml/2006/main">
+            <a:pPr algn="ctr">
+              <a:defRPr sz="975" b="0">
+                <a:solidFill>
+                  <a:srgbClr val="64748B"/>
+                </a:solidFill>
+                <a:latin typeface="PingFang SC"/>
+                <a:ea typeface="PingFang SC"/>
+                <a:cs typeface="PingFang SC"/>
+              </a:defRPr>
+            </a:pPr>
+            <a:r>
+              <a:rPr sz="975" b="0">
+                <a:solidFill>
+                  <a:srgbClr val="64748B"/>
+                </a:solidFill>
+                <a:latin typeface="PingFang SC"/>
+                <a:ea typeface="PingFang SC"/>
+                <a:cs typeface="PingFang SC"/>
+              </a:rPr>
+              <a:t>提交反馈</a:t>
+            </a:r>
+          </a:p>
+          <a:p xmlns:a="http://schemas.openxmlformats.org/drawingml/2006/main">
+            <a:pPr algn="ctr">
+              <a:defRPr sz="975" b="0">
+                <a:solidFill>
+                  <a:srgbClr val="64748B"/>
+                </a:solidFill>
+                <a:latin typeface="PingFang SC"/>
+                <a:ea typeface="PingFang SC"/>
+                <a:cs typeface="PingFang SC"/>
+              </a:defRPr>
+            </a:pPr>
+            <a:r>
+              <a:rPr sz="975" b="0">
+                <a:solidFill>
+                  <a:srgbClr val="64748B"/>
+                </a:solidFill>
+                <a:latin typeface="PingFang SC"/>
+                <a:ea typeface="PingFang SC"/>
+                <a:cs typeface="PingFang SC"/>
+              </a:rPr>
+              <a:t>查看个人统计</a:t>
+            </a:r>
+          </a:p>
         </p:txBody>
       </p:sp>
       <p:sp>
@@ -7047,19 +7139,19 @@
           <p:cNvPr id="10" name="">
             <a:extLst xmlns:a="http://schemas.openxmlformats.org/drawingml/2006/main">
               <a:ext uri="{FF2B5EF4-FFF2-40B4-BE49-F238E27FC236}">
-                <a16:creationId xmlns:a16="http://schemas.microsoft.com/office/drawing/2014/main" id="{ABBD3EEF-B638-4214-9174-FE3ED0BE00F8}"/>
-              </a:ext>
-            </a:extLst>
-          </p:cNvPr>
-          <p:cNvSpPr>
-            <a:spLocks xmlns:a="http://schemas.openxmlformats.org/drawingml/2006/main" noGrp="1"/>
-          </p:cNvSpPr>
-          <p:nvPr/>
-        </p:nvSpPr>
-        <p:spPr>
-          <a:xfrm xmlns:a="http://schemas.openxmlformats.org/drawingml/2006/main">
-            <a:off x="3810000" y="2838450"/>
-            <a:ext cx="904875" cy="28575"/>
+                <a16:creationId xmlns:a16="http://schemas.microsoft.com/office/drawing/2014/main" id="{002582B9-219A-4027-86A9-B0E9BA9D2BCA}"/>
+              </a:ext>
+            </a:extLst>
+          </p:cNvPr>
+          <p:cNvSpPr>
+            <a:spLocks xmlns:a="http://schemas.openxmlformats.org/drawingml/2006/main" noGrp="1"/>
+          </p:cNvSpPr>
+          <p:nvPr/>
+        </p:nvSpPr>
+        <p:spPr>
+          <a:xfrm xmlns:a="http://schemas.openxmlformats.org/drawingml/2006/main">
+            <a:off x="5095875" y="3067050"/>
+            <a:ext cx="1381125" cy="28575"/>
           </a:xfrm>
           <a:prstGeom xmlns:a="http://schemas.openxmlformats.org/drawingml/2006/main" prst="rect">
             <a:avLst/>
@@ -7082,18 +7174,18 @@
           <p:cNvPr id="11" name="">
             <a:extLst xmlns:a="http://schemas.openxmlformats.org/drawingml/2006/main">
               <a:ext uri="{FF2B5EF4-FFF2-40B4-BE49-F238E27FC236}">
-                <a16:creationId xmlns:a16="http://schemas.microsoft.com/office/drawing/2014/main" id="{24CA184C-F405-487E-AF91-042D5A671718}"/>
-              </a:ext>
-            </a:extLst>
-          </p:cNvPr>
-          <p:cNvSpPr>
-            <a:spLocks xmlns:a="http://schemas.openxmlformats.org/drawingml/2006/main" noGrp="1"/>
-          </p:cNvSpPr>
-          <p:nvPr/>
-        </p:nvSpPr>
-        <p:spPr>
-          <a:xfrm xmlns:a="http://schemas.openxmlformats.org/drawingml/2006/main">
-            <a:off x="4676775" y="2771775"/>
+                <a16:creationId xmlns:a16="http://schemas.microsoft.com/office/drawing/2014/main" id="{0997C3CF-0F39-47E9-8658-55B1497682EE}"/>
+              </a:ext>
+            </a:extLst>
+          </p:cNvPr>
+          <p:cNvSpPr>
+            <a:spLocks xmlns:a="http://schemas.openxmlformats.org/drawingml/2006/main" noGrp="1"/>
+          </p:cNvSpPr>
+          <p:nvPr/>
+        </p:nvSpPr>
+        <p:spPr>
+          <a:xfrm xmlns:a="http://schemas.openxmlformats.org/drawingml/2006/main">
+            <a:off x="6438900" y="3000375"/>
             <a:ext cx="152400" cy="152400"/>
           </a:xfrm>
           <a:prstGeom xmlns:a="http://schemas.openxmlformats.org/drawingml/2006/main" prst="triangle">
@@ -7115,19 +7207,19 @@
           <p:cNvPr id="12" name="">
             <a:extLst xmlns:a="http://schemas.openxmlformats.org/drawingml/2006/main">
               <a:ext uri="{FF2B5EF4-FFF2-40B4-BE49-F238E27FC236}">
-                <a16:creationId xmlns:a16="http://schemas.microsoft.com/office/drawing/2014/main" id="{D21163FE-84E8-459E-8297-1A22FDD79DE6}"/>
-              </a:ext>
-            </a:extLst>
-          </p:cNvPr>
-          <p:cNvSpPr>
-            <a:spLocks xmlns:a="http://schemas.openxmlformats.org/drawingml/2006/main" noGrp="1"/>
-          </p:cNvSpPr>
-          <p:nvPr/>
-        </p:nvSpPr>
-        <p:spPr>
-          <a:xfrm xmlns:a="http://schemas.openxmlformats.org/drawingml/2006/main">
-            <a:off x="4905375" y="2047875"/>
-            <a:ext cx="2714625" cy="1619250"/>
+                <a16:creationId xmlns:a16="http://schemas.microsoft.com/office/drawing/2014/main" id="{6BF0ACAE-DF65-4633-BC32-821235ADBDC3}"/>
+              </a:ext>
+            </a:extLst>
+          </p:cNvPr>
+          <p:cNvSpPr>
+            <a:spLocks xmlns:a="http://schemas.openxmlformats.org/drawingml/2006/main" noGrp="1"/>
+          </p:cNvSpPr>
+          <p:nvPr/>
+        </p:nvSpPr>
+        <p:spPr>
+          <a:xfrm xmlns:a="http://schemas.openxmlformats.org/drawingml/2006/main">
+            <a:off x="7000875" y="2095500"/>
+            <a:ext cx="3048000" cy="2000250"/>
           </a:xfrm>
           <a:prstGeom xmlns:a="http://schemas.openxmlformats.org/drawingml/2006/main" prst="rect">
             <a:avLst/>
@@ -7137,7 +7229,7 @@
           </a:solidFill>
           <a:ln xmlns:a="http://schemas.openxmlformats.org/drawingml/2006/main" w="13335">
             <a:solidFill>
-              <a:srgbClr val="F59E0B"/>
+              <a:srgbClr val="7C3AED"/>
             </a:solidFill>
             <a:prstDash val="solid"/>
           </a:ln>
@@ -7148,25 +7240,25 @@
           <p:cNvPr id="13" name="">
             <a:extLst xmlns:a="http://schemas.openxmlformats.org/drawingml/2006/main">
               <a:ext uri="{FF2B5EF4-FFF2-40B4-BE49-F238E27FC236}">
-                <a16:creationId xmlns:a16="http://schemas.microsoft.com/office/drawing/2014/main" id="{9AD78907-2752-4BB8-8E87-22B25855AC6C}"/>
-              </a:ext>
-            </a:extLst>
-          </p:cNvPr>
-          <p:cNvSpPr>
-            <a:spLocks xmlns:a="http://schemas.openxmlformats.org/drawingml/2006/main" noGrp="1"/>
-          </p:cNvSpPr>
-          <p:nvPr/>
-        </p:nvSpPr>
-        <p:spPr>
-          <a:xfrm xmlns:a="http://schemas.openxmlformats.org/drawingml/2006/main">
-            <a:off x="4905375" y="2047875"/>
-            <a:ext cx="2714625" cy="66675"/>
-          </a:xfrm>
-          <a:prstGeom xmlns:a="http://schemas.openxmlformats.org/drawingml/2006/main" prst="rect">
-            <a:avLst/>
-          </a:prstGeom>
-          <a:solidFill xmlns:a="http://schemas.openxmlformats.org/drawingml/2006/main">
-            <a:srgbClr val="F59E0B"/>
+                <a16:creationId xmlns:a16="http://schemas.microsoft.com/office/drawing/2014/main" id="{A2C64B48-0AE5-4362-933E-CAAADBDF6D9B}"/>
+              </a:ext>
+            </a:extLst>
+          </p:cNvPr>
+          <p:cNvSpPr>
+            <a:spLocks xmlns:a="http://schemas.openxmlformats.org/drawingml/2006/main" noGrp="1"/>
+          </p:cNvSpPr>
+          <p:nvPr/>
+        </p:nvSpPr>
+        <p:spPr>
+          <a:xfrm xmlns:a="http://schemas.openxmlformats.org/drawingml/2006/main">
+            <a:off x="7000875" y="2095500"/>
+            <a:ext cx="3048000" cy="66675"/>
+          </a:xfrm>
+          <a:prstGeom xmlns:a="http://schemas.openxmlformats.org/drawingml/2006/main" prst="rect">
+            <a:avLst/>
+          </a:prstGeom>
+          <a:solidFill xmlns:a="http://schemas.openxmlformats.org/drawingml/2006/main">
+            <a:srgbClr val="7C3AED"/>
           </a:solidFill>
           <a:ln xmlns:a="http://schemas.openxmlformats.org/drawingml/2006/main" w="0">
             <a:solidFill>
@@ -7183,19 +7275,19 @@
           <p:cNvPr id="14" name="">
             <a:extLst xmlns:a="http://schemas.openxmlformats.org/drawingml/2006/main">
               <a:ext uri="{FF2B5EF4-FFF2-40B4-BE49-F238E27FC236}">
-                <a16:creationId xmlns:a16="http://schemas.microsoft.com/office/drawing/2014/main" id="{DA487D3A-5FBE-429E-8AE4-8D8E920DB591}"/>
-              </a:ext>
-            </a:extLst>
-          </p:cNvPr>
-          <p:cNvSpPr>
-            <a:spLocks xmlns:a="http://schemas.openxmlformats.org/drawingml/2006/main" noGrp="1"/>
-          </p:cNvSpPr>
-          <p:nvPr/>
-        </p:nvSpPr>
-        <p:spPr>
-          <a:xfrm xmlns:a="http://schemas.openxmlformats.org/drawingml/2006/main">
-            <a:off x="5038725" y="2257425"/>
-            <a:ext cx="2447925" cy="266700"/>
+                <a16:creationId xmlns:a16="http://schemas.microsoft.com/office/drawing/2014/main" id="{2FA8E82F-782D-46CB-94F7-1412A30FD102}"/>
+              </a:ext>
+            </a:extLst>
+          </p:cNvPr>
+          <p:cNvSpPr>
+            <a:spLocks xmlns:a="http://schemas.openxmlformats.org/drawingml/2006/main" noGrp="1"/>
+          </p:cNvSpPr>
+          <p:nvPr/>
+        </p:nvSpPr>
+        <p:spPr>
+          <a:xfrm xmlns:a="http://schemas.openxmlformats.org/drawingml/2006/main">
+            <a:off x="7134225" y="2305050"/>
+            <a:ext cx="2781300" cy="266700"/>
           </a:xfrm>
           <a:prstGeom xmlns:a="http://schemas.openxmlformats.org/drawingml/2006/main" prst="rect">
             <a:avLst/>
@@ -7237,7 +7329,7 @@
                 <a:ea typeface="PingFang SC"/>
                 <a:cs typeface="PingFang SC"/>
               </a:rPr>
-              <a:t>角色维护者</a:t>
+              <a:t>管理员</a:t>
             </a:r>
           </a:p>
         </p:txBody>
@@ -7247,19 +7339,19 @@
           <p:cNvPr id="15" name="">
             <a:extLst xmlns:a="http://schemas.openxmlformats.org/drawingml/2006/main">
               <a:ext uri="{FF2B5EF4-FFF2-40B4-BE49-F238E27FC236}">
-                <a16:creationId xmlns:a16="http://schemas.microsoft.com/office/drawing/2014/main" id="{02819265-B109-4FC2-9D20-2034309A6169}"/>
-              </a:ext>
-            </a:extLst>
-          </p:cNvPr>
-          <p:cNvSpPr>
-            <a:spLocks xmlns:a="http://schemas.openxmlformats.org/drawingml/2006/main" noGrp="1"/>
-          </p:cNvSpPr>
-          <p:nvPr/>
-        </p:nvSpPr>
-        <p:spPr>
-          <a:xfrm xmlns:a="http://schemas.openxmlformats.org/drawingml/2006/main">
-            <a:off x="5076825" y="2600325"/>
-            <a:ext cx="2371725" cy="990600"/>
+                <a16:creationId xmlns:a16="http://schemas.microsoft.com/office/drawing/2014/main" id="{2D66AF47-10A5-4405-B934-90EE2BB02314}"/>
+              </a:ext>
+            </a:extLst>
+          </p:cNvPr>
+          <p:cNvSpPr>
+            <a:spLocks xmlns:a="http://schemas.openxmlformats.org/drawingml/2006/main" noGrp="1"/>
+          </p:cNvSpPr>
+          <p:nvPr/>
+        </p:nvSpPr>
+        <p:spPr>
+          <a:xfrm xmlns:a="http://schemas.openxmlformats.org/drawingml/2006/main">
+            <a:off x="7172325" y="2647950"/>
+            <a:ext cx="2705100" cy="1371600"/>
           </a:xfrm>
           <a:prstGeom xmlns:a="http://schemas.openxmlformats.org/drawingml/2006/main" prst="rect">
             <a:avLst/>
@@ -7301,250 +7393,9 @@
                 <a:ea typeface="PingFang SC"/>
                 <a:cs typeface="PingFang SC"/>
               </a:rPr>
-              <a:t>维护 AI 角色资料与状态，服务内容侧配置</a:t>
+              <a:t>用户管理</a:t>
             </a:r>
           </a:p>
-        </p:txBody>
-      </p:sp>
-      <p:sp>
-        <p:nvSpPr>
-          <p:cNvPr id="16" name="">
-            <a:extLst xmlns:a="http://schemas.openxmlformats.org/drawingml/2006/main">
-              <a:ext uri="{FF2B5EF4-FFF2-40B4-BE49-F238E27FC236}">
-                <a16:creationId xmlns:a16="http://schemas.microsoft.com/office/drawing/2014/main" id="{2B1539B2-8EB7-4AD9-A8FA-0BC04F29FB87}"/>
-              </a:ext>
-            </a:extLst>
-          </p:cNvPr>
-          <p:cNvSpPr>
-            <a:spLocks xmlns:a="http://schemas.openxmlformats.org/drawingml/2006/main" noGrp="1"/>
-          </p:cNvSpPr>
-          <p:nvPr/>
-        </p:nvSpPr>
-        <p:spPr>
-          <a:xfrm xmlns:a="http://schemas.openxmlformats.org/drawingml/2006/main">
-            <a:off x="7810500" y="2838450"/>
-            <a:ext cx="904875" cy="28575"/>
-          </a:xfrm>
-          <a:prstGeom xmlns:a="http://schemas.openxmlformats.org/drawingml/2006/main" prst="rect">
-            <a:avLst/>
-          </a:prstGeom>
-          <a:solidFill xmlns:a="http://schemas.openxmlformats.org/drawingml/2006/main">
-            <a:srgbClr val="94A3B8"/>
-          </a:solidFill>
-          <a:ln xmlns:a="http://schemas.openxmlformats.org/drawingml/2006/main" w="0">
-            <a:solidFill>
-              <a:srgbClr val="000000">
-                <a:alpha val="0"/>
-              </a:srgbClr>
-            </a:solidFill>
-            <a:prstDash val="solid"/>
-          </a:ln>
-        </p:spPr>
-      </p:sp>
-      <p:sp>
-        <p:nvSpPr>
-          <p:cNvPr id="17" name="">
-            <a:extLst xmlns:a="http://schemas.openxmlformats.org/drawingml/2006/main">
-              <a:ext uri="{FF2B5EF4-FFF2-40B4-BE49-F238E27FC236}">
-                <a16:creationId xmlns:a16="http://schemas.microsoft.com/office/drawing/2014/main" id="{6C5FED63-56B3-4B3B-9E00-90AFA93152BB}"/>
-              </a:ext>
-            </a:extLst>
-          </p:cNvPr>
-          <p:cNvSpPr>
-            <a:spLocks xmlns:a="http://schemas.openxmlformats.org/drawingml/2006/main" noGrp="1"/>
-          </p:cNvSpPr>
-          <p:nvPr/>
-        </p:nvSpPr>
-        <p:spPr>
-          <a:xfrm xmlns:a="http://schemas.openxmlformats.org/drawingml/2006/main">
-            <a:off x="8677275" y="2771775"/>
-            <a:ext cx="152400" cy="152400"/>
-          </a:xfrm>
-          <a:prstGeom xmlns:a="http://schemas.openxmlformats.org/drawingml/2006/main" prst="triangle">
-            <a:avLst/>
-          </a:prstGeom>
-          <a:solidFill xmlns:a="http://schemas.openxmlformats.org/drawingml/2006/main">
-            <a:srgbClr val="94A3B8"/>
-          </a:solidFill>
-          <a:ln xmlns:a="http://schemas.openxmlformats.org/drawingml/2006/main" w="0">
-            <a:solidFill>
-              <a:srgbClr val="94A3B8"/>
-            </a:solidFill>
-            <a:prstDash val="solid"/>
-          </a:ln>
-        </p:spPr>
-      </p:sp>
-      <p:sp>
-        <p:nvSpPr>
-          <p:cNvPr id="18" name="">
-            <a:extLst xmlns:a="http://schemas.openxmlformats.org/drawingml/2006/main">
-              <a:ext uri="{FF2B5EF4-FFF2-40B4-BE49-F238E27FC236}">
-                <a16:creationId xmlns:a16="http://schemas.microsoft.com/office/drawing/2014/main" id="{78B4D2E7-DAD2-4268-9CEB-902E2FB8A29D}"/>
-              </a:ext>
-            </a:extLst>
-          </p:cNvPr>
-          <p:cNvSpPr>
-            <a:spLocks xmlns:a="http://schemas.openxmlformats.org/drawingml/2006/main" noGrp="1"/>
-          </p:cNvSpPr>
-          <p:nvPr/>
-        </p:nvSpPr>
-        <p:spPr>
-          <a:xfrm xmlns:a="http://schemas.openxmlformats.org/drawingml/2006/main">
-            <a:off x="8905875" y="2047875"/>
-            <a:ext cx="2714625" cy="1619250"/>
-          </a:xfrm>
-          <a:prstGeom xmlns:a="http://schemas.openxmlformats.org/drawingml/2006/main" prst="rect">
-            <a:avLst/>
-          </a:prstGeom>
-          <a:solidFill xmlns:a="http://schemas.openxmlformats.org/drawingml/2006/main">
-            <a:srgbClr val="FFFFFF"/>
-          </a:solidFill>
-          <a:ln xmlns:a="http://schemas.openxmlformats.org/drawingml/2006/main" w="13335">
-            <a:solidFill>
-              <a:srgbClr val="7C3AED"/>
-            </a:solidFill>
-            <a:prstDash val="solid"/>
-          </a:ln>
-        </p:spPr>
-      </p:sp>
-      <p:sp>
-        <p:nvSpPr>
-          <p:cNvPr id="19" name="">
-            <a:extLst xmlns:a="http://schemas.openxmlformats.org/drawingml/2006/main">
-              <a:ext uri="{FF2B5EF4-FFF2-40B4-BE49-F238E27FC236}">
-                <a16:creationId xmlns:a16="http://schemas.microsoft.com/office/drawing/2014/main" id="{A1CF8811-1652-4274-B1BE-4919D68794FC}"/>
-              </a:ext>
-            </a:extLst>
-          </p:cNvPr>
-          <p:cNvSpPr>
-            <a:spLocks xmlns:a="http://schemas.openxmlformats.org/drawingml/2006/main" noGrp="1"/>
-          </p:cNvSpPr>
-          <p:nvPr/>
-        </p:nvSpPr>
-        <p:spPr>
-          <a:xfrm xmlns:a="http://schemas.openxmlformats.org/drawingml/2006/main">
-            <a:off x="8905875" y="2047875"/>
-            <a:ext cx="2714625" cy="66675"/>
-          </a:xfrm>
-          <a:prstGeom xmlns:a="http://schemas.openxmlformats.org/drawingml/2006/main" prst="rect">
-            <a:avLst/>
-          </a:prstGeom>
-          <a:solidFill xmlns:a="http://schemas.openxmlformats.org/drawingml/2006/main">
-            <a:srgbClr val="7C3AED"/>
-          </a:solidFill>
-          <a:ln xmlns:a="http://schemas.openxmlformats.org/drawingml/2006/main" w="0">
-            <a:solidFill>
-              <a:srgbClr val="000000">
-                <a:alpha val="0"/>
-              </a:srgbClr>
-            </a:solidFill>
-            <a:prstDash val="solid"/>
-          </a:ln>
-        </p:spPr>
-      </p:sp>
-      <p:sp>
-        <p:nvSpPr>
-          <p:cNvPr id="20" name="">
-            <a:extLst xmlns:a="http://schemas.openxmlformats.org/drawingml/2006/main">
-              <a:ext uri="{FF2B5EF4-FFF2-40B4-BE49-F238E27FC236}">
-                <a16:creationId xmlns:a16="http://schemas.microsoft.com/office/drawing/2014/main" id="{43C67BF9-E4AE-4218-8142-7D9887BA00A9}"/>
-              </a:ext>
-            </a:extLst>
-          </p:cNvPr>
-          <p:cNvSpPr>
-            <a:spLocks xmlns:a="http://schemas.openxmlformats.org/drawingml/2006/main" noGrp="1"/>
-          </p:cNvSpPr>
-          <p:nvPr/>
-        </p:nvSpPr>
-        <p:spPr>
-          <a:xfrm xmlns:a="http://schemas.openxmlformats.org/drawingml/2006/main">
-            <a:off x="9039225" y="2257425"/>
-            <a:ext cx="2447925" cy="266700"/>
-          </a:xfrm>
-          <a:prstGeom xmlns:a="http://schemas.openxmlformats.org/drawingml/2006/main" prst="rect">
-            <a:avLst/>
-          </a:prstGeom>
-          <a:solidFill xmlns:a="http://schemas.openxmlformats.org/drawingml/2006/main">
-            <a:srgbClr val="000000">
-              <a:alpha val="0"/>
-            </a:srgbClr>
-          </a:solidFill>
-          <a:ln xmlns:a="http://schemas.openxmlformats.org/drawingml/2006/main" w="0">
-            <a:solidFill>
-              <a:srgbClr val="000000">
-                <a:alpha val="0"/>
-              </a:srgbClr>
-            </a:solidFill>
-            <a:prstDash val="solid"/>
-          </a:ln>
-        </p:spPr>
-        <p:txBody>
-          <a:bodyPr xmlns:a="http://schemas.openxmlformats.org/drawingml/2006/main" lIns="0" tIns="0" rIns="0" bIns="0" anchor="t"/>
-          <a:lstStyle xmlns:a="http://schemas.openxmlformats.org/drawingml/2006/main"/>
-          <a:p xmlns:a="http://schemas.openxmlformats.org/drawingml/2006/main">
-            <a:pPr algn="ctr">
-              <a:defRPr sz="1425" b="1">
-                <a:solidFill>
-                  <a:srgbClr val="111827"/>
-                </a:solidFill>
-                <a:latin typeface="PingFang SC"/>
-                <a:ea typeface="PingFang SC"/>
-                <a:cs typeface="PingFang SC"/>
-              </a:defRPr>
-            </a:pPr>
-            <a:r>
-              <a:rPr sz="1425" b="1">
-                <a:solidFill>
-                  <a:srgbClr val="111827"/>
-                </a:solidFill>
-                <a:latin typeface="PingFang SC"/>
-                <a:ea typeface="PingFang SC"/>
-                <a:cs typeface="PingFang SC"/>
-              </a:rPr>
-              <a:t>管理员</a:t>
-            </a:r>
-          </a:p>
-        </p:txBody>
-      </p:sp>
-      <p:sp>
-        <p:nvSpPr>
-          <p:cNvPr id="21" name="">
-            <a:extLst xmlns:a="http://schemas.openxmlformats.org/drawingml/2006/main">
-              <a:ext uri="{FF2B5EF4-FFF2-40B4-BE49-F238E27FC236}">
-                <a16:creationId xmlns:a16="http://schemas.microsoft.com/office/drawing/2014/main" id="{6E474EEA-18CF-4121-AF61-91DFB0B58E88}"/>
-              </a:ext>
-            </a:extLst>
-          </p:cNvPr>
-          <p:cNvSpPr>
-            <a:spLocks xmlns:a="http://schemas.openxmlformats.org/drawingml/2006/main" noGrp="1"/>
-          </p:cNvSpPr>
-          <p:nvPr/>
-        </p:nvSpPr>
-        <p:spPr>
-          <a:xfrm xmlns:a="http://schemas.openxmlformats.org/drawingml/2006/main">
-            <a:off x="9077325" y="2600325"/>
-            <a:ext cx="2371725" cy="990600"/>
-          </a:xfrm>
-          <a:prstGeom xmlns:a="http://schemas.openxmlformats.org/drawingml/2006/main" prst="rect">
-            <a:avLst/>
-          </a:prstGeom>
-          <a:solidFill xmlns:a="http://schemas.openxmlformats.org/drawingml/2006/main">
-            <a:srgbClr val="000000">
-              <a:alpha val="0"/>
-            </a:srgbClr>
-          </a:solidFill>
-          <a:ln xmlns:a="http://schemas.openxmlformats.org/drawingml/2006/main" w="0">
-            <a:solidFill>
-              <a:srgbClr val="000000">
-                <a:alpha val="0"/>
-              </a:srgbClr>
-            </a:solidFill>
-            <a:prstDash val="solid"/>
-          </a:ln>
-        </p:spPr>
-        <p:txBody>
-          <a:bodyPr xmlns:a="http://schemas.openxmlformats.org/drawingml/2006/main" lIns="0" tIns="0" rIns="0" bIns="0" anchor="t"/>
-          <a:lstStyle xmlns:a="http://schemas.openxmlformats.org/drawingml/2006/main"/>
           <a:p xmlns:a="http://schemas.openxmlformats.org/drawingml/2006/main">
             <a:pPr algn="ctr">
               <a:defRPr sz="975" b="0">
@@ -7565,29 +7416,98 @@
                 <a:ea typeface="PingFang SC"/>
                 <a:cs typeface="PingFang SC"/>
               </a:rPr>
-              <a:t>用户管理、消息管理、反馈、日志、统计，继承维护者能力</a:t>
+              <a:t>AI 角色状态管理</a:t>
             </a:r>
           </a:p>
-        </p:txBody>
-      </p:sp>
-      <p:sp>
-        <p:nvSpPr>
-          <p:cNvPr id="22" name="">
-            <a:extLst xmlns:a="http://schemas.openxmlformats.org/drawingml/2006/main">
-              <a:ext uri="{FF2B5EF4-FFF2-40B4-BE49-F238E27FC236}">
-                <a16:creationId xmlns:a16="http://schemas.microsoft.com/office/drawing/2014/main" id="{C394AA5D-42E4-4CBD-8AEF-6FA1F5AFD700}"/>
-              </a:ext>
-            </a:extLst>
-          </p:cNvPr>
-          <p:cNvSpPr>
-            <a:spLocks xmlns:a="http://schemas.openxmlformats.org/drawingml/2006/main" noGrp="1"/>
-          </p:cNvSpPr>
-          <p:nvPr/>
-        </p:nvSpPr>
-        <p:spPr>
-          <a:xfrm xmlns:a="http://schemas.openxmlformats.org/drawingml/2006/main">
-            <a:off x="1238250" y="4333875"/>
-            <a:ext cx="9715500" cy="1047750"/>
+          <a:p xmlns:a="http://schemas.openxmlformats.org/drawingml/2006/main">
+            <a:pPr algn="ctr">
+              <a:defRPr sz="975" b="0">
+                <a:solidFill>
+                  <a:srgbClr val="64748B"/>
+                </a:solidFill>
+                <a:latin typeface="PingFang SC"/>
+                <a:ea typeface="PingFang SC"/>
+                <a:cs typeface="PingFang SC"/>
+              </a:defRPr>
+            </a:pPr>
+            <a:r>
+              <a:rPr sz="975" b="0">
+                <a:solidFill>
+                  <a:srgbClr val="64748B"/>
+                </a:solidFill>
+                <a:latin typeface="PingFang SC"/>
+                <a:ea typeface="PingFang SC"/>
+                <a:cs typeface="PingFang SC"/>
+              </a:rPr>
+              <a:t>消息治理</a:t>
+            </a:r>
+          </a:p>
+          <a:p xmlns:a="http://schemas.openxmlformats.org/drawingml/2006/main">
+            <a:pPr algn="ctr">
+              <a:defRPr sz="975" b="0">
+                <a:solidFill>
+                  <a:srgbClr val="64748B"/>
+                </a:solidFill>
+                <a:latin typeface="PingFang SC"/>
+                <a:ea typeface="PingFang SC"/>
+                <a:cs typeface="PingFang SC"/>
+              </a:defRPr>
+            </a:pPr>
+            <a:r>
+              <a:rPr sz="975" b="0">
+                <a:solidFill>
+                  <a:srgbClr val="64748B"/>
+                </a:solidFill>
+                <a:latin typeface="PingFang SC"/>
+                <a:ea typeface="PingFang SC"/>
+                <a:cs typeface="PingFang SC"/>
+              </a:rPr>
+              <a:t>反馈处理</a:t>
+            </a:r>
+          </a:p>
+          <a:p xmlns:a="http://schemas.openxmlformats.org/drawingml/2006/main">
+            <a:pPr algn="ctr">
+              <a:defRPr sz="975" b="0">
+                <a:solidFill>
+                  <a:srgbClr val="64748B"/>
+                </a:solidFill>
+                <a:latin typeface="PingFang SC"/>
+                <a:ea typeface="PingFang SC"/>
+                <a:cs typeface="PingFang SC"/>
+              </a:defRPr>
+            </a:pPr>
+            <a:r>
+              <a:rPr sz="975" b="0">
+                <a:solidFill>
+                  <a:srgbClr val="64748B"/>
+                </a:solidFill>
+                <a:latin typeface="PingFang SC"/>
+                <a:ea typeface="PingFang SC"/>
+                <a:cs typeface="PingFang SC"/>
+              </a:rPr>
+              <a:t>日志与系统统计</a:t>
+            </a:r>
+          </a:p>
+        </p:txBody>
+      </p:sp>
+      <p:sp>
+        <p:nvSpPr>
+          <p:cNvPr id="16" name="">
+            <a:extLst xmlns:a="http://schemas.openxmlformats.org/drawingml/2006/main">
+              <a:ext uri="{FF2B5EF4-FFF2-40B4-BE49-F238E27FC236}">
+                <a16:creationId xmlns:a16="http://schemas.microsoft.com/office/drawing/2014/main" id="{18B2C460-9BA1-46C2-B22B-4BDA37D43D32}"/>
+              </a:ext>
+            </a:extLst>
+          </p:cNvPr>
+          <p:cNvSpPr>
+            <a:spLocks xmlns:a="http://schemas.openxmlformats.org/drawingml/2006/main" noGrp="1"/>
+          </p:cNvSpPr>
+          <p:nvPr/>
+        </p:nvSpPr>
+        <p:spPr>
+          <a:xfrm xmlns:a="http://schemas.openxmlformats.org/drawingml/2006/main">
+            <a:off x="1238250" y="4762500"/>
+            <a:ext cx="9715500" cy="914400"/>
           </a:xfrm>
           <a:prstGeom xmlns:a="http://schemas.openxmlformats.org/drawingml/2006/main" prst="rect">
             <a:avLst/>
@@ -7605,22 +7525,22 @@
       </p:sp>
       <p:sp>
         <p:nvSpPr>
-          <p:cNvPr id="23" name="">
-            <a:extLst xmlns:a="http://schemas.openxmlformats.org/drawingml/2006/main">
-              <a:ext uri="{FF2B5EF4-FFF2-40B4-BE49-F238E27FC236}">
-                <a16:creationId xmlns:a16="http://schemas.microsoft.com/office/drawing/2014/main" id="{6EE95041-9DD7-444F-9987-F7961F1A5A7E}"/>
-              </a:ext>
-            </a:extLst>
-          </p:cNvPr>
-          <p:cNvSpPr>
-            <a:spLocks xmlns:a="http://schemas.openxmlformats.org/drawingml/2006/main" noGrp="1"/>
-          </p:cNvSpPr>
-          <p:nvPr/>
-        </p:nvSpPr>
-        <p:spPr>
-          <a:xfrm xmlns:a="http://schemas.openxmlformats.org/drawingml/2006/main">
-            <a:off x="1524000" y="4591050"/>
-            <a:ext cx="4953000" cy="266700"/>
+          <p:cNvPr id="17" name="">
+            <a:extLst xmlns:a="http://schemas.openxmlformats.org/drawingml/2006/main">
+              <a:ext uri="{FF2B5EF4-FFF2-40B4-BE49-F238E27FC236}">
+                <a16:creationId xmlns:a16="http://schemas.microsoft.com/office/drawing/2014/main" id="{BEB7E33A-EEC3-4F38-BCA6-761F5B3FD5E6}"/>
+              </a:ext>
+            </a:extLst>
+          </p:cNvPr>
+          <p:cNvSpPr>
+            <a:spLocks xmlns:a="http://schemas.openxmlformats.org/drawingml/2006/main" noGrp="1"/>
+          </p:cNvSpPr>
+          <p:nvPr/>
+        </p:nvSpPr>
+        <p:spPr>
+          <a:xfrm xmlns:a="http://schemas.openxmlformats.org/drawingml/2006/main">
+            <a:off x="1524000" y="5000625"/>
+            <a:ext cx="3429000" cy="266700"/>
           </a:xfrm>
           <a:prstGeom xmlns:a="http://schemas.openxmlformats.org/drawingml/2006/main" prst="rect">
             <a:avLst/>
@@ -7662,29 +7582,29 @@
                 <a:ea typeface="PingFang SC"/>
                 <a:cs typeface="PingFang SC"/>
               </a:rPr>
-              <a:t>为什么角色维护者和管理员不合并？</a:t>
+              <a:t>为什么合并“角色维护者”？</a:t>
             </a:r>
           </a:p>
         </p:txBody>
       </p:sp>
       <p:sp>
         <p:nvSpPr>
-          <p:cNvPr id="24" name="">
-            <a:extLst xmlns:a="http://schemas.openxmlformats.org/drawingml/2006/main">
-              <a:ext uri="{FF2B5EF4-FFF2-40B4-BE49-F238E27FC236}">
-                <a16:creationId xmlns:a16="http://schemas.microsoft.com/office/drawing/2014/main" id="{B35D2879-0B4B-45E8-AA24-63412E06E606}"/>
-              </a:ext>
-            </a:extLst>
-          </p:cNvPr>
-          <p:cNvSpPr>
-            <a:spLocks xmlns:a="http://schemas.openxmlformats.org/drawingml/2006/main" noGrp="1"/>
-          </p:cNvSpPr>
-          <p:nvPr/>
-        </p:nvSpPr>
-        <p:spPr>
-          <a:xfrm xmlns:a="http://schemas.openxmlformats.org/drawingml/2006/main">
-            <a:off x="1524000" y="4972050"/>
-            <a:ext cx="8572500" cy="381000"/>
+          <p:cNvPr id="18" name="">
+            <a:extLst xmlns:a="http://schemas.openxmlformats.org/drawingml/2006/main">
+              <a:ext uri="{FF2B5EF4-FFF2-40B4-BE49-F238E27FC236}">
+                <a16:creationId xmlns:a16="http://schemas.microsoft.com/office/drawing/2014/main" id="{F8FB6853-DD96-4A6D-B0FB-39CA8065FB72}"/>
+              </a:ext>
+            </a:extLst>
+          </p:cNvPr>
+          <p:cNvSpPr>
+            <a:spLocks xmlns:a="http://schemas.openxmlformats.org/drawingml/2006/main" noGrp="1"/>
+          </p:cNvSpPr>
+          <p:nvPr/>
+        </p:nvSpPr>
+        <p:spPr>
+          <a:xfrm xmlns:a="http://schemas.openxmlformats.org/drawingml/2006/main">
+            <a:off x="4762500" y="5010150"/>
+            <a:ext cx="5429250" cy="400050"/>
           </a:xfrm>
           <a:prstGeom xmlns:a="http://schemas.openxmlformats.org/drawingml/2006/main" prst="rect">
             <a:avLst/>
@@ -7726,17 +7646,17 @@
                 <a:ea typeface="PingFang SC"/>
                 <a:cs typeface="PingFang SC"/>
               </a:rPr>
-              <a:t>角色维护是内容配置权限；管理员是平台治理权限。拆开可以避免“能改角色的人也能改用户、看日志、看统计”的越权问题。管理员继承维护能力，但维护者不能反向进入系统管理。</a:t>
+              <a:t>它本质是用户侧自定义配置：普通用户维护自己的 AI 角色，管理员负责平台级审核和状态治理。这样角色体系更简单，答辩演示也更自然。</a:t>
             </a:r>
           </a:p>
         </p:txBody>
       </p:sp>
       <p:sp>
         <p:nvSpPr>
-          <p:cNvPr id="25" name="">
-            <a:extLst xmlns:a="http://schemas.openxmlformats.org/drawingml/2006/main">
-              <a:ext uri="{FF2B5EF4-FFF2-40B4-BE49-F238E27FC236}">
-                <a16:creationId xmlns:a16="http://schemas.microsoft.com/office/drawing/2014/main" id="{77DB5382-FB0F-4560-ADF1-2EDB2E58BBAB}"/>
+          <p:cNvPr id="19" name="">
+            <a:extLst xmlns:a="http://schemas.openxmlformats.org/drawingml/2006/main">
+              <a:ext uri="{FF2B5EF4-FFF2-40B4-BE49-F238E27FC236}">
+                <a16:creationId xmlns:a16="http://schemas.microsoft.com/office/drawing/2014/main" id="{A75FA749-85FB-419F-9D5C-4C56BDD3A50B}"/>
               </a:ext>
             </a:extLst>
           </p:cNvPr>
@@ -7797,10 +7717,10 @@
       </p:sp>
       <p:sp>
         <p:nvSpPr>
-          <p:cNvPr id="26" name="">
-            <a:extLst xmlns:a="http://schemas.openxmlformats.org/drawingml/2006/main">
-              <a:ext uri="{FF2B5EF4-FFF2-40B4-BE49-F238E27FC236}">
-                <a16:creationId xmlns:a16="http://schemas.microsoft.com/office/drawing/2014/main" id="{237BDF70-1A1C-4050-88A8-2FB041DA8A5C}"/>
+          <p:cNvPr id="20" name="">
+            <a:extLst xmlns:a="http://schemas.openxmlformats.org/drawingml/2006/main">
+              <a:ext uri="{FF2B5EF4-FFF2-40B4-BE49-F238E27FC236}">
+                <a16:creationId xmlns:a16="http://schemas.microsoft.com/office/drawing/2014/main" id="{23EAEE7D-68C5-4C57-A581-BA883D6D86E4}"/>
               </a:ext>
             </a:extLst>
           </p:cNvPr>
@@ -7862,7 +7782,7 @@
     </p:spTree>
     <p:extLst>
       <p:ext uri="{BB962C8B-B14F-4D97-AF65-F5344CB8AC3E}">
-        <p14:creationId xmlns:p14="http://schemas.microsoft.com/office/powerpoint/2010/main" val="61501972"/>
+        <p14:creationId xmlns:p14="http://schemas.microsoft.com/office/powerpoint/2010/main" val="2067681135"/>
       </p:ext>
     </p:extLst>
   </p:cSld>
@@ -7886,7 +7806,7 @@
           <p:cNvPr id="1" name="">
             <a:extLst xmlns:a="http://schemas.openxmlformats.org/drawingml/2006/main">
               <a:ext uri="{FF2B5EF4-FFF2-40B4-BE49-F238E27FC236}">
-                <a16:creationId xmlns:a16="http://schemas.microsoft.com/office/drawing/2014/main" id="{6428B36B-FCC6-4880-805C-CC6DA144364C}"/>
+                <a16:creationId xmlns:a16="http://schemas.microsoft.com/office/drawing/2014/main" id="{276902C1-6DB1-472C-B017-1209FA917692}"/>
               </a:ext>
             </a:extLst>
           </p:cNvPr>
@@ -7921,7 +7841,7 @@
           <p:cNvPr id="2" name="">
             <a:extLst xmlns:a="http://schemas.openxmlformats.org/drawingml/2006/main">
               <a:ext uri="{FF2B5EF4-FFF2-40B4-BE49-F238E27FC236}">
-                <a16:creationId xmlns:a16="http://schemas.microsoft.com/office/drawing/2014/main" id="{BB0D03A3-3421-4DDF-B160-46C0AA6A488E}"/>
+                <a16:creationId xmlns:a16="http://schemas.microsoft.com/office/drawing/2014/main" id="{C6DDC7E6-5C6C-4674-9434-6D028E44E6FD}"/>
               </a:ext>
             </a:extLst>
           </p:cNvPr>
@@ -7956,7 +7876,7 @@
           <p:cNvPr id="3" name="">
             <a:extLst xmlns:a="http://schemas.openxmlformats.org/drawingml/2006/main">
               <a:ext uri="{FF2B5EF4-FFF2-40B4-BE49-F238E27FC236}">
-                <a16:creationId xmlns:a16="http://schemas.microsoft.com/office/drawing/2014/main" id="{13E0564E-F9B0-4496-83C8-C69F35B1CDC3}"/>
+                <a16:creationId xmlns:a16="http://schemas.microsoft.com/office/drawing/2014/main" id="{D356296C-DC21-4ABD-9E33-9A6458D029A8}"/>
               </a:ext>
             </a:extLst>
           </p:cNvPr>
@@ -7991,7 +7911,7 @@
           <p:cNvPr id="4" name="">
             <a:extLst xmlns:a="http://schemas.openxmlformats.org/drawingml/2006/main">
               <a:ext uri="{FF2B5EF4-FFF2-40B4-BE49-F238E27FC236}">
-                <a16:creationId xmlns:a16="http://schemas.microsoft.com/office/drawing/2014/main" id="{54F5A95C-18D7-4BDA-827D-B0B80A8FFFE7}"/>
+                <a16:creationId xmlns:a16="http://schemas.microsoft.com/office/drawing/2014/main" id="{EFDF0276-EA3A-4BEC-A558-EA6A9022654A}"/>
               </a:ext>
             </a:extLst>
           </p:cNvPr>
@@ -8055,7 +7975,7 @@
           <p:cNvPr id="5" name="">
             <a:extLst xmlns:a="http://schemas.openxmlformats.org/drawingml/2006/main">
               <a:ext uri="{FF2B5EF4-FFF2-40B4-BE49-F238E27FC236}">
-                <a16:creationId xmlns:a16="http://schemas.microsoft.com/office/drawing/2014/main" id="{5F367622-7F26-4DE5-9AF7-115F9AC9CEBC}"/>
+                <a16:creationId xmlns:a16="http://schemas.microsoft.com/office/drawing/2014/main" id="{CD517936-8A22-4D6D-8C79-AABC4454BD19}"/>
               </a:ext>
             </a:extLst>
           </p:cNvPr>
@@ -8119,7 +8039,7 @@
           <p:cNvPr id="6" name="">
             <a:extLst xmlns:a="http://schemas.openxmlformats.org/drawingml/2006/main">
               <a:ext uri="{FF2B5EF4-FFF2-40B4-BE49-F238E27FC236}">
-                <a16:creationId xmlns:a16="http://schemas.microsoft.com/office/drawing/2014/main" id="{53D4BBD9-3046-474A-A395-029DD2178880}"/>
+                <a16:creationId xmlns:a16="http://schemas.microsoft.com/office/drawing/2014/main" id="{66EAED3B-51FD-462D-AE49-4F415F983977}"/>
               </a:ext>
             </a:extLst>
           </p:cNvPr>
@@ -8152,7 +8072,7 @@
           <p:cNvPr id="7" name="">
             <a:extLst xmlns:a="http://schemas.openxmlformats.org/drawingml/2006/main">
               <a:ext uri="{FF2B5EF4-FFF2-40B4-BE49-F238E27FC236}">
-                <a16:creationId xmlns:a16="http://schemas.microsoft.com/office/drawing/2014/main" id="{D4212A40-28E4-4CE9-9FC2-3480144A24B4}"/>
+                <a16:creationId xmlns:a16="http://schemas.microsoft.com/office/drawing/2014/main" id="{A39C48D9-E4D7-49BE-A4EE-0170801724A7}"/>
               </a:ext>
             </a:extLst>
           </p:cNvPr>
@@ -8187,7 +8107,7 @@
           <p:cNvPr id="8" name="">
             <a:extLst xmlns:a="http://schemas.openxmlformats.org/drawingml/2006/main">
               <a:ext uri="{FF2B5EF4-FFF2-40B4-BE49-F238E27FC236}">
-                <a16:creationId xmlns:a16="http://schemas.microsoft.com/office/drawing/2014/main" id="{5E7B4BE2-2FAB-4753-A1C7-A01EB2C9BA4A}"/>
+                <a16:creationId xmlns:a16="http://schemas.microsoft.com/office/drawing/2014/main" id="{4AA000AD-DFBB-4E8B-B09F-A8DE76CE8FC2}"/>
               </a:ext>
             </a:extLst>
           </p:cNvPr>
@@ -8251,7 +8171,7 @@
           <p:cNvPr id="9" name="">
             <a:extLst xmlns:a="http://schemas.openxmlformats.org/drawingml/2006/main">
               <a:ext uri="{FF2B5EF4-FFF2-40B4-BE49-F238E27FC236}">
-                <a16:creationId xmlns:a16="http://schemas.microsoft.com/office/drawing/2014/main" id="{82EFBE59-5E61-4CF7-ADE6-75A6D0C6EA84}"/>
+                <a16:creationId xmlns:a16="http://schemas.microsoft.com/office/drawing/2014/main" id="{2922A0F4-26BF-41C6-A236-A4AD79131321}"/>
               </a:ext>
             </a:extLst>
           </p:cNvPr>
@@ -8315,7 +8235,7 @@
           <p:cNvPr id="10" name="">
             <a:extLst xmlns:a="http://schemas.openxmlformats.org/drawingml/2006/main">
               <a:ext uri="{FF2B5EF4-FFF2-40B4-BE49-F238E27FC236}">
-                <a16:creationId xmlns:a16="http://schemas.microsoft.com/office/drawing/2014/main" id="{8176F435-46F2-4F4E-BE59-C842937D0901}"/>
+                <a16:creationId xmlns:a16="http://schemas.microsoft.com/office/drawing/2014/main" id="{C6E721D6-45D5-4430-88A4-27DB0FA3782F}"/>
               </a:ext>
             </a:extLst>
           </p:cNvPr>
@@ -8350,7 +8270,7 @@
           <p:cNvPr id="11" name="">
             <a:extLst xmlns:a="http://schemas.openxmlformats.org/drawingml/2006/main">
               <a:ext uri="{FF2B5EF4-FFF2-40B4-BE49-F238E27FC236}">
-                <a16:creationId xmlns:a16="http://schemas.microsoft.com/office/drawing/2014/main" id="{F8DAAD6A-DA31-418E-B6BE-F3A360565872}"/>
+                <a16:creationId xmlns:a16="http://schemas.microsoft.com/office/drawing/2014/main" id="{38C53E29-DE11-4858-A1E2-F75D1DAE7A28}"/>
               </a:ext>
             </a:extLst>
           </p:cNvPr>
@@ -8383,7 +8303,7 @@
           <p:cNvPr id="12" name="">
             <a:extLst xmlns:a="http://schemas.openxmlformats.org/drawingml/2006/main">
               <a:ext uri="{FF2B5EF4-FFF2-40B4-BE49-F238E27FC236}">
-                <a16:creationId xmlns:a16="http://schemas.microsoft.com/office/drawing/2014/main" id="{AFA32376-A3C4-422C-85A9-0785B3430A19}"/>
+                <a16:creationId xmlns:a16="http://schemas.microsoft.com/office/drawing/2014/main" id="{4D31BDE2-D009-44B7-9528-A5457B86368B}"/>
               </a:ext>
             </a:extLst>
           </p:cNvPr>
@@ -8416,7 +8336,7 @@
           <p:cNvPr id="13" name="">
             <a:extLst xmlns:a="http://schemas.openxmlformats.org/drawingml/2006/main">
               <a:ext uri="{FF2B5EF4-FFF2-40B4-BE49-F238E27FC236}">
-                <a16:creationId xmlns:a16="http://schemas.microsoft.com/office/drawing/2014/main" id="{E769B64B-73C8-41F3-A9A2-C4F76E8E0E0F}"/>
+                <a16:creationId xmlns:a16="http://schemas.microsoft.com/office/drawing/2014/main" id="{12729759-E7DC-435C-8A93-04B9EE8ED618}"/>
               </a:ext>
             </a:extLst>
           </p:cNvPr>
@@ -8451,7 +8371,7 @@
           <p:cNvPr id="14" name="">
             <a:extLst xmlns:a="http://schemas.openxmlformats.org/drawingml/2006/main">
               <a:ext uri="{FF2B5EF4-FFF2-40B4-BE49-F238E27FC236}">
-                <a16:creationId xmlns:a16="http://schemas.microsoft.com/office/drawing/2014/main" id="{72532896-5A11-442D-A8E5-9E78B71A7CBF}"/>
+                <a16:creationId xmlns:a16="http://schemas.microsoft.com/office/drawing/2014/main" id="{6D27E321-334D-4788-B828-0DE90FDC032A}"/>
               </a:ext>
             </a:extLst>
           </p:cNvPr>
@@ -8515,7 +8435,7 @@
           <p:cNvPr id="15" name="">
             <a:extLst xmlns:a="http://schemas.openxmlformats.org/drawingml/2006/main">
               <a:ext uri="{FF2B5EF4-FFF2-40B4-BE49-F238E27FC236}">
-                <a16:creationId xmlns:a16="http://schemas.microsoft.com/office/drawing/2014/main" id="{B0CDA57C-DB61-4B5A-8896-6CE9075AF78E}"/>
+                <a16:creationId xmlns:a16="http://schemas.microsoft.com/office/drawing/2014/main" id="{E67B5021-D24F-4191-8A40-F5B77F00F2B9}"/>
               </a:ext>
             </a:extLst>
           </p:cNvPr>
@@ -8579,7 +8499,7 @@
           <p:cNvPr id="16" name="">
             <a:extLst xmlns:a="http://schemas.openxmlformats.org/drawingml/2006/main">
               <a:ext uri="{FF2B5EF4-FFF2-40B4-BE49-F238E27FC236}">
-                <a16:creationId xmlns:a16="http://schemas.microsoft.com/office/drawing/2014/main" id="{86A06EE1-EC6F-4665-B9E9-B275F47D1935}"/>
+                <a16:creationId xmlns:a16="http://schemas.microsoft.com/office/drawing/2014/main" id="{637863E8-B796-4D89-957D-21D8CEEB51C1}"/>
               </a:ext>
             </a:extLst>
           </p:cNvPr>
@@ -8614,7 +8534,7 @@
           <p:cNvPr id="17" name="">
             <a:extLst xmlns:a="http://schemas.openxmlformats.org/drawingml/2006/main">
               <a:ext uri="{FF2B5EF4-FFF2-40B4-BE49-F238E27FC236}">
-                <a16:creationId xmlns:a16="http://schemas.microsoft.com/office/drawing/2014/main" id="{49E7BC44-5CB0-40AA-ADCA-1E282A81400B}"/>
+                <a16:creationId xmlns:a16="http://schemas.microsoft.com/office/drawing/2014/main" id="{1840894A-9D8E-4216-B8CF-FF84112A8190}"/>
               </a:ext>
             </a:extLst>
           </p:cNvPr>
@@ -8647,7 +8567,7 @@
           <p:cNvPr id="18" name="">
             <a:extLst xmlns:a="http://schemas.openxmlformats.org/drawingml/2006/main">
               <a:ext uri="{FF2B5EF4-FFF2-40B4-BE49-F238E27FC236}">
-                <a16:creationId xmlns:a16="http://schemas.microsoft.com/office/drawing/2014/main" id="{F9A6DB38-7C86-4ADE-B1A9-D69490A04A8B}"/>
+                <a16:creationId xmlns:a16="http://schemas.microsoft.com/office/drawing/2014/main" id="{4E8F62C1-E387-43D8-A82A-0633030F522F}"/>
               </a:ext>
             </a:extLst>
           </p:cNvPr>
@@ -8680,7 +8600,7 @@
           <p:cNvPr id="19" name="">
             <a:extLst xmlns:a="http://schemas.openxmlformats.org/drawingml/2006/main">
               <a:ext uri="{FF2B5EF4-FFF2-40B4-BE49-F238E27FC236}">
-                <a16:creationId xmlns:a16="http://schemas.microsoft.com/office/drawing/2014/main" id="{1FE079B7-06B4-4C57-8CE7-1BA34237723A}"/>
+                <a16:creationId xmlns:a16="http://schemas.microsoft.com/office/drawing/2014/main" id="{6C48260E-80F8-418A-94E1-A4464EE6ADC0}"/>
               </a:ext>
             </a:extLst>
           </p:cNvPr>
@@ -8715,7 +8635,7 @@
           <p:cNvPr id="20" name="">
             <a:extLst xmlns:a="http://schemas.openxmlformats.org/drawingml/2006/main">
               <a:ext uri="{FF2B5EF4-FFF2-40B4-BE49-F238E27FC236}">
-                <a16:creationId xmlns:a16="http://schemas.microsoft.com/office/drawing/2014/main" id="{5744FF77-BAAA-49CC-A433-5D33832DA69A}"/>
+                <a16:creationId xmlns:a16="http://schemas.microsoft.com/office/drawing/2014/main" id="{98B2E359-6676-4E86-A3B7-3976CF4E1DD5}"/>
               </a:ext>
             </a:extLst>
           </p:cNvPr>
@@ -8779,7 +8699,7 @@
           <p:cNvPr id="21" name="">
             <a:extLst xmlns:a="http://schemas.openxmlformats.org/drawingml/2006/main">
               <a:ext uri="{FF2B5EF4-FFF2-40B4-BE49-F238E27FC236}">
-                <a16:creationId xmlns:a16="http://schemas.microsoft.com/office/drawing/2014/main" id="{FC92CC2A-87BD-4CBF-95E2-96F47B18D1E1}"/>
+                <a16:creationId xmlns:a16="http://schemas.microsoft.com/office/drawing/2014/main" id="{7763A68F-5860-416B-A39B-AE145D6FD2D4}"/>
               </a:ext>
             </a:extLst>
           </p:cNvPr>
@@ -8843,7 +8763,7 @@
           <p:cNvPr id="22" name="">
             <a:extLst xmlns:a="http://schemas.openxmlformats.org/drawingml/2006/main">
               <a:ext uri="{FF2B5EF4-FFF2-40B4-BE49-F238E27FC236}">
-                <a16:creationId xmlns:a16="http://schemas.microsoft.com/office/drawing/2014/main" id="{64A80758-C409-4172-8C34-C64DBC581FC4}"/>
+                <a16:creationId xmlns:a16="http://schemas.microsoft.com/office/drawing/2014/main" id="{039AE5DF-C427-47DF-B851-8BA5B3814735}"/>
               </a:ext>
             </a:extLst>
           </p:cNvPr>
@@ -8878,7 +8798,7 @@
           <p:cNvPr id="23" name="">
             <a:extLst xmlns:a="http://schemas.openxmlformats.org/drawingml/2006/main">
               <a:ext uri="{FF2B5EF4-FFF2-40B4-BE49-F238E27FC236}">
-                <a16:creationId xmlns:a16="http://schemas.microsoft.com/office/drawing/2014/main" id="{DB906730-4A27-4F96-A183-44222D60E3CC}"/>
+                <a16:creationId xmlns:a16="http://schemas.microsoft.com/office/drawing/2014/main" id="{6A8BE8F1-DFDD-42C3-AA3B-3918115A6D9C}"/>
               </a:ext>
             </a:extLst>
           </p:cNvPr>
@@ -8911,7 +8831,7 @@
           <p:cNvPr id="24" name="">
             <a:extLst xmlns:a="http://schemas.openxmlformats.org/drawingml/2006/main">
               <a:ext uri="{FF2B5EF4-FFF2-40B4-BE49-F238E27FC236}">
-                <a16:creationId xmlns:a16="http://schemas.microsoft.com/office/drawing/2014/main" id="{F843C2D9-8350-4017-8DD8-8D43A0EC6E58}"/>
+                <a16:creationId xmlns:a16="http://schemas.microsoft.com/office/drawing/2014/main" id="{C94F4941-81CA-4AC2-A8F0-515E9FC24405}"/>
               </a:ext>
             </a:extLst>
           </p:cNvPr>
@@ -8944,7 +8864,7 @@
           <p:cNvPr id="25" name="">
             <a:extLst xmlns:a="http://schemas.openxmlformats.org/drawingml/2006/main">
               <a:ext uri="{FF2B5EF4-FFF2-40B4-BE49-F238E27FC236}">
-                <a16:creationId xmlns:a16="http://schemas.microsoft.com/office/drawing/2014/main" id="{54B7C3D2-6113-4EBE-B13C-571F14EF128D}"/>
+                <a16:creationId xmlns:a16="http://schemas.microsoft.com/office/drawing/2014/main" id="{D7D12FBE-830F-4EDE-BFED-1542ACDE21F1}"/>
               </a:ext>
             </a:extLst>
           </p:cNvPr>
@@ -8979,7 +8899,7 @@
           <p:cNvPr id="26" name="">
             <a:extLst xmlns:a="http://schemas.openxmlformats.org/drawingml/2006/main">
               <a:ext uri="{FF2B5EF4-FFF2-40B4-BE49-F238E27FC236}">
-                <a16:creationId xmlns:a16="http://schemas.microsoft.com/office/drawing/2014/main" id="{D222B52B-1ED5-4CF2-B98D-EFFF44AD1359}"/>
+                <a16:creationId xmlns:a16="http://schemas.microsoft.com/office/drawing/2014/main" id="{C20F263F-0E53-4375-8544-00237CA853E9}"/>
               </a:ext>
             </a:extLst>
           </p:cNvPr>
@@ -9043,7 +8963,7 @@
           <p:cNvPr id="27" name="">
             <a:extLst xmlns:a="http://schemas.openxmlformats.org/drawingml/2006/main">
               <a:ext uri="{FF2B5EF4-FFF2-40B4-BE49-F238E27FC236}">
-                <a16:creationId xmlns:a16="http://schemas.microsoft.com/office/drawing/2014/main" id="{8312A81C-10E4-4829-87A4-44A76D3B3ECF}"/>
+                <a16:creationId xmlns:a16="http://schemas.microsoft.com/office/drawing/2014/main" id="{052796BF-A1C7-4F52-83A4-B595C6237992}"/>
               </a:ext>
             </a:extLst>
           </p:cNvPr>
@@ -9107,7 +9027,7 @@
           <p:cNvPr id="28" name="">
             <a:extLst xmlns:a="http://schemas.openxmlformats.org/drawingml/2006/main">
               <a:ext uri="{FF2B5EF4-FFF2-40B4-BE49-F238E27FC236}">
-                <a16:creationId xmlns:a16="http://schemas.microsoft.com/office/drawing/2014/main" id="{5813E5C0-D6AF-40D3-9122-286E5B57D51F}"/>
+                <a16:creationId xmlns:a16="http://schemas.microsoft.com/office/drawing/2014/main" id="{00B4A54A-66CD-4D8B-BE3D-DBB6CEAC0929}"/>
               </a:ext>
             </a:extLst>
           </p:cNvPr>
@@ -9142,7 +9062,7 @@
           <p:cNvPr id="29" name="">
             <a:extLst xmlns:a="http://schemas.openxmlformats.org/drawingml/2006/main">
               <a:ext uri="{FF2B5EF4-FFF2-40B4-BE49-F238E27FC236}">
-                <a16:creationId xmlns:a16="http://schemas.microsoft.com/office/drawing/2014/main" id="{18480012-57A9-41B6-8C4F-0E805746E0F8}"/>
+                <a16:creationId xmlns:a16="http://schemas.microsoft.com/office/drawing/2014/main" id="{F82208BC-9DD3-4565-A755-DB6793C9C876}"/>
               </a:ext>
             </a:extLst>
           </p:cNvPr>
@@ -9175,7 +9095,7 @@
           <p:cNvPr id="30" name="">
             <a:extLst xmlns:a="http://schemas.openxmlformats.org/drawingml/2006/main">
               <a:ext uri="{FF2B5EF4-FFF2-40B4-BE49-F238E27FC236}">
-                <a16:creationId xmlns:a16="http://schemas.microsoft.com/office/drawing/2014/main" id="{78651047-FA8E-4D2E-B872-F1A8E91AA7C1}"/>
+                <a16:creationId xmlns:a16="http://schemas.microsoft.com/office/drawing/2014/main" id="{A4C0303A-582C-4FDE-9642-68C7D352412D}"/>
               </a:ext>
             </a:extLst>
           </p:cNvPr>
@@ -9208,7 +9128,7 @@
           <p:cNvPr id="31" name="">
             <a:extLst xmlns:a="http://schemas.openxmlformats.org/drawingml/2006/main">
               <a:ext uri="{FF2B5EF4-FFF2-40B4-BE49-F238E27FC236}">
-                <a16:creationId xmlns:a16="http://schemas.microsoft.com/office/drawing/2014/main" id="{8330DBEE-C118-4F8A-8E62-69EB9EB47C4D}"/>
+                <a16:creationId xmlns:a16="http://schemas.microsoft.com/office/drawing/2014/main" id="{4DF1C88D-B699-4F32-99A4-A830137AD224}"/>
               </a:ext>
             </a:extLst>
           </p:cNvPr>
@@ -9243,7 +9163,7 @@
           <p:cNvPr id="32" name="">
             <a:extLst xmlns:a="http://schemas.openxmlformats.org/drawingml/2006/main">
               <a:ext uri="{FF2B5EF4-FFF2-40B4-BE49-F238E27FC236}">
-                <a16:creationId xmlns:a16="http://schemas.microsoft.com/office/drawing/2014/main" id="{A90DAED7-64CB-4FA4-BFD8-2C1394F9D5E1}"/>
+                <a16:creationId xmlns:a16="http://schemas.microsoft.com/office/drawing/2014/main" id="{12C6FA96-B22F-4CCF-9BC8-A2A0E5D7FF30}"/>
               </a:ext>
             </a:extLst>
           </p:cNvPr>
@@ -9307,7 +9227,7 @@
           <p:cNvPr id="33" name="">
             <a:extLst xmlns:a="http://schemas.openxmlformats.org/drawingml/2006/main">
               <a:ext uri="{FF2B5EF4-FFF2-40B4-BE49-F238E27FC236}">
-                <a16:creationId xmlns:a16="http://schemas.microsoft.com/office/drawing/2014/main" id="{0EE163DC-DE71-4F21-A9F8-F4F569A923A7}"/>
+                <a16:creationId xmlns:a16="http://schemas.microsoft.com/office/drawing/2014/main" id="{15067894-E355-41F8-976A-424AD195B0E3}"/>
               </a:ext>
             </a:extLst>
           </p:cNvPr>
@@ -9371,7 +9291,7 @@
           <p:cNvPr id="34" name="">
             <a:extLst xmlns:a="http://schemas.openxmlformats.org/drawingml/2006/main">
               <a:ext uri="{FF2B5EF4-FFF2-40B4-BE49-F238E27FC236}">
-                <a16:creationId xmlns:a16="http://schemas.microsoft.com/office/drawing/2014/main" id="{E1B78BCD-B295-42A4-969F-4DF7E57806C7}"/>
+                <a16:creationId xmlns:a16="http://schemas.microsoft.com/office/drawing/2014/main" id="{D398BC45-8B2A-4317-A20F-9F073762E5ED}"/>
               </a:ext>
             </a:extLst>
           </p:cNvPr>
@@ -9435,7 +9355,7 @@
           <p:cNvPr id="35" name="">
             <a:extLst xmlns:a="http://schemas.openxmlformats.org/drawingml/2006/main">
               <a:ext uri="{FF2B5EF4-FFF2-40B4-BE49-F238E27FC236}">
-                <a16:creationId xmlns:a16="http://schemas.microsoft.com/office/drawing/2014/main" id="{E8416EBD-AD24-415F-A2CB-7734609E29CE}"/>
+                <a16:creationId xmlns:a16="http://schemas.microsoft.com/office/drawing/2014/main" id="{ED12D38B-4218-4C55-A236-D47C3655E0B5}"/>
               </a:ext>
             </a:extLst>
           </p:cNvPr>
@@ -9499,7 +9419,7 @@
           <p:cNvPr id="36" name="">
             <a:extLst xmlns:a="http://schemas.openxmlformats.org/drawingml/2006/main">
               <a:ext uri="{FF2B5EF4-FFF2-40B4-BE49-F238E27FC236}">
-                <a16:creationId xmlns:a16="http://schemas.microsoft.com/office/drawing/2014/main" id="{F5379D12-FB81-4F2E-AFCA-B8EF496FDF69}"/>
+                <a16:creationId xmlns:a16="http://schemas.microsoft.com/office/drawing/2014/main" id="{D47F1089-6702-4CD4-A64A-98766FE6C09A}"/>
               </a:ext>
             </a:extLst>
           </p:cNvPr>
@@ -9563,7 +9483,7 @@
           <p:cNvPr id="37" name="">
             <a:extLst xmlns:a="http://schemas.openxmlformats.org/drawingml/2006/main">
               <a:ext uri="{FF2B5EF4-FFF2-40B4-BE49-F238E27FC236}">
-                <a16:creationId xmlns:a16="http://schemas.microsoft.com/office/drawing/2014/main" id="{A3EEB95E-B2DB-46E7-BCC2-CB13619A5954}"/>
+                <a16:creationId xmlns:a16="http://schemas.microsoft.com/office/drawing/2014/main" id="{2A430726-BB30-477F-8F1A-3E09E04137CD}"/>
               </a:ext>
             </a:extLst>
           </p:cNvPr>
@@ -9625,7 +9545,7 @@
     </p:spTree>
     <p:extLst>
       <p:ext uri="{BB962C8B-B14F-4D97-AF65-F5344CB8AC3E}">
-        <p14:creationId xmlns:p14="http://schemas.microsoft.com/office/powerpoint/2010/main" val="1976648794"/>
+        <p14:creationId xmlns:p14="http://schemas.microsoft.com/office/powerpoint/2010/main" val="1339283403"/>
       </p:ext>
     </p:extLst>
   </p:cSld>
@@ -9649,7 +9569,7 @@
           <p:cNvPr id="1" name="">
             <a:extLst xmlns:a="http://schemas.openxmlformats.org/drawingml/2006/main">
               <a:ext uri="{FF2B5EF4-FFF2-40B4-BE49-F238E27FC236}">
-                <a16:creationId xmlns:a16="http://schemas.microsoft.com/office/drawing/2014/main" id="{BDC53711-E2BC-4C75-AE53-7A09DD705AEE}"/>
+                <a16:creationId xmlns:a16="http://schemas.microsoft.com/office/drawing/2014/main" id="{A453AABF-BDC6-4549-A068-F1BD6AD390DB}"/>
               </a:ext>
             </a:extLst>
           </p:cNvPr>
@@ -9684,7 +9604,7 @@
           <p:cNvPr id="2" name="">
             <a:extLst xmlns:a="http://schemas.openxmlformats.org/drawingml/2006/main">
               <a:ext uri="{FF2B5EF4-FFF2-40B4-BE49-F238E27FC236}">
-                <a16:creationId xmlns:a16="http://schemas.microsoft.com/office/drawing/2014/main" id="{0D5F9BB8-2444-46B7-AB98-EE1420BBD50E}"/>
+                <a16:creationId xmlns:a16="http://schemas.microsoft.com/office/drawing/2014/main" id="{3762817E-184F-4D26-A144-93B629EE0148}"/>
               </a:ext>
             </a:extLst>
           </p:cNvPr>
@@ -9719,7 +9639,7 @@
           <p:cNvPr id="3" name="">
             <a:extLst xmlns:a="http://schemas.openxmlformats.org/drawingml/2006/main">
               <a:ext uri="{FF2B5EF4-FFF2-40B4-BE49-F238E27FC236}">
-                <a16:creationId xmlns:a16="http://schemas.microsoft.com/office/drawing/2014/main" id="{71FBEADC-6B60-499A-A50C-6032171551C6}"/>
+                <a16:creationId xmlns:a16="http://schemas.microsoft.com/office/drawing/2014/main" id="{0A5E8001-13B7-4156-9030-635988F55AD4}"/>
               </a:ext>
             </a:extLst>
           </p:cNvPr>
@@ -9754,7 +9674,7 @@
           <p:cNvPr id="4" name="">
             <a:extLst xmlns:a="http://schemas.openxmlformats.org/drawingml/2006/main">
               <a:ext uri="{FF2B5EF4-FFF2-40B4-BE49-F238E27FC236}">
-                <a16:creationId xmlns:a16="http://schemas.microsoft.com/office/drawing/2014/main" id="{B6B68CE0-2208-4F53-8A77-91686437B214}"/>
+                <a16:creationId xmlns:a16="http://schemas.microsoft.com/office/drawing/2014/main" id="{67AB0E54-5772-4847-B6DD-965F8A1AF3CA}"/>
               </a:ext>
             </a:extLst>
           </p:cNvPr>
@@ -9818,7 +9738,7 @@
           <p:cNvPr id="5" name="">
             <a:extLst xmlns:a="http://schemas.openxmlformats.org/drawingml/2006/main">
               <a:ext uri="{FF2B5EF4-FFF2-40B4-BE49-F238E27FC236}">
-                <a16:creationId xmlns:a16="http://schemas.microsoft.com/office/drawing/2014/main" id="{D7B47D92-97DF-47EB-B666-088972D87016}"/>
+                <a16:creationId xmlns:a16="http://schemas.microsoft.com/office/drawing/2014/main" id="{EB30240B-4C18-4CD5-ABDC-E83F91EA58B1}"/>
               </a:ext>
             </a:extLst>
           </p:cNvPr>
@@ -9882,7 +9802,7 @@
           <p:cNvPr id="6" name="">
             <a:extLst xmlns:a="http://schemas.openxmlformats.org/drawingml/2006/main">
               <a:ext uri="{FF2B5EF4-FFF2-40B4-BE49-F238E27FC236}">
-                <a16:creationId xmlns:a16="http://schemas.microsoft.com/office/drawing/2014/main" id="{61E7EEC7-1270-4928-9743-C6027ED04697}"/>
+                <a16:creationId xmlns:a16="http://schemas.microsoft.com/office/drawing/2014/main" id="{B519ADDE-9646-46EB-8EAE-619E3F4761FD}"/>
               </a:ext>
             </a:extLst>
           </p:cNvPr>
@@ -9915,7 +9835,7 @@
           <p:cNvPr id="7" name="">
             <a:extLst xmlns:a="http://schemas.openxmlformats.org/drawingml/2006/main">
               <a:ext uri="{FF2B5EF4-FFF2-40B4-BE49-F238E27FC236}">
-                <a16:creationId xmlns:a16="http://schemas.microsoft.com/office/drawing/2014/main" id="{4239AA3D-BE86-4D91-B41A-763C4415151F}"/>
+                <a16:creationId xmlns:a16="http://schemas.microsoft.com/office/drawing/2014/main" id="{546F0FEC-BFF2-46D1-9F40-89DE417DB27B}"/>
               </a:ext>
             </a:extLst>
           </p:cNvPr>
@@ -9950,7 +9870,7 @@
           <p:cNvPr id="8" name="">
             <a:extLst xmlns:a="http://schemas.openxmlformats.org/drawingml/2006/main">
               <a:ext uri="{FF2B5EF4-FFF2-40B4-BE49-F238E27FC236}">
-                <a16:creationId xmlns:a16="http://schemas.microsoft.com/office/drawing/2014/main" id="{71C245B9-3B05-4966-9B51-94ADFD03F89E}"/>
+                <a16:creationId xmlns:a16="http://schemas.microsoft.com/office/drawing/2014/main" id="{D5580718-E931-4EFD-892E-E7595A03AA7F}"/>
               </a:ext>
             </a:extLst>
           </p:cNvPr>
@@ -10014,7 +9934,7 @@
           <p:cNvPr id="9" name="">
             <a:extLst xmlns:a="http://schemas.openxmlformats.org/drawingml/2006/main">
               <a:ext uri="{FF2B5EF4-FFF2-40B4-BE49-F238E27FC236}">
-                <a16:creationId xmlns:a16="http://schemas.microsoft.com/office/drawing/2014/main" id="{1CFB260B-2005-4243-BDA0-0F5B64B3C2EF}"/>
+                <a16:creationId xmlns:a16="http://schemas.microsoft.com/office/drawing/2014/main" id="{FDDCFE92-0172-42FA-8910-225CE87146AC}"/>
               </a:ext>
             </a:extLst>
           </p:cNvPr>
@@ -10124,7 +10044,7 @@
           <p:cNvPr id="10" name="">
             <a:extLst xmlns:a="http://schemas.openxmlformats.org/drawingml/2006/main">
               <a:ext uri="{FF2B5EF4-FFF2-40B4-BE49-F238E27FC236}">
-                <a16:creationId xmlns:a16="http://schemas.microsoft.com/office/drawing/2014/main" id="{A4854A9F-ADE5-4741-AEB0-339898DACCB1}"/>
+                <a16:creationId xmlns:a16="http://schemas.microsoft.com/office/drawing/2014/main" id="{11A44467-BEE3-436F-B52B-C2D1D83A63FC}"/>
               </a:ext>
             </a:extLst>
           </p:cNvPr>
@@ -10159,7 +10079,7 @@
           <p:cNvPr id="11" name="">
             <a:extLst xmlns:a="http://schemas.openxmlformats.org/drawingml/2006/main">
               <a:ext uri="{FF2B5EF4-FFF2-40B4-BE49-F238E27FC236}">
-                <a16:creationId xmlns:a16="http://schemas.microsoft.com/office/drawing/2014/main" id="{1D8C57C6-1FAF-40D6-A7C0-BECBA92864CA}"/>
+                <a16:creationId xmlns:a16="http://schemas.microsoft.com/office/drawing/2014/main" id="{7956CC6E-3F03-4D34-A210-5624CD172FFC}"/>
               </a:ext>
             </a:extLst>
           </p:cNvPr>
@@ -10192,7 +10112,7 @@
           <p:cNvPr id="12" name="">
             <a:extLst xmlns:a="http://schemas.openxmlformats.org/drawingml/2006/main">
               <a:ext uri="{FF2B5EF4-FFF2-40B4-BE49-F238E27FC236}">
-                <a16:creationId xmlns:a16="http://schemas.microsoft.com/office/drawing/2014/main" id="{0EA8097A-026E-402C-8EF1-23F602F278B5}"/>
+                <a16:creationId xmlns:a16="http://schemas.microsoft.com/office/drawing/2014/main" id="{1C4ECF0D-9C50-4434-82F7-ABE30DECDD11}"/>
               </a:ext>
             </a:extLst>
           </p:cNvPr>
@@ -10225,7 +10145,7 @@
           <p:cNvPr id="13" name="">
             <a:extLst xmlns:a="http://schemas.openxmlformats.org/drawingml/2006/main">
               <a:ext uri="{FF2B5EF4-FFF2-40B4-BE49-F238E27FC236}">
-                <a16:creationId xmlns:a16="http://schemas.microsoft.com/office/drawing/2014/main" id="{FAAA28E0-0628-4A59-8418-37FF6ECADB18}"/>
+                <a16:creationId xmlns:a16="http://schemas.microsoft.com/office/drawing/2014/main" id="{5912BA84-DB5D-481B-A8C0-0BB11EC24715}"/>
               </a:ext>
             </a:extLst>
           </p:cNvPr>
@@ -10260,7 +10180,7 @@
           <p:cNvPr id="14" name="">
             <a:extLst xmlns:a="http://schemas.openxmlformats.org/drawingml/2006/main">
               <a:ext uri="{FF2B5EF4-FFF2-40B4-BE49-F238E27FC236}">
-                <a16:creationId xmlns:a16="http://schemas.microsoft.com/office/drawing/2014/main" id="{B5D4BDBD-20BC-429C-A207-F6A673AF543D}"/>
+                <a16:creationId xmlns:a16="http://schemas.microsoft.com/office/drawing/2014/main" id="{FF1A473C-ABE3-4058-B9B4-AFA4FA509B45}"/>
               </a:ext>
             </a:extLst>
           </p:cNvPr>
@@ -10324,7 +10244,7 @@
           <p:cNvPr id="15" name="">
             <a:extLst xmlns:a="http://schemas.openxmlformats.org/drawingml/2006/main">
               <a:ext uri="{FF2B5EF4-FFF2-40B4-BE49-F238E27FC236}">
-                <a16:creationId xmlns:a16="http://schemas.microsoft.com/office/drawing/2014/main" id="{1A11050E-8FEA-40D5-882C-83DCBBB714EA}"/>
+                <a16:creationId xmlns:a16="http://schemas.microsoft.com/office/drawing/2014/main" id="{6405F97D-84EE-46CD-B40C-A9F35086E1D9}"/>
               </a:ext>
             </a:extLst>
           </p:cNvPr>
@@ -10434,7 +10354,7 @@
           <p:cNvPr id="16" name="">
             <a:extLst xmlns:a="http://schemas.openxmlformats.org/drawingml/2006/main">
               <a:ext uri="{FF2B5EF4-FFF2-40B4-BE49-F238E27FC236}">
-                <a16:creationId xmlns:a16="http://schemas.microsoft.com/office/drawing/2014/main" id="{3A339951-1C5E-42FF-BDC9-7A3A44E96D31}"/>
+                <a16:creationId xmlns:a16="http://schemas.microsoft.com/office/drawing/2014/main" id="{A9AB1F65-861A-496C-91E2-D29D65694A54}"/>
               </a:ext>
             </a:extLst>
           </p:cNvPr>
@@ -10469,7 +10389,7 @@
           <p:cNvPr id="17" name="">
             <a:extLst xmlns:a="http://schemas.openxmlformats.org/drawingml/2006/main">
               <a:ext uri="{FF2B5EF4-FFF2-40B4-BE49-F238E27FC236}">
-                <a16:creationId xmlns:a16="http://schemas.microsoft.com/office/drawing/2014/main" id="{0667BC08-925F-46ED-975E-0FF51E5D8F1C}"/>
+                <a16:creationId xmlns:a16="http://schemas.microsoft.com/office/drawing/2014/main" id="{A895E136-DAD3-4A31-BDC0-C081D2480CFB}"/>
               </a:ext>
             </a:extLst>
           </p:cNvPr>
@@ -10502,7 +10422,7 @@
           <p:cNvPr id="18" name="">
             <a:extLst xmlns:a="http://schemas.openxmlformats.org/drawingml/2006/main">
               <a:ext uri="{FF2B5EF4-FFF2-40B4-BE49-F238E27FC236}">
-                <a16:creationId xmlns:a16="http://schemas.microsoft.com/office/drawing/2014/main" id="{824D45A2-DB09-4842-9697-EA5467B48E7A}"/>
+                <a16:creationId xmlns:a16="http://schemas.microsoft.com/office/drawing/2014/main" id="{E05B451F-489D-436B-981E-35F69C91641C}"/>
               </a:ext>
             </a:extLst>
           </p:cNvPr>
@@ -10535,7 +10455,7 @@
           <p:cNvPr id="19" name="">
             <a:extLst xmlns:a="http://schemas.openxmlformats.org/drawingml/2006/main">
               <a:ext uri="{FF2B5EF4-FFF2-40B4-BE49-F238E27FC236}">
-                <a16:creationId xmlns:a16="http://schemas.microsoft.com/office/drawing/2014/main" id="{B92D0892-02A8-4AB8-9216-8220763BC079}"/>
+                <a16:creationId xmlns:a16="http://schemas.microsoft.com/office/drawing/2014/main" id="{57BFE193-CC12-46FA-8C2C-46D2E8FAAF08}"/>
               </a:ext>
             </a:extLst>
           </p:cNvPr>
@@ -10570,7 +10490,7 @@
           <p:cNvPr id="20" name="">
             <a:extLst xmlns:a="http://schemas.openxmlformats.org/drawingml/2006/main">
               <a:ext uri="{FF2B5EF4-FFF2-40B4-BE49-F238E27FC236}">
-                <a16:creationId xmlns:a16="http://schemas.microsoft.com/office/drawing/2014/main" id="{E5669A87-0CE3-4EDC-8BFC-161A2003EB36}"/>
+                <a16:creationId xmlns:a16="http://schemas.microsoft.com/office/drawing/2014/main" id="{34DC651E-DCBF-4570-8825-2B981E83ABEA}"/>
               </a:ext>
             </a:extLst>
           </p:cNvPr>
@@ -10634,7 +10554,7 @@
           <p:cNvPr id="21" name="">
             <a:extLst xmlns:a="http://schemas.openxmlformats.org/drawingml/2006/main">
               <a:ext uri="{FF2B5EF4-FFF2-40B4-BE49-F238E27FC236}">
-                <a16:creationId xmlns:a16="http://schemas.microsoft.com/office/drawing/2014/main" id="{8DD9E184-0810-45CF-B22A-EB5F232175D9}"/>
+                <a16:creationId xmlns:a16="http://schemas.microsoft.com/office/drawing/2014/main" id="{7DB12D1A-CCE1-4D41-B3A1-90467EF8DF66}"/>
               </a:ext>
             </a:extLst>
           </p:cNvPr>
@@ -10744,7 +10664,7 @@
           <p:cNvPr id="22" name="">
             <a:extLst xmlns:a="http://schemas.openxmlformats.org/drawingml/2006/main">
               <a:ext uri="{FF2B5EF4-FFF2-40B4-BE49-F238E27FC236}">
-                <a16:creationId xmlns:a16="http://schemas.microsoft.com/office/drawing/2014/main" id="{36A47D37-F392-422D-9F01-2B42EFEC8D8C}"/>
+                <a16:creationId xmlns:a16="http://schemas.microsoft.com/office/drawing/2014/main" id="{2F2A5C5D-6C59-4D50-B02B-285DA6A649E6}"/>
               </a:ext>
             </a:extLst>
           </p:cNvPr>
@@ -10777,7 +10697,7 @@
           <p:cNvPr id="23" name="">
             <a:extLst xmlns:a="http://schemas.openxmlformats.org/drawingml/2006/main">
               <a:ext uri="{FF2B5EF4-FFF2-40B4-BE49-F238E27FC236}">
-                <a16:creationId xmlns:a16="http://schemas.microsoft.com/office/drawing/2014/main" id="{C172ADDC-85DB-4916-8ED3-79DF5BFCB923}"/>
+                <a16:creationId xmlns:a16="http://schemas.microsoft.com/office/drawing/2014/main" id="{AB7AC28D-A6C9-48B5-A5EE-A3C98E1B5725}"/>
               </a:ext>
             </a:extLst>
           </p:cNvPr>
@@ -10812,7 +10732,7 @@
           <p:cNvPr id="24" name="">
             <a:extLst xmlns:a="http://schemas.openxmlformats.org/drawingml/2006/main">
               <a:ext uri="{FF2B5EF4-FFF2-40B4-BE49-F238E27FC236}">
-                <a16:creationId xmlns:a16="http://schemas.microsoft.com/office/drawing/2014/main" id="{AA01D517-87DA-411F-9440-2E7A2CDC984B}"/>
+                <a16:creationId xmlns:a16="http://schemas.microsoft.com/office/drawing/2014/main" id="{3E31464E-A85E-4D18-B997-3436E56BF6A3}"/>
               </a:ext>
             </a:extLst>
           </p:cNvPr>
@@ -10876,7 +10796,7 @@
           <p:cNvPr id="25" name="">
             <a:extLst xmlns:a="http://schemas.openxmlformats.org/drawingml/2006/main">
               <a:ext uri="{FF2B5EF4-FFF2-40B4-BE49-F238E27FC236}">
-                <a16:creationId xmlns:a16="http://schemas.microsoft.com/office/drawing/2014/main" id="{2E4245B2-DC20-4E88-A413-8CAB65837381}"/>
+                <a16:creationId xmlns:a16="http://schemas.microsoft.com/office/drawing/2014/main" id="{2A7CC80F-D6AD-4D32-90EF-B4FC03A6EDD6}"/>
               </a:ext>
             </a:extLst>
           </p:cNvPr>
@@ -10940,7 +10860,7 @@
           <p:cNvPr id="26" name="">
             <a:extLst xmlns:a="http://schemas.openxmlformats.org/drawingml/2006/main">
               <a:ext uri="{FF2B5EF4-FFF2-40B4-BE49-F238E27FC236}">
-                <a16:creationId xmlns:a16="http://schemas.microsoft.com/office/drawing/2014/main" id="{35D447E6-4A4D-47A6-B1C5-7804490EE817}"/>
+                <a16:creationId xmlns:a16="http://schemas.microsoft.com/office/drawing/2014/main" id="{760581C3-5D48-470A-BC86-8F8CB9D98D04}"/>
               </a:ext>
             </a:extLst>
           </p:cNvPr>
@@ -10973,7 +10893,7 @@
           <p:cNvPr id="27" name="">
             <a:extLst xmlns:a="http://schemas.openxmlformats.org/drawingml/2006/main">
               <a:ext uri="{FF2B5EF4-FFF2-40B4-BE49-F238E27FC236}">
-                <a16:creationId xmlns:a16="http://schemas.microsoft.com/office/drawing/2014/main" id="{95A14E21-445F-459B-BC3D-E8247A4A3B45}"/>
+                <a16:creationId xmlns:a16="http://schemas.microsoft.com/office/drawing/2014/main" id="{8C32E441-20AF-4133-9EDF-1D674D1043E7}"/>
               </a:ext>
             </a:extLst>
           </p:cNvPr>
@@ -11008,7 +10928,7 @@
           <p:cNvPr id="28" name="">
             <a:extLst xmlns:a="http://schemas.openxmlformats.org/drawingml/2006/main">
               <a:ext uri="{FF2B5EF4-FFF2-40B4-BE49-F238E27FC236}">
-                <a16:creationId xmlns:a16="http://schemas.microsoft.com/office/drawing/2014/main" id="{E53EFFFB-48DE-40CF-9935-FD974A519DED}"/>
+                <a16:creationId xmlns:a16="http://schemas.microsoft.com/office/drawing/2014/main" id="{3C05A7B8-9A72-487D-BEF8-DC51CC46BAB4}"/>
               </a:ext>
             </a:extLst>
           </p:cNvPr>
@@ -11072,7 +10992,7 @@
           <p:cNvPr id="29" name="">
             <a:extLst xmlns:a="http://schemas.openxmlformats.org/drawingml/2006/main">
               <a:ext uri="{FF2B5EF4-FFF2-40B4-BE49-F238E27FC236}">
-                <a16:creationId xmlns:a16="http://schemas.microsoft.com/office/drawing/2014/main" id="{A1E69352-14D7-45FE-9ADB-DA4642C460F7}"/>
+                <a16:creationId xmlns:a16="http://schemas.microsoft.com/office/drawing/2014/main" id="{92C972FA-C061-471B-AF2B-0289659F0AE6}"/>
               </a:ext>
             </a:extLst>
           </p:cNvPr>
@@ -11126,7 +11046,7 @@
                 <a:ea typeface="PingFang SC"/>
                 <a:cs typeface="PingFang SC"/>
               </a:rPr>
-              <a:t>后端导入、ORM 表注册、前端 TypeScript、Vite 构建、Docker API 冒烟测试均已通过。</a:t>
+              <a:t>后端导入、ORM 表注册、前端 TypeScript、Vite 构建均已通过；真实模型适配层支持失败回退。</a:t>
             </a:r>
           </a:p>
         </p:txBody>
@@ -11136,7 +11056,7 @@
           <p:cNvPr id="30" name="">
             <a:extLst xmlns:a="http://schemas.openxmlformats.org/drawingml/2006/main">
               <a:ext uri="{FF2B5EF4-FFF2-40B4-BE49-F238E27FC236}">
-                <a16:creationId xmlns:a16="http://schemas.microsoft.com/office/drawing/2014/main" id="{E527B9BB-DA01-4482-AD7E-0F7B61D1AA62}"/>
+                <a16:creationId xmlns:a16="http://schemas.microsoft.com/office/drawing/2014/main" id="{D68C6252-DE65-4B50-923A-2F0BCBF72767}"/>
               </a:ext>
             </a:extLst>
           </p:cNvPr>
@@ -11200,7 +11120,7 @@
           <p:cNvPr id="31" name="">
             <a:extLst xmlns:a="http://schemas.openxmlformats.org/drawingml/2006/main">
               <a:ext uri="{FF2B5EF4-FFF2-40B4-BE49-F238E27FC236}">
-                <a16:creationId xmlns:a16="http://schemas.microsoft.com/office/drawing/2014/main" id="{12769B5E-A28D-42D9-922D-CCAB5866B501}"/>
+                <a16:creationId xmlns:a16="http://schemas.microsoft.com/office/drawing/2014/main" id="{FB97AA52-3962-4150-BA53-EE55F0A7A967}"/>
               </a:ext>
             </a:extLst>
           </p:cNvPr>
@@ -11262,7 +11182,7 @@
     </p:spTree>
     <p:extLst>
       <p:ext uri="{BB962C8B-B14F-4D97-AF65-F5344CB8AC3E}">
-        <p14:creationId xmlns:p14="http://schemas.microsoft.com/office/powerpoint/2010/main" val="1045665935"/>
+        <p14:creationId xmlns:p14="http://schemas.microsoft.com/office/powerpoint/2010/main" val="628243490"/>
       </p:ext>
     </p:extLst>
   </p:cSld>
@@ -11286,7 +11206,7 @@
           <p:cNvPr id="1" name="">
             <a:extLst xmlns:a="http://schemas.openxmlformats.org/drawingml/2006/main">
               <a:ext uri="{FF2B5EF4-FFF2-40B4-BE49-F238E27FC236}">
-                <a16:creationId xmlns:a16="http://schemas.microsoft.com/office/drawing/2014/main" id="{C8F9E148-8845-4107-BE2D-E77C8ACD379E}"/>
+                <a16:creationId xmlns:a16="http://schemas.microsoft.com/office/drawing/2014/main" id="{F8966B3D-DFD2-4D57-AFC5-6F8BD7A26B70}"/>
               </a:ext>
             </a:extLst>
           </p:cNvPr>
@@ -11321,7 +11241,7 @@
           <p:cNvPr id="2" name="">
             <a:extLst xmlns:a="http://schemas.openxmlformats.org/drawingml/2006/main">
               <a:ext uri="{FF2B5EF4-FFF2-40B4-BE49-F238E27FC236}">
-                <a16:creationId xmlns:a16="http://schemas.microsoft.com/office/drawing/2014/main" id="{C7AF038D-5E77-4CC1-8983-1E47001C42BB}"/>
+                <a16:creationId xmlns:a16="http://schemas.microsoft.com/office/drawing/2014/main" id="{8712AF36-9233-4F31-AEE6-CDE5BFE108C0}"/>
               </a:ext>
             </a:extLst>
           </p:cNvPr>
@@ -11356,7 +11276,7 @@
           <p:cNvPr id="3" name="">
             <a:extLst xmlns:a="http://schemas.openxmlformats.org/drawingml/2006/main">
               <a:ext uri="{FF2B5EF4-FFF2-40B4-BE49-F238E27FC236}">
-                <a16:creationId xmlns:a16="http://schemas.microsoft.com/office/drawing/2014/main" id="{81630BEA-1F82-401E-8867-F0B258E97E47}"/>
+                <a16:creationId xmlns:a16="http://schemas.microsoft.com/office/drawing/2014/main" id="{FA337663-6C97-42D8-BCAD-367B96B60770}"/>
               </a:ext>
             </a:extLst>
           </p:cNvPr>
@@ -11391,7 +11311,7 @@
           <p:cNvPr id="4" name="">
             <a:extLst xmlns:a="http://schemas.openxmlformats.org/drawingml/2006/main">
               <a:ext uri="{FF2B5EF4-FFF2-40B4-BE49-F238E27FC236}">
-                <a16:creationId xmlns:a16="http://schemas.microsoft.com/office/drawing/2014/main" id="{19A72D41-1DEA-45D9-8B75-B20E36BC05B3}"/>
+                <a16:creationId xmlns:a16="http://schemas.microsoft.com/office/drawing/2014/main" id="{5896ECC1-58EC-489C-B352-D662120485C9}"/>
               </a:ext>
             </a:extLst>
           </p:cNvPr>
@@ -11455,7 +11375,7 @@
           <p:cNvPr id="5" name="">
             <a:extLst xmlns:a="http://schemas.openxmlformats.org/drawingml/2006/main">
               <a:ext uri="{FF2B5EF4-FFF2-40B4-BE49-F238E27FC236}">
-                <a16:creationId xmlns:a16="http://schemas.microsoft.com/office/drawing/2014/main" id="{FE9D1627-C5B2-47B8-BFF5-1017CB4BC9CD}"/>
+                <a16:creationId xmlns:a16="http://schemas.microsoft.com/office/drawing/2014/main" id="{C7F1395A-1823-4604-9144-D00FBB68E9C7}"/>
               </a:ext>
             </a:extLst>
           </p:cNvPr>
@@ -11519,7 +11439,7 @@
           <p:cNvPr id="6" name="">
             <a:extLst xmlns:a="http://schemas.openxmlformats.org/drawingml/2006/main">
               <a:ext uri="{FF2B5EF4-FFF2-40B4-BE49-F238E27FC236}">
-                <a16:creationId xmlns:a16="http://schemas.microsoft.com/office/drawing/2014/main" id="{58F670ED-58FB-407A-8B90-3639EE79AB90}"/>
+                <a16:creationId xmlns:a16="http://schemas.microsoft.com/office/drawing/2014/main" id="{174BA816-6F40-44CD-8C82-C5B8A40518DC}"/>
               </a:ext>
             </a:extLst>
           </p:cNvPr>
@@ -11552,7 +11472,7 @@
           <p:cNvPr id="7" name="">
             <a:extLst xmlns:a="http://schemas.openxmlformats.org/drawingml/2006/main">
               <a:ext uri="{FF2B5EF4-FFF2-40B4-BE49-F238E27FC236}">
-                <a16:creationId xmlns:a16="http://schemas.microsoft.com/office/drawing/2014/main" id="{EAC523A2-4094-4CC9-B8CB-D57392BA0ED6}"/>
+                <a16:creationId xmlns:a16="http://schemas.microsoft.com/office/drawing/2014/main" id="{928C04F4-E9FC-451F-8A95-34D5C502DF09}"/>
               </a:ext>
             </a:extLst>
           </p:cNvPr>
@@ -11587,7 +11507,7 @@
           <p:cNvPr id="8" name="">
             <a:extLst xmlns:a="http://schemas.openxmlformats.org/drawingml/2006/main">
               <a:ext uri="{FF2B5EF4-FFF2-40B4-BE49-F238E27FC236}">
-                <a16:creationId xmlns:a16="http://schemas.microsoft.com/office/drawing/2014/main" id="{5392A9E8-B436-46D7-A021-7FFDA6E2A9F5}"/>
+                <a16:creationId xmlns:a16="http://schemas.microsoft.com/office/drawing/2014/main" id="{1C183B17-BBB3-4B62-86B3-C6C41792F9A2}"/>
               </a:ext>
             </a:extLst>
           </p:cNvPr>
@@ -11651,7 +11571,7 @@
           <p:cNvPr id="9" name="">
             <a:extLst xmlns:a="http://schemas.openxmlformats.org/drawingml/2006/main">
               <a:ext uri="{FF2B5EF4-FFF2-40B4-BE49-F238E27FC236}">
-                <a16:creationId xmlns:a16="http://schemas.microsoft.com/office/drawing/2014/main" id="{90716E9D-1F4A-4F45-856F-9ECCA0C906BC}"/>
+                <a16:creationId xmlns:a16="http://schemas.microsoft.com/office/drawing/2014/main" id="{E873B2AA-00C4-46A6-832D-AD93EDDA88CE}"/>
               </a:ext>
             </a:extLst>
           </p:cNvPr>
@@ -11738,7 +11658,7 @@
           <p:cNvPr id="10" name="">
             <a:extLst xmlns:a="http://schemas.openxmlformats.org/drawingml/2006/main">
               <a:ext uri="{FF2B5EF4-FFF2-40B4-BE49-F238E27FC236}">
-                <a16:creationId xmlns:a16="http://schemas.microsoft.com/office/drawing/2014/main" id="{74C39068-3773-43CF-BB95-6E26218FC782}"/>
+                <a16:creationId xmlns:a16="http://schemas.microsoft.com/office/drawing/2014/main" id="{89CBA112-8E15-483B-8BE1-60E59104B690}"/>
               </a:ext>
             </a:extLst>
           </p:cNvPr>
@@ -11771,7 +11691,7 @@
           <p:cNvPr id="11" name="">
             <a:extLst xmlns:a="http://schemas.openxmlformats.org/drawingml/2006/main">
               <a:ext uri="{FF2B5EF4-FFF2-40B4-BE49-F238E27FC236}">
-                <a16:creationId xmlns:a16="http://schemas.microsoft.com/office/drawing/2014/main" id="{EDD5415A-5B57-4373-8CD0-D03301DC9391}"/>
+                <a16:creationId xmlns:a16="http://schemas.microsoft.com/office/drawing/2014/main" id="{A60C443E-4658-4EB6-A3C2-BFDABB8701C5}"/>
               </a:ext>
             </a:extLst>
           </p:cNvPr>
@@ -11806,7 +11726,7 @@
           <p:cNvPr id="12" name="">
             <a:extLst xmlns:a="http://schemas.openxmlformats.org/drawingml/2006/main">
               <a:ext uri="{FF2B5EF4-FFF2-40B4-BE49-F238E27FC236}">
-                <a16:creationId xmlns:a16="http://schemas.microsoft.com/office/drawing/2014/main" id="{DB27F740-AE08-424D-91BC-5D6711940A31}"/>
+                <a16:creationId xmlns:a16="http://schemas.microsoft.com/office/drawing/2014/main" id="{8100B03F-E241-44F4-9648-0449E61BD93D}"/>
               </a:ext>
             </a:extLst>
           </p:cNvPr>
@@ -11870,7 +11790,7 @@
           <p:cNvPr id="13" name="">
             <a:extLst xmlns:a="http://schemas.openxmlformats.org/drawingml/2006/main">
               <a:ext uri="{FF2B5EF4-FFF2-40B4-BE49-F238E27FC236}">
-                <a16:creationId xmlns:a16="http://schemas.microsoft.com/office/drawing/2014/main" id="{627F4150-6384-47E7-A777-3DABA5E4C6B7}"/>
+                <a16:creationId xmlns:a16="http://schemas.microsoft.com/office/drawing/2014/main" id="{71A5995D-1FD7-4748-ADE5-E2658705E94E}"/>
               </a:ext>
             </a:extLst>
           </p:cNvPr>
@@ -11980,7 +11900,7 @@
           <p:cNvPr id="14" name="">
             <a:extLst xmlns:a="http://schemas.openxmlformats.org/drawingml/2006/main">
               <a:ext uri="{FF2B5EF4-FFF2-40B4-BE49-F238E27FC236}">
-                <a16:creationId xmlns:a16="http://schemas.microsoft.com/office/drawing/2014/main" id="{8BA8E79B-FF54-4206-B204-259A47793D95}"/>
+                <a16:creationId xmlns:a16="http://schemas.microsoft.com/office/drawing/2014/main" id="{C45B77D7-2D39-4C05-8CB4-F08FDAA982F2}"/>
               </a:ext>
             </a:extLst>
           </p:cNvPr>
@@ -12013,7 +11933,7 @@
           <p:cNvPr id="15" name="">
             <a:extLst xmlns:a="http://schemas.openxmlformats.org/drawingml/2006/main">
               <a:ext uri="{FF2B5EF4-FFF2-40B4-BE49-F238E27FC236}">
-                <a16:creationId xmlns:a16="http://schemas.microsoft.com/office/drawing/2014/main" id="{7EB92CF9-C09D-4727-A0ED-3469B1CF2194}"/>
+                <a16:creationId xmlns:a16="http://schemas.microsoft.com/office/drawing/2014/main" id="{3DBB8FB1-5C14-465C-B5A1-C4E355683CC8}"/>
               </a:ext>
             </a:extLst>
           </p:cNvPr>
@@ -12048,7 +11968,7 @@
           <p:cNvPr id="16" name="">
             <a:extLst xmlns:a="http://schemas.openxmlformats.org/drawingml/2006/main">
               <a:ext uri="{FF2B5EF4-FFF2-40B4-BE49-F238E27FC236}">
-                <a16:creationId xmlns:a16="http://schemas.microsoft.com/office/drawing/2014/main" id="{D379D82C-3656-4A68-BB81-DBFF14EF99CE}"/>
+                <a16:creationId xmlns:a16="http://schemas.microsoft.com/office/drawing/2014/main" id="{7430C97D-50E9-451A-9547-9CCA20E26C44}"/>
               </a:ext>
             </a:extLst>
           </p:cNvPr>
@@ -12112,7 +12032,7 @@
           <p:cNvPr id="17" name="">
             <a:extLst xmlns:a="http://schemas.openxmlformats.org/drawingml/2006/main">
               <a:ext uri="{FF2B5EF4-FFF2-40B4-BE49-F238E27FC236}">
-                <a16:creationId xmlns:a16="http://schemas.microsoft.com/office/drawing/2014/main" id="{FD4E6981-39C0-4B99-9B30-DF0937131F64}"/>
+                <a16:creationId xmlns:a16="http://schemas.microsoft.com/office/drawing/2014/main" id="{F83ECB6B-549B-4670-AE37-7E8303F53231}"/>
               </a:ext>
             </a:extLst>
           </p:cNvPr>
@@ -12245,7 +12165,7 @@
           <p:cNvPr id="18" name="">
             <a:extLst xmlns:a="http://schemas.openxmlformats.org/drawingml/2006/main">
               <a:ext uri="{FF2B5EF4-FFF2-40B4-BE49-F238E27FC236}">
-                <a16:creationId xmlns:a16="http://schemas.microsoft.com/office/drawing/2014/main" id="{D7AFCD2B-950C-4560-8F7E-2818551D96D4}"/>
+                <a16:creationId xmlns:a16="http://schemas.microsoft.com/office/drawing/2014/main" id="{997A8C93-F8E1-4EE6-8170-B3CDBBD192DE}"/>
               </a:ext>
             </a:extLst>
           </p:cNvPr>
@@ -12278,7 +12198,7 @@
           <p:cNvPr id="19" name="">
             <a:extLst xmlns:a="http://schemas.openxmlformats.org/drawingml/2006/main">
               <a:ext uri="{FF2B5EF4-FFF2-40B4-BE49-F238E27FC236}">
-                <a16:creationId xmlns:a16="http://schemas.microsoft.com/office/drawing/2014/main" id="{7698EB8C-0F27-4E47-A4C1-4A49011E6ADB}"/>
+                <a16:creationId xmlns:a16="http://schemas.microsoft.com/office/drawing/2014/main" id="{708FF205-12BC-45F7-932D-06307676CEBF}"/>
               </a:ext>
             </a:extLst>
           </p:cNvPr>
@@ -12313,7 +12233,7 @@
           <p:cNvPr id="20" name="">
             <a:extLst xmlns:a="http://schemas.openxmlformats.org/drawingml/2006/main">
               <a:ext uri="{FF2B5EF4-FFF2-40B4-BE49-F238E27FC236}">
-                <a16:creationId xmlns:a16="http://schemas.microsoft.com/office/drawing/2014/main" id="{8872BD31-C28D-4721-87C7-F60491B4402C}"/>
+                <a16:creationId xmlns:a16="http://schemas.microsoft.com/office/drawing/2014/main" id="{FC89D67D-222B-4517-93DF-00B2D0398A67}"/>
               </a:ext>
             </a:extLst>
           </p:cNvPr>
@@ -12377,7 +12297,7 @@
           <p:cNvPr id="21" name="">
             <a:extLst xmlns:a="http://schemas.openxmlformats.org/drawingml/2006/main">
               <a:ext uri="{FF2B5EF4-FFF2-40B4-BE49-F238E27FC236}">
-                <a16:creationId xmlns:a16="http://schemas.microsoft.com/office/drawing/2014/main" id="{B57D6D6F-F1EB-48F6-844D-53ABE754B920}"/>
+                <a16:creationId xmlns:a16="http://schemas.microsoft.com/office/drawing/2014/main" id="{97A1456A-74D4-4AB2-8632-9F3244AAE107}"/>
               </a:ext>
             </a:extLst>
           </p:cNvPr>
@@ -12510,7 +12430,7 @@
           <p:cNvPr id="22" name="">
             <a:extLst xmlns:a="http://schemas.openxmlformats.org/drawingml/2006/main">
               <a:ext uri="{FF2B5EF4-FFF2-40B4-BE49-F238E27FC236}">
-                <a16:creationId xmlns:a16="http://schemas.microsoft.com/office/drawing/2014/main" id="{B47CBD29-C611-4292-83A0-61724512A644}"/>
+                <a16:creationId xmlns:a16="http://schemas.microsoft.com/office/drawing/2014/main" id="{F12A67FF-C30A-4E3F-86C1-04E37B84C9E7}"/>
               </a:ext>
             </a:extLst>
           </p:cNvPr>
@@ -12543,7 +12463,7 @@
           <p:cNvPr id="23" name="">
             <a:extLst xmlns:a="http://schemas.openxmlformats.org/drawingml/2006/main">
               <a:ext uri="{FF2B5EF4-FFF2-40B4-BE49-F238E27FC236}">
-                <a16:creationId xmlns:a16="http://schemas.microsoft.com/office/drawing/2014/main" id="{84DA74A3-12BD-4FFD-AACD-90A2DE609715}"/>
+                <a16:creationId xmlns:a16="http://schemas.microsoft.com/office/drawing/2014/main" id="{4BD923A8-A2C3-40D0-91EB-564909857349}"/>
               </a:ext>
             </a:extLst>
           </p:cNvPr>
@@ -12607,7 +12527,7 @@
           <p:cNvPr id="24" name="">
             <a:extLst xmlns:a="http://schemas.openxmlformats.org/drawingml/2006/main">
               <a:ext uri="{FF2B5EF4-FFF2-40B4-BE49-F238E27FC236}">
-                <a16:creationId xmlns:a16="http://schemas.microsoft.com/office/drawing/2014/main" id="{F2C3ABA8-1B7C-4A3E-83C0-23E85542C41E}"/>
+                <a16:creationId xmlns:a16="http://schemas.microsoft.com/office/drawing/2014/main" id="{C1502810-99DD-402A-A223-0D9AA5A68B6B}"/>
               </a:ext>
             </a:extLst>
           </p:cNvPr>
@@ -12671,7 +12591,7 @@
           <p:cNvPr id="25" name="">
             <a:extLst xmlns:a="http://schemas.openxmlformats.org/drawingml/2006/main">
               <a:ext uri="{FF2B5EF4-FFF2-40B4-BE49-F238E27FC236}">
-                <a16:creationId xmlns:a16="http://schemas.microsoft.com/office/drawing/2014/main" id="{68FD5FE0-17C4-494F-A98F-AEB9655CBF63}"/>
+                <a16:creationId xmlns:a16="http://schemas.microsoft.com/office/drawing/2014/main" id="{4557DC58-E391-48E8-A8DC-4B46D579E372}"/>
               </a:ext>
             </a:extLst>
           </p:cNvPr>
@@ -12735,7 +12655,7 @@
           <p:cNvPr id="26" name="">
             <a:extLst xmlns:a="http://schemas.openxmlformats.org/drawingml/2006/main">
               <a:ext uri="{FF2B5EF4-FFF2-40B4-BE49-F238E27FC236}">
-                <a16:creationId xmlns:a16="http://schemas.microsoft.com/office/drawing/2014/main" id="{7DE8A3EA-8390-4171-B1EE-D564FF92A019}"/>
+                <a16:creationId xmlns:a16="http://schemas.microsoft.com/office/drawing/2014/main" id="{ADAF358A-648E-4606-B641-FD19B12CFFB4}"/>
               </a:ext>
             </a:extLst>
           </p:cNvPr>
@@ -12797,7 +12717,7 @@
     </p:spTree>
     <p:extLst>
       <p:ext uri="{BB962C8B-B14F-4D97-AF65-F5344CB8AC3E}">
-        <p14:creationId xmlns:p14="http://schemas.microsoft.com/office/powerpoint/2010/main" val="653527002"/>
+        <p14:creationId xmlns:p14="http://schemas.microsoft.com/office/powerpoint/2010/main" val="57637331"/>
       </p:ext>
     </p:extLst>
   </p:cSld>
@@ -12821,7 +12741,7 @@
           <p:cNvPr id="1" name="">
             <a:extLst xmlns:a="http://schemas.openxmlformats.org/drawingml/2006/main">
               <a:ext uri="{FF2B5EF4-FFF2-40B4-BE49-F238E27FC236}">
-                <a16:creationId xmlns:a16="http://schemas.microsoft.com/office/drawing/2014/main" id="{1F7F7396-C45A-4A10-944C-FE86E525D257}"/>
+                <a16:creationId xmlns:a16="http://schemas.microsoft.com/office/drawing/2014/main" id="{AB7FF795-2535-4B6F-BF9F-E96F2C9878A0}"/>
               </a:ext>
             </a:extLst>
           </p:cNvPr>
@@ -12856,7 +12776,7 @@
           <p:cNvPr id="2" name="">
             <a:extLst xmlns:a="http://schemas.openxmlformats.org/drawingml/2006/main">
               <a:ext uri="{FF2B5EF4-FFF2-40B4-BE49-F238E27FC236}">
-                <a16:creationId xmlns:a16="http://schemas.microsoft.com/office/drawing/2014/main" id="{3978895E-C3D2-406B-AE5C-DE904574B6F0}"/>
+                <a16:creationId xmlns:a16="http://schemas.microsoft.com/office/drawing/2014/main" id="{2D7EA0AA-FB99-43D4-A3B5-E8C52F83E2E1}"/>
               </a:ext>
             </a:extLst>
           </p:cNvPr>
@@ -12891,7 +12811,7 @@
           <p:cNvPr id="3" name="">
             <a:extLst xmlns:a="http://schemas.openxmlformats.org/drawingml/2006/main">
               <a:ext uri="{FF2B5EF4-FFF2-40B4-BE49-F238E27FC236}">
-                <a16:creationId xmlns:a16="http://schemas.microsoft.com/office/drawing/2014/main" id="{53405F92-6123-4925-BBCF-1EC636363E75}"/>
+                <a16:creationId xmlns:a16="http://schemas.microsoft.com/office/drawing/2014/main" id="{75B472F3-707C-4BF7-8B2E-B0ABFBEDE4AD}"/>
               </a:ext>
             </a:extLst>
           </p:cNvPr>
@@ -12926,7 +12846,7 @@
           <p:cNvPr id="4" name="">
             <a:extLst xmlns:a="http://schemas.openxmlformats.org/drawingml/2006/main">
               <a:ext uri="{FF2B5EF4-FFF2-40B4-BE49-F238E27FC236}">
-                <a16:creationId xmlns:a16="http://schemas.microsoft.com/office/drawing/2014/main" id="{00AA3F8A-1932-4483-8513-BD0F22EA0891}"/>
+                <a16:creationId xmlns:a16="http://schemas.microsoft.com/office/drawing/2014/main" id="{4F07052F-DA97-4A21-8066-4DA974DA1509}"/>
               </a:ext>
             </a:extLst>
           </p:cNvPr>
@@ -12990,7 +12910,7 @@
           <p:cNvPr id="5" name="">
             <a:extLst xmlns:a="http://schemas.openxmlformats.org/drawingml/2006/main">
               <a:ext uri="{FF2B5EF4-FFF2-40B4-BE49-F238E27FC236}">
-                <a16:creationId xmlns:a16="http://schemas.microsoft.com/office/drawing/2014/main" id="{0CCC2698-EBB0-4260-9FB8-3627B066DE53}"/>
+                <a16:creationId xmlns:a16="http://schemas.microsoft.com/office/drawing/2014/main" id="{AE5A960B-CF97-4E56-83A0-238750C71618}"/>
               </a:ext>
             </a:extLst>
           </p:cNvPr>
@@ -13054,7 +12974,7 @@
           <p:cNvPr id="6" name="">
             <a:extLst xmlns:a="http://schemas.openxmlformats.org/drawingml/2006/main">
               <a:ext uri="{FF2B5EF4-FFF2-40B4-BE49-F238E27FC236}">
-                <a16:creationId xmlns:a16="http://schemas.microsoft.com/office/drawing/2014/main" id="{550CA620-2483-4268-91B6-1DFEAF278838}"/>
+                <a16:creationId xmlns:a16="http://schemas.microsoft.com/office/drawing/2014/main" id="{6E3941FA-8E6E-4C12-8676-92FD37DB00C8}"/>
               </a:ext>
             </a:extLst>
           </p:cNvPr>
@@ -13087,7 +13007,7 @@
           <p:cNvPr id="7" name="">
             <a:extLst xmlns:a="http://schemas.openxmlformats.org/drawingml/2006/main">
               <a:ext uri="{FF2B5EF4-FFF2-40B4-BE49-F238E27FC236}">
-                <a16:creationId xmlns:a16="http://schemas.microsoft.com/office/drawing/2014/main" id="{3E5B6DEB-FC3E-4F2C-AB9C-848682E022CC}"/>
+                <a16:creationId xmlns:a16="http://schemas.microsoft.com/office/drawing/2014/main" id="{A214EDE1-822D-43A7-B981-1BCF42BCE589}"/>
               </a:ext>
             </a:extLst>
           </p:cNvPr>
@@ -13122,7 +13042,7 @@
           <p:cNvPr id="8" name="">
             <a:extLst xmlns:a="http://schemas.openxmlformats.org/drawingml/2006/main">
               <a:ext uri="{FF2B5EF4-FFF2-40B4-BE49-F238E27FC236}">
-                <a16:creationId xmlns:a16="http://schemas.microsoft.com/office/drawing/2014/main" id="{28290B7F-729E-476B-8D24-468F81999E3F}"/>
+                <a16:creationId xmlns:a16="http://schemas.microsoft.com/office/drawing/2014/main" id="{E7DC64EC-D94C-455B-990A-7D0BFCA8FA6C}"/>
               </a:ext>
             </a:extLst>
           </p:cNvPr>
@@ -13186,7 +13106,7 @@
           <p:cNvPr id="9" name="">
             <a:extLst xmlns:a="http://schemas.openxmlformats.org/drawingml/2006/main">
               <a:ext uri="{FF2B5EF4-FFF2-40B4-BE49-F238E27FC236}">
-                <a16:creationId xmlns:a16="http://schemas.microsoft.com/office/drawing/2014/main" id="{BF16A1F6-3C86-4F7C-BC73-E420DBE6AED6}"/>
+                <a16:creationId xmlns:a16="http://schemas.microsoft.com/office/drawing/2014/main" id="{3ABFDF6D-CF26-4273-B735-220D36EAEBE2}"/>
               </a:ext>
             </a:extLst>
           </p:cNvPr>
@@ -13250,7 +13170,7 @@
           <p:cNvPr id="10" name="">
             <a:extLst xmlns:a="http://schemas.openxmlformats.org/drawingml/2006/main">
               <a:ext uri="{FF2B5EF4-FFF2-40B4-BE49-F238E27FC236}">
-                <a16:creationId xmlns:a16="http://schemas.microsoft.com/office/drawing/2014/main" id="{69B7D446-786D-4B07-A940-8C95CEF7DB10}"/>
+                <a16:creationId xmlns:a16="http://schemas.microsoft.com/office/drawing/2014/main" id="{621F94E9-567B-4079-95E6-2DC52AE9FE95}"/>
               </a:ext>
             </a:extLst>
           </p:cNvPr>
@@ -13285,7 +13205,7 @@
           <p:cNvPr id="11" name="">
             <a:extLst xmlns:a="http://schemas.openxmlformats.org/drawingml/2006/main">
               <a:ext uri="{FF2B5EF4-FFF2-40B4-BE49-F238E27FC236}">
-                <a16:creationId xmlns:a16="http://schemas.microsoft.com/office/drawing/2014/main" id="{2AE1F507-CB56-4A6B-9F07-62D90EE77653}"/>
+                <a16:creationId xmlns:a16="http://schemas.microsoft.com/office/drawing/2014/main" id="{55F4B096-2FB3-42C1-9769-C74494847F11}"/>
               </a:ext>
             </a:extLst>
           </p:cNvPr>
@@ -13318,7 +13238,7 @@
           <p:cNvPr id="12" name="">
             <a:extLst xmlns:a="http://schemas.openxmlformats.org/drawingml/2006/main">
               <a:ext uri="{FF2B5EF4-FFF2-40B4-BE49-F238E27FC236}">
-                <a16:creationId xmlns:a16="http://schemas.microsoft.com/office/drawing/2014/main" id="{0E870C7C-B3F3-426E-818F-805A5EE118BF}"/>
+                <a16:creationId xmlns:a16="http://schemas.microsoft.com/office/drawing/2014/main" id="{C9953227-B603-46F3-82BD-DA23E374F733}"/>
               </a:ext>
             </a:extLst>
           </p:cNvPr>
@@ -13351,7 +13271,7 @@
           <p:cNvPr id="13" name="">
             <a:extLst xmlns:a="http://schemas.openxmlformats.org/drawingml/2006/main">
               <a:ext uri="{FF2B5EF4-FFF2-40B4-BE49-F238E27FC236}">
-                <a16:creationId xmlns:a16="http://schemas.microsoft.com/office/drawing/2014/main" id="{B7502D45-7B9C-432B-BC5E-B3BE8C04868F}"/>
+                <a16:creationId xmlns:a16="http://schemas.microsoft.com/office/drawing/2014/main" id="{3E6C06C9-B438-4704-BD31-5633DB6A03EF}"/>
               </a:ext>
             </a:extLst>
           </p:cNvPr>
@@ -13386,7 +13306,7 @@
           <p:cNvPr id="14" name="">
             <a:extLst xmlns:a="http://schemas.openxmlformats.org/drawingml/2006/main">
               <a:ext uri="{FF2B5EF4-FFF2-40B4-BE49-F238E27FC236}">
-                <a16:creationId xmlns:a16="http://schemas.microsoft.com/office/drawing/2014/main" id="{18D6CFC2-F0A8-4110-BB6B-7BCA727CB62B}"/>
+                <a16:creationId xmlns:a16="http://schemas.microsoft.com/office/drawing/2014/main" id="{9BAD43DA-D4A6-4455-8875-9B98988E7F41}"/>
               </a:ext>
             </a:extLst>
           </p:cNvPr>
@@ -13450,7 +13370,7 @@
           <p:cNvPr id="15" name="">
             <a:extLst xmlns:a="http://schemas.openxmlformats.org/drawingml/2006/main">
               <a:ext uri="{FF2B5EF4-FFF2-40B4-BE49-F238E27FC236}">
-                <a16:creationId xmlns:a16="http://schemas.microsoft.com/office/drawing/2014/main" id="{81E7C114-4DED-4612-9832-A0934313F450}"/>
+                <a16:creationId xmlns:a16="http://schemas.microsoft.com/office/drawing/2014/main" id="{E9ED2C02-2685-494B-8F8C-E4E0B856D3CE}"/>
               </a:ext>
             </a:extLst>
           </p:cNvPr>
@@ -13514,7 +13434,7 @@
           <p:cNvPr id="16" name="">
             <a:extLst xmlns:a="http://schemas.openxmlformats.org/drawingml/2006/main">
               <a:ext uri="{FF2B5EF4-FFF2-40B4-BE49-F238E27FC236}">
-                <a16:creationId xmlns:a16="http://schemas.microsoft.com/office/drawing/2014/main" id="{BF0C2F60-3675-4951-9AD8-9D0194067213}"/>
+                <a16:creationId xmlns:a16="http://schemas.microsoft.com/office/drawing/2014/main" id="{DD424F9B-6281-4BFF-8A80-67D4E9381E0B}"/>
               </a:ext>
             </a:extLst>
           </p:cNvPr>
@@ -13549,7 +13469,7 @@
           <p:cNvPr id="17" name="">
             <a:extLst xmlns:a="http://schemas.openxmlformats.org/drawingml/2006/main">
               <a:ext uri="{FF2B5EF4-FFF2-40B4-BE49-F238E27FC236}">
-                <a16:creationId xmlns:a16="http://schemas.microsoft.com/office/drawing/2014/main" id="{B121F318-B285-4607-83FE-9E3C4A3F1F0E}"/>
+                <a16:creationId xmlns:a16="http://schemas.microsoft.com/office/drawing/2014/main" id="{3589BE40-D7F2-46EC-855D-BA23B10AE351}"/>
               </a:ext>
             </a:extLst>
           </p:cNvPr>
@@ -13582,7 +13502,7 @@
           <p:cNvPr id="18" name="">
             <a:extLst xmlns:a="http://schemas.openxmlformats.org/drawingml/2006/main">
               <a:ext uri="{FF2B5EF4-FFF2-40B4-BE49-F238E27FC236}">
-                <a16:creationId xmlns:a16="http://schemas.microsoft.com/office/drawing/2014/main" id="{3C0CA3B9-BE21-44E2-A3B8-6727444808C4}"/>
+                <a16:creationId xmlns:a16="http://schemas.microsoft.com/office/drawing/2014/main" id="{8BE7B1FF-6AE8-4BD5-BED1-E6000000017C}"/>
               </a:ext>
             </a:extLst>
           </p:cNvPr>
@@ -13615,7 +13535,7 @@
           <p:cNvPr id="19" name="">
             <a:extLst xmlns:a="http://schemas.openxmlformats.org/drawingml/2006/main">
               <a:ext uri="{FF2B5EF4-FFF2-40B4-BE49-F238E27FC236}">
-                <a16:creationId xmlns:a16="http://schemas.microsoft.com/office/drawing/2014/main" id="{33836B74-8ED8-4976-BC24-5CAF935EE058}"/>
+                <a16:creationId xmlns:a16="http://schemas.microsoft.com/office/drawing/2014/main" id="{7BAD1EBC-F10B-4069-A557-9D777093ECA8}"/>
               </a:ext>
             </a:extLst>
           </p:cNvPr>
@@ -13650,7 +13570,7 @@
           <p:cNvPr id="20" name="">
             <a:extLst xmlns:a="http://schemas.openxmlformats.org/drawingml/2006/main">
               <a:ext uri="{FF2B5EF4-FFF2-40B4-BE49-F238E27FC236}">
-                <a16:creationId xmlns:a16="http://schemas.microsoft.com/office/drawing/2014/main" id="{106BA668-9989-4E5E-ADD9-8BA7469530EC}"/>
+                <a16:creationId xmlns:a16="http://schemas.microsoft.com/office/drawing/2014/main" id="{FB81B5E7-0439-4CEB-9A80-D6F191238EA2}"/>
               </a:ext>
             </a:extLst>
           </p:cNvPr>
@@ -13714,7 +13634,7 @@
           <p:cNvPr id="21" name="">
             <a:extLst xmlns:a="http://schemas.openxmlformats.org/drawingml/2006/main">
               <a:ext uri="{FF2B5EF4-FFF2-40B4-BE49-F238E27FC236}">
-                <a16:creationId xmlns:a16="http://schemas.microsoft.com/office/drawing/2014/main" id="{60CCE64C-64D1-453B-8BA6-7AFE5C8D56E8}"/>
+                <a16:creationId xmlns:a16="http://schemas.microsoft.com/office/drawing/2014/main" id="{FE28DB31-F95F-42B7-AAD1-48AF9F31CA6A}"/>
               </a:ext>
             </a:extLst>
           </p:cNvPr>
@@ -13778,7 +13698,7 @@
           <p:cNvPr id="22" name="">
             <a:extLst xmlns:a="http://schemas.openxmlformats.org/drawingml/2006/main">
               <a:ext uri="{FF2B5EF4-FFF2-40B4-BE49-F238E27FC236}">
-                <a16:creationId xmlns:a16="http://schemas.microsoft.com/office/drawing/2014/main" id="{701F897F-EEEF-43A8-906C-B347BBED35EB}"/>
+                <a16:creationId xmlns:a16="http://schemas.microsoft.com/office/drawing/2014/main" id="{C6402578-343B-40AB-A2FB-7B585FEAF648}"/>
               </a:ext>
             </a:extLst>
           </p:cNvPr>
@@ -13813,7 +13733,7 @@
           <p:cNvPr id="23" name="">
             <a:extLst xmlns:a="http://schemas.openxmlformats.org/drawingml/2006/main">
               <a:ext uri="{FF2B5EF4-FFF2-40B4-BE49-F238E27FC236}">
-                <a16:creationId xmlns:a16="http://schemas.microsoft.com/office/drawing/2014/main" id="{333D64C2-524D-4AB5-9EFC-6E708D61804D}"/>
+                <a16:creationId xmlns:a16="http://schemas.microsoft.com/office/drawing/2014/main" id="{9A6C3EDD-1280-409B-884B-56551774461C}"/>
               </a:ext>
             </a:extLst>
           </p:cNvPr>
@@ -13846,7 +13766,7 @@
           <p:cNvPr id="24" name="">
             <a:extLst xmlns:a="http://schemas.openxmlformats.org/drawingml/2006/main">
               <a:ext uri="{FF2B5EF4-FFF2-40B4-BE49-F238E27FC236}">
-                <a16:creationId xmlns:a16="http://schemas.microsoft.com/office/drawing/2014/main" id="{D70C0ECF-F64D-49D0-B28B-B6F3BEBA8B90}"/>
+                <a16:creationId xmlns:a16="http://schemas.microsoft.com/office/drawing/2014/main" id="{22BA5167-B266-465F-9309-9C0C52430784}"/>
               </a:ext>
             </a:extLst>
           </p:cNvPr>
@@ -13879,7 +13799,7 @@
           <p:cNvPr id="25" name="">
             <a:extLst xmlns:a="http://schemas.openxmlformats.org/drawingml/2006/main">
               <a:ext uri="{FF2B5EF4-FFF2-40B4-BE49-F238E27FC236}">
-                <a16:creationId xmlns:a16="http://schemas.microsoft.com/office/drawing/2014/main" id="{C051182B-3B34-439E-BB3B-1ECCDA2C4E91}"/>
+                <a16:creationId xmlns:a16="http://schemas.microsoft.com/office/drawing/2014/main" id="{66701691-86E2-4BDE-8EE1-D3A6C106ADEE}"/>
               </a:ext>
             </a:extLst>
           </p:cNvPr>
@@ -13914,7 +13834,7 @@
           <p:cNvPr id="26" name="">
             <a:extLst xmlns:a="http://schemas.openxmlformats.org/drawingml/2006/main">
               <a:ext uri="{FF2B5EF4-FFF2-40B4-BE49-F238E27FC236}">
-                <a16:creationId xmlns:a16="http://schemas.microsoft.com/office/drawing/2014/main" id="{4EA02BC5-B3CB-421B-9EC2-523B02D2C08C}"/>
+                <a16:creationId xmlns:a16="http://schemas.microsoft.com/office/drawing/2014/main" id="{DDF79FF2-833C-47CB-A307-271D6D523606}"/>
               </a:ext>
             </a:extLst>
           </p:cNvPr>
@@ -13978,7 +13898,7 @@
           <p:cNvPr id="27" name="">
             <a:extLst xmlns:a="http://schemas.openxmlformats.org/drawingml/2006/main">
               <a:ext uri="{FF2B5EF4-FFF2-40B4-BE49-F238E27FC236}">
-                <a16:creationId xmlns:a16="http://schemas.microsoft.com/office/drawing/2014/main" id="{ACB38064-0779-4B48-9C65-456335FFF182}"/>
+                <a16:creationId xmlns:a16="http://schemas.microsoft.com/office/drawing/2014/main" id="{6882F872-4D8F-4C43-846A-3C433816C6F1}"/>
               </a:ext>
             </a:extLst>
           </p:cNvPr>
@@ -14042,7 +13962,7 @@
           <p:cNvPr id="28" name="">
             <a:extLst xmlns:a="http://schemas.openxmlformats.org/drawingml/2006/main">
               <a:ext uri="{FF2B5EF4-FFF2-40B4-BE49-F238E27FC236}">
-                <a16:creationId xmlns:a16="http://schemas.microsoft.com/office/drawing/2014/main" id="{6F4E8A94-A3EF-4C8D-A9F7-DE6B36E3A067}"/>
+                <a16:creationId xmlns:a16="http://schemas.microsoft.com/office/drawing/2014/main" id="{1856F359-A1B7-41BB-B2A7-83F551D221E8}"/>
               </a:ext>
             </a:extLst>
           </p:cNvPr>
@@ -14077,7 +13997,7 @@
           <p:cNvPr id="29" name="">
             <a:extLst xmlns:a="http://schemas.openxmlformats.org/drawingml/2006/main">
               <a:ext uri="{FF2B5EF4-FFF2-40B4-BE49-F238E27FC236}">
-                <a16:creationId xmlns:a16="http://schemas.microsoft.com/office/drawing/2014/main" id="{49E124C6-418B-47B0-A158-98F663691C71}"/>
+                <a16:creationId xmlns:a16="http://schemas.microsoft.com/office/drawing/2014/main" id="{BAE4C87B-1021-4DCA-82A3-7B6D4BEBD165}"/>
               </a:ext>
             </a:extLst>
           </p:cNvPr>
@@ -14110,7 +14030,7 @@
           <p:cNvPr id="30" name="">
             <a:extLst xmlns:a="http://schemas.openxmlformats.org/drawingml/2006/main">
               <a:ext uri="{FF2B5EF4-FFF2-40B4-BE49-F238E27FC236}">
-                <a16:creationId xmlns:a16="http://schemas.microsoft.com/office/drawing/2014/main" id="{5800FBEB-64BE-48A1-BD43-13843BF83578}"/>
+                <a16:creationId xmlns:a16="http://schemas.microsoft.com/office/drawing/2014/main" id="{5593928C-65DC-44FD-8C81-B3D849B6E0E4}"/>
               </a:ext>
             </a:extLst>
           </p:cNvPr>
@@ -14143,7 +14063,7 @@
           <p:cNvPr id="31" name="">
             <a:extLst xmlns:a="http://schemas.openxmlformats.org/drawingml/2006/main">
               <a:ext uri="{FF2B5EF4-FFF2-40B4-BE49-F238E27FC236}">
-                <a16:creationId xmlns:a16="http://schemas.microsoft.com/office/drawing/2014/main" id="{C73D865A-F07C-46B5-B336-F4A269B62032}"/>
+                <a16:creationId xmlns:a16="http://schemas.microsoft.com/office/drawing/2014/main" id="{801D6D2F-43B2-4B0D-8BD8-DD1D3D124CDC}"/>
               </a:ext>
             </a:extLst>
           </p:cNvPr>
@@ -14178,7 +14098,7 @@
           <p:cNvPr id="32" name="">
             <a:extLst xmlns:a="http://schemas.openxmlformats.org/drawingml/2006/main">
               <a:ext uri="{FF2B5EF4-FFF2-40B4-BE49-F238E27FC236}">
-                <a16:creationId xmlns:a16="http://schemas.microsoft.com/office/drawing/2014/main" id="{D34B1A90-32A5-4CBB-9F47-57732362C1DA}"/>
+                <a16:creationId xmlns:a16="http://schemas.microsoft.com/office/drawing/2014/main" id="{1AD42732-212F-445C-A6D5-5309E087E13D}"/>
               </a:ext>
             </a:extLst>
           </p:cNvPr>
@@ -14242,7 +14162,7 @@
           <p:cNvPr id="33" name="">
             <a:extLst xmlns:a="http://schemas.openxmlformats.org/drawingml/2006/main">
               <a:ext uri="{FF2B5EF4-FFF2-40B4-BE49-F238E27FC236}">
-                <a16:creationId xmlns:a16="http://schemas.microsoft.com/office/drawing/2014/main" id="{D5B5BBA4-278C-4F2B-8EBF-DD1AB70B549B}"/>
+                <a16:creationId xmlns:a16="http://schemas.microsoft.com/office/drawing/2014/main" id="{03B6B876-79B8-43E9-879B-714FFBA4EF43}"/>
               </a:ext>
             </a:extLst>
           </p:cNvPr>
@@ -14306,7 +14226,7 @@
           <p:cNvPr id="34" name="">
             <a:extLst xmlns:a="http://schemas.openxmlformats.org/drawingml/2006/main">
               <a:ext uri="{FF2B5EF4-FFF2-40B4-BE49-F238E27FC236}">
-                <a16:creationId xmlns:a16="http://schemas.microsoft.com/office/drawing/2014/main" id="{6A48D7C5-D63F-4796-902C-FF392FE8F79D}"/>
+                <a16:creationId xmlns:a16="http://schemas.microsoft.com/office/drawing/2014/main" id="{F33B657B-31F5-49B8-8F76-0277379FED28}"/>
               </a:ext>
             </a:extLst>
           </p:cNvPr>
@@ -14370,7 +14290,7 @@
           <p:cNvPr id="35" name="">
             <a:extLst xmlns:a="http://schemas.openxmlformats.org/drawingml/2006/main">
               <a:ext uri="{FF2B5EF4-FFF2-40B4-BE49-F238E27FC236}">
-                <a16:creationId xmlns:a16="http://schemas.microsoft.com/office/drawing/2014/main" id="{D63F9E05-8923-438E-BD56-324BB99766B8}"/>
+                <a16:creationId xmlns:a16="http://schemas.microsoft.com/office/drawing/2014/main" id="{318F1AED-6645-4976-B3A8-62A2383315B3}"/>
               </a:ext>
             </a:extLst>
           </p:cNvPr>
@@ -14434,7 +14354,7 @@
           <p:cNvPr id="36" name="">
             <a:extLst xmlns:a="http://schemas.openxmlformats.org/drawingml/2006/main">
               <a:ext uri="{FF2B5EF4-FFF2-40B4-BE49-F238E27FC236}">
-                <a16:creationId xmlns:a16="http://schemas.microsoft.com/office/drawing/2014/main" id="{B04BC483-F663-439F-AE30-3B87D25942FD}"/>
+                <a16:creationId xmlns:a16="http://schemas.microsoft.com/office/drawing/2014/main" id="{8F51EA52-4887-4F92-8CB9-E2AF20C65EEB}"/>
               </a:ext>
             </a:extLst>
           </p:cNvPr>
@@ -14498,7 +14418,7 @@
           <p:cNvPr id="37" name="">
             <a:extLst xmlns:a="http://schemas.openxmlformats.org/drawingml/2006/main">
               <a:ext uri="{FF2B5EF4-FFF2-40B4-BE49-F238E27FC236}">
-                <a16:creationId xmlns:a16="http://schemas.microsoft.com/office/drawing/2014/main" id="{75856EBB-6872-4F6F-B497-CCED7F4F8453}"/>
+                <a16:creationId xmlns:a16="http://schemas.microsoft.com/office/drawing/2014/main" id="{F07964C1-86B5-4033-8DA7-42E4039F40D4}"/>
               </a:ext>
             </a:extLst>
           </p:cNvPr>
@@ -14560,7 +14480,7 @@
     </p:spTree>
     <p:extLst>
       <p:ext uri="{BB962C8B-B14F-4D97-AF65-F5344CB8AC3E}">
-        <p14:creationId xmlns:p14="http://schemas.microsoft.com/office/powerpoint/2010/main" val="1684184312"/>
+        <p14:creationId xmlns:p14="http://schemas.microsoft.com/office/powerpoint/2010/main" val="1370767342"/>
       </p:ext>
     </p:extLst>
   </p:cSld>
@@ -14584,7 +14504,7 @@
           <p:cNvPr id="1" name="">
             <a:extLst xmlns:a="http://schemas.openxmlformats.org/drawingml/2006/main">
               <a:ext uri="{FF2B5EF4-FFF2-40B4-BE49-F238E27FC236}">
-                <a16:creationId xmlns:a16="http://schemas.microsoft.com/office/drawing/2014/main" id="{004E6184-1D6D-40CA-982F-48B294A7FEEE}"/>
+                <a16:creationId xmlns:a16="http://schemas.microsoft.com/office/drawing/2014/main" id="{F85B1D79-23FD-4D50-8398-E6EB2932B463}"/>
               </a:ext>
             </a:extLst>
           </p:cNvPr>
@@ -14619,7 +14539,7 @@
           <p:cNvPr id="2" name="">
             <a:extLst xmlns:a="http://schemas.openxmlformats.org/drawingml/2006/main">
               <a:ext uri="{FF2B5EF4-FFF2-40B4-BE49-F238E27FC236}">
-                <a16:creationId xmlns:a16="http://schemas.microsoft.com/office/drawing/2014/main" id="{CE143F08-991A-4AA8-B450-E95EBCDFE998}"/>
+                <a16:creationId xmlns:a16="http://schemas.microsoft.com/office/drawing/2014/main" id="{1961F6C0-49E2-41CD-8BE2-99E6BEDF895C}"/>
               </a:ext>
             </a:extLst>
           </p:cNvPr>
@@ -14654,7 +14574,7 @@
           <p:cNvPr id="3" name="">
             <a:extLst xmlns:a="http://schemas.openxmlformats.org/drawingml/2006/main">
               <a:ext uri="{FF2B5EF4-FFF2-40B4-BE49-F238E27FC236}">
-                <a16:creationId xmlns:a16="http://schemas.microsoft.com/office/drawing/2014/main" id="{6077926D-FB53-4FFA-A706-17342B4B80AF}"/>
+                <a16:creationId xmlns:a16="http://schemas.microsoft.com/office/drawing/2014/main" id="{DCA77CE5-300E-44B3-9989-641D9E760FEB}"/>
               </a:ext>
             </a:extLst>
           </p:cNvPr>
@@ -14689,7 +14609,7 @@
           <p:cNvPr id="4" name="">
             <a:extLst xmlns:a="http://schemas.openxmlformats.org/drawingml/2006/main">
               <a:ext uri="{FF2B5EF4-FFF2-40B4-BE49-F238E27FC236}">
-                <a16:creationId xmlns:a16="http://schemas.microsoft.com/office/drawing/2014/main" id="{93B45613-8F21-4B34-9CD1-C1AD4E17911D}"/>
+                <a16:creationId xmlns:a16="http://schemas.microsoft.com/office/drawing/2014/main" id="{71804028-E66E-41C3-8186-44981927CBAD}"/>
               </a:ext>
             </a:extLst>
           </p:cNvPr>
@@ -14753,7 +14673,7 @@
           <p:cNvPr id="5" name="">
             <a:extLst xmlns:a="http://schemas.openxmlformats.org/drawingml/2006/main">
               <a:ext uri="{FF2B5EF4-FFF2-40B4-BE49-F238E27FC236}">
-                <a16:creationId xmlns:a16="http://schemas.microsoft.com/office/drawing/2014/main" id="{DF2BAD91-FA3C-4D80-98CA-EEA28899C0FF}"/>
+                <a16:creationId xmlns:a16="http://schemas.microsoft.com/office/drawing/2014/main" id="{0DC4294C-3613-4E1E-AB8F-0049CEAB4A22}"/>
               </a:ext>
             </a:extLst>
           </p:cNvPr>
@@ -14817,7 +14737,7 @@
           <p:cNvPr id="6" name="">
             <a:extLst xmlns:a="http://schemas.openxmlformats.org/drawingml/2006/main">
               <a:ext uri="{FF2B5EF4-FFF2-40B4-BE49-F238E27FC236}">
-                <a16:creationId xmlns:a16="http://schemas.microsoft.com/office/drawing/2014/main" id="{CA962E78-5035-472A-8121-4E7E278608A0}"/>
+                <a16:creationId xmlns:a16="http://schemas.microsoft.com/office/drawing/2014/main" id="{1CFDC460-CEA5-4788-844B-57230EFAD5B5}"/>
               </a:ext>
             </a:extLst>
           </p:cNvPr>
@@ -14850,7 +14770,7 @@
           <p:cNvPr id="7" name="">
             <a:extLst xmlns:a="http://schemas.openxmlformats.org/drawingml/2006/main">
               <a:ext uri="{FF2B5EF4-FFF2-40B4-BE49-F238E27FC236}">
-                <a16:creationId xmlns:a16="http://schemas.microsoft.com/office/drawing/2014/main" id="{E84204AB-3D1F-4232-837B-7D4A7D7AB84E}"/>
+                <a16:creationId xmlns:a16="http://schemas.microsoft.com/office/drawing/2014/main" id="{AB59AA2A-0990-46DC-8329-0445F41506D1}"/>
               </a:ext>
             </a:extLst>
           </p:cNvPr>
@@ -14885,7 +14805,7 @@
           <p:cNvPr id="8" name="">
             <a:extLst xmlns:a="http://schemas.openxmlformats.org/drawingml/2006/main">
               <a:ext uri="{FF2B5EF4-FFF2-40B4-BE49-F238E27FC236}">
-                <a16:creationId xmlns:a16="http://schemas.microsoft.com/office/drawing/2014/main" id="{DBE95A36-DB75-4098-ABB1-553C4601D2C0}"/>
+                <a16:creationId xmlns:a16="http://schemas.microsoft.com/office/drawing/2014/main" id="{6359B728-13E4-4776-9D3E-A2F064B78221}"/>
               </a:ext>
             </a:extLst>
           </p:cNvPr>
@@ -14949,7 +14869,7 @@
           <p:cNvPr id="9" name="">
             <a:extLst xmlns:a="http://schemas.openxmlformats.org/drawingml/2006/main">
               <a:ext uri="{FF2B5EF4-FFF2-40B4-BE49-F238E27FC236}">
-                <a16:creationId xmlns:a16="http://schemas.microsoft.com/office/drawing/2014/main" id="{6CD204BF-20B8-47C2-82FD-D7C32F81D611}"/>
+                <a16:creationId xmlns:a16="http://schemas.microsoft.com/office/drawing/2014/main" id="{D7A4EF4F-D03F-4ECB-B5E5-D8E3C71F9500}"/>
               </a:ext>
             </a:extLst>
           </p:cNvPr>
@@ -15013,7 +14933,7 @@
           <p:cNvPr id="10" name="">
             <a:extLst xmlns:a="http://schemas.openxmlformats.org/drawingml/2006/main">
               <a:ext uri="{FF2B5EF4-FFF2-40B4-BE49-F238E27FC236}">
-                <a16:creationId xmlns:a16="http://schemas.microsoft.com/office/drawing/2014/main" id="{B7733A15-A6EF-4C1E-85F0-D2A6FA2D95EB}"/>
+                <a16:creationId xmlns:a16="http://schemas.microsoft.com/office/drawing/2014/main" id="{6CC05CED-2F91-4AB2-A7E0-6EC0BF8749A9}"/>
               </a:ext>
             </a:extLst>
           </p:cNvPr>
@@ -15046,7 +14966,7 @@
           <p:cNvPr id="11" name="">
             <a:extLst xmlns:a="http://schemas.openxmlformats.org/drawingml/2006/main">
               <a:ext uri="{FF2B5EF4-FFF2-40B4-BE49-F238E27FC236}">
-                <a16:creationId xmlns:a16="http://schemas.microsoft.com/office/drawing/2014/main" id="{4F245AB2-1817-4311-BF38-12EA7926E9F5}"/>
+                <a16:creationId xmlns:a16="http://schemas.microsoft.com/office/drawing/2014/main" id="{E7E501FD-A809-4D47-9182-4E33AB8C07C9}"/>
               </a:ext>
             </a:extLst>
           </p:cNvPr>
@@ -15081,7 +15001,7 @@
           <p:cNvPr id="12" name="">
             <a:extLst xmlns:a="http://schemas.openxmlformats.org/drawingml/2006/main">
               <a:ext uri="{FF2B5EF4-FFF2-40B4-BE49-F238E27FC236}">
-                <a16:creationId xmlns:a16="http://schemas.microsoft.com/office/drawing/2014/main" id="{D5537EDB-8145-436F-BAC2-1342F9777649}"/>
+                <a16:creationId xmlns:a16="http://schemas.microsoft.com/office/drawing/2014/main" id="{DCE0EFA4-4321-43CB-9F1E-88049601C201}"/>
               </a:ext>
             </a:extLst>
           </p:cNvPr>
@@ -15135,7 +15055,7 @@
                 <a:ea typeface="PingFang SC"/>
                 <a:cs typeface="PingFang SC"/>
               </a:rPr>
-              <a:t>角色维护</a:t>
+              <a:t>角色管理</a:t>
             </a:r>
           </a:p>
         </p:txBody>
@@ -15145,7 +15065,7 @@
           <p:cNvPr id="13" name="">
             <a:extLst xmlns:a="http://schemas.openxmlformats.org/drawingml/2006/main">
               <a:ext uri="{FF2B5EF4-FFF2-40B4-BE49-F238E27FC236}">
-                <a16:creationId xmlns:a16="http://schemas.microsoft.com/office/drawing/2014/main" id="{D935C83F-0974-4246-A2CF-5A1BAB4B71E5}"/>
+                <a16:creationId xmlns:a16="http://schemas.microsoft.com/office/drawing/2014/main" id="{2595665E-CD74-4B4F-8285-C2A2C476B0D4}"/>
               </a:ext>
             </a:extLst>
           </p:cNvPr>
@@ -15199,7 +15119,7 @@
                 <a:ea typeface="PingFang SC"/>
                 <a:cs typeface="PingFang SC"/>
               </a:rPr>
-              <a:t>AI 角色列表、状态管理、资料维护；由角色维护者和管理员进入。</a:t>
+              <a:t>普通用户维护自己的 AI 角色；管理员统一管理角色状态和平台可用性。</a:t>
             </a:r>
           </a:p>
         </p:txBody>
@@ -15209,7 +15129,7 @@
           <p:cNvPr id="14" name="">
             <a:extLst xmlns:a="http://schemas.openxmlformats.org/drawingml/2006/main">
               <a:ext uri="{FF2B5EF4-FFF2-40B4-BE49-F238E27FC236}">
-                <a16:creationId xmlns:a16="http://schemas.microsoft.com/office/drawing/2014/main" id="{140E6768-B9D6-4CD2-B50D-B62305025D1B}"/>
+                <a16:creationId xmlns:a16="http://schemas.microsoft.com/office/drawing/2014/main" id="{B1926312-EF78-4B8B-984F-E73D16DFE8A2}"/>
               </a:ext>
             </a:extLst>
           </p:cNvPr>
@@ -15242,7 +15162,7 @@
           <p:cNvPr id="15" name="">
             <a:extLst xmlns:a="http://schemas.openxmlformats.org/drawingml/2006/main">
               <a:ext uri="{FF2B5EF4-FFF2-40B4-BE49-F238E27FC236}">
-                <a16:creationId xmlns:a16="http://schemas.microsoft.com/office/drawing/2014/main" id="{7F30FB96-5D44-4E8A-98FA-BFE99A0C275D}"/>
+                <a16:creationId xmlns:a16="http://schemas.microsoft.com/office/drawing/2014/main" id="{87781C4A-CCA8-45FB-962B-80D74F32BC08}"/>
               </a:ext>
             </a:extLst>
           </p:cNvPr>
@@ -15277,7 +15197,7 @@
           <p:cNvPr id="16" name="">
             <a:extLst xmlns:a="http://schemas.openxmlformats.org/drawingml/2006/main">
               <a:ext uri="{FF2B5EF4-FFF2-40B4-BE49-F238E27FC236}">
-                <a16:creationId xmlns:a16="http://schemas.microsoft.com/office/drawing/2014/main" id="{E6AA6505-A448-4CE2-A61D-BDD558098C67}"/>
+                <a16:creationId xmlns:a16="http://schemas.microsoft.com/office/drawing/2014/main" id="{58A1D722-AF49-451A-B360-ECF4BE728C83}"/>
               </a:ext>
             </a:extLst>
           </p:cNvPr>
@@ -15341,7 +15261,7 @@
           <p:cNvPr id="17" name="">
             <a:extLst xmlns:a="http://schemas.openxmlformats.org/drawingml/2006/main">
               <a:ext uri="{FF2B5EF4-FFF2-40B4-BE49-F238E27FC236}">
-                <a16:creationId xmlns:a16="http://schemas.microsoft.com/office/drawing/2014/main" id="{57F0FD9D-EFAB-4C31-9F94-D70D437BFE30}"/>
+                <a16:creationId xmlns:a16="http://schemas.microsoft.com/office/drawing/2014/main" id="{A8A7735E-35B6-4B42-A9BA-C3C35D8001AE}"/>
               </a:ext>
             </a:extLst>
           </p:cNvPr>
@@ -15405,7 +15325,7 @@
           <p:cNvPr id="18" name="">
             <a:extLst xmlns:a="http://schemas.openxmlformats.org/drawingml/2006/main">
               <a:ext uri="{FF2B5EF4-FFF2-40B4-BE49-F238E27FC236}">
-                <a16:creationId xmlns:a16="http://schemas.microsoft.com/office/drawing/2014/main" id="{674584CD-E1E1-4B06-8EFE-4AB008C33DBC}"/>
+                <a16:creationId xmlns:a16="http://schemas.microsoft.com/office/drawing/2014/main" id="{8278EEC5-9795-46D8-A6F8-67C8CB8DF5F9}"/>
               </a:ext>
             </a:extLst>
           </p:cNvPr>
@@ -15438,7 +15358,7 @@
           <p:cNvPr id="19" name="">
             <a:extLst xmlns:a="http://schemas.openxmlformats.org/drawingml/2006/main">
               <a:ext uri="{FF2B5EF4-FFF2-40B4-BE49-F238E27FC236}">
-                <a16:creationId xmlns:a16="http://schemas.microsoft.com/office/drawing/2014/main" id="{1C121FE5-FBA2-4657-9C68-3258575013F6}"/>
+                <a16:creationId xmlns:a16="http://schemas.microsoft.com/office/drawing/2014/main" id="{7E68994F-D850-425C-8B33-B49CD6002EF2}"/>
               </a:ext>
             </a:extLst>
           </p:cNvPr>
@@ -15473,7 +15393,7 @@
           <p:cNvPr id="20" name="">
             <a:extLst xmlns:a="http://schemas.openxmlformats.org/drawingml/2006/main">
               <a:ext uri="{FF2B5EF4-FFF2-40B4-BE49-F238E27FC236}">
-                <a16:creationId xmlns:a16="http://schemas.microsoft.com/office/drawing/2014/main" id="{612DCD21-00F2-4B9D-84BD-03F85AD8CC41}"/>
+                <a16:creationId xmlns:a16="http://schemas.microsoft.com/office/drawing/2014/main" id="{D8D8CFBC-7962-4D62-9DCA-252D94CBA75F}"/>
               </a:ext>
             </a:extLst>
           </p:cNvPr>
@@ -15537,7 +15457,7 @@
           <p:cNvPr id="21" name="">
             <a:extLst xmlns:a="http://schemas.openxmlformats.org/drawingml/2006/main">
               <a:ext uri="{FF2B5EF4-FFF2-40B4-BE49-F238E27FC236}">
-                <a16:creationId xmlns:a16="http://schemas.microsoft.com/office/drawing/2014/main" id="{24B50E8F-2111-4E1C-BECB-ED26855CCDB7}"/>
+                <a16:creationId xmlns:a16="http://schemas.microsoft.com/office/drawing/2014/main" id="{3FC7A685-C342-48BA-90ED-6880ABA960E7}"/>
               </a:ext>
             </a:extLst>
           </p:cNvPr>
@@ -15601,7 +15521,7 @@
           <p:cNvPr id="22" name="">
             <a:extLst xmlns:a="http://schemas.openxmlformats.org/drawingml/2006/main">
               <a:ext uri="{FF2B5EF4-FFF2-40B4-BE49-F238E27FC236}">
-                <a16:creationId xmlns:a16="http://schemas.microsoft.com/office/drawing/2014/main" id="{9C0D3E01-C5F8-4A0C-8C11-713A7D59E33A}"/>
+                <a16:creationId xmlns:a16="http://schemas.microsoft.com/office/drawing/2014/main" id="{695F5324-3DC7-4DF4-85C8-2899F131F5B7}"/>
               </a:ext>
             </a:extLst>
           </p:cNvPr>
@@ -15634,7 +15554,7 @@
           <p:cNvPr id="23" name="">
             <a:extLst xmlns:a="http://schemas.openxmlformats.org/drawingml/2006/main">
               <a:ext uri="{FF2B5EF4-FFF2-40B4-BE49-F238E27FC236}">
-                <a16:creationId xmlns:a16="http://schemas.microsoft.com/office/drawing/2014/main" id="{8CEA3865-3B01-47C0-9399-94C34915F31F}"/>
+                <a16:creationId xmlns:a16="http://schemas.microsoft.com/office/drawing/2014/main" id="{8410DC1F-985B-4F94-840A-F92C9EEC0F21}"/>
               </a:ext>
             </a:extLst>
           </p:cNvPr>
@@ -15669,7 +15589,7 @@
           <p:cNvPr id="24" name="">
             <a:extLst xmlns:a="http://schemas.openxmlformats.org/drawingml/2006/main">
               <a:ext uri="{FF2B5EF4-FFF2-40B4-BE49-F238E27FC236}">
-                <a16:creationId xmlns:a16="http://schemas.microsoft.com/office/drawing/2014/main" id="{E3C7B810-3AEE-4CA5-86D7-BBF39D65821E}"/>
+                <a16:creationId xmlns:a16="http://schemas.microsoft.com/office/drawing/2014/main" id="{9BFC4B6A-7883-4C0E-8395-71975A2B9E84}"/>
               </a:ext>
             </a:extLst>
           </p:cNvPr>
@@ -15733,7 +15653,7 @@
           <p:cNvPr id="25" name="">
             <a:extLst xmlns:a="http://schemas.openxmlformats.org/drawingml/2006/main">
               <a:ext uri="{FF2B5EF4-FFF2-40B4-BE49-F238E27FC236}">
-                <a16:creationId xmlns:a16="http://schemas.microsoft.com/office/drawing/2014/main" id="{19B1F7D9-1A6F-478F-8DB4-F7EE14188868}"/>
+                <a16:creationId xmlns:a16="http://schemas.microsoft.com/office/drawing/2014/main" id="{B801300A-0D8C-442F-9FF5-594C8753AA57}"/>
               </a:ext>
             </a:extLst>
           </p:cNvPr>
@@ -15797,7 +15717,7 @@
           <p:cNvPr id="26" name="">
             <a:extLst xmlns:a="http://schemas.openxmlformats.org/drawingml/2006/main">
               <a:ext uri="{FF2B5EF4-FFF2-40B4-BE49-F238E27FC236}">
-                <a16:creationId xmlns:a16="http://schemas.microsoft.com/office/drawing/2014/main" id="{3B8BCAF4-D887-4D45-8D56-D4D86256D532}"/>
+                <a16:creationId xmlns:a16="http://schemas.microsoft.com/office/drawing/2014/main" id="{EE898295-4A64-4BF1-A844-F9350833810B}"/>
               </a:ext>
             </a:extLst>
           </p:cNvPr>
@@ -15830,7 +15750,7 @@
           <p:cNvPr id="27" name="">
             <a:extLst xmlns:a="http://schemas.openxmlformats.org/drawingml/2006/main">
               <a:ext uri="{FF2B5EF4-FFF2-40B4-BE49-F238E27FC236}">
-                <a16:creationId xmlns:a16="http://schemas.microsoft.com/office/drawing/2014/main" id="{5EE87EB8-E13E-46BE-B538-1D1CB57B1AF8}"/>
+                <a16:creationId xmlns:a16="http://schemas.microsoft.com/office/drawing/2014/main" id="{F37B10AA-E7DC-4FD9-BEC4-8CA399216C43}"/>
               </a:ext>
             </a:extLst>
           </p:cNvPr>
@@ -15865,7 +15785,7 @@
           <p:cNvPr id="28" name="">
             <a:extLst xmlns:a="http://schemas.openxmlformats.org/drawingml/2006/main">
               <a:ext uri="{FF2B5EF4-FFF2-40B4-BE49-F238E27FC236}">
-                <a16:creationId xmlns:a16="http://schemas.microsoft.com/office/drawing/2014/main" id="{0F4F345E-7E96-4A64-9DD6-8385EC4AF08C}"/>
+                <a16:creationId xmlns:a16="http://schemas.microsoft.com/office/drawing/2014/main" id="{233E3B64-08EC-4A87-9653-34C8BEBB5F3E}"/>
               </a:ext>
             </a:extLst>
           </p:cNvPr>
@@ -15929,7 +15849,7 @@
           <p:cNvPr id="29" name="">
             <a:extLst xmlns:a="http://schemas.openxmlformats.org/drawingml/2006/main">
               <a:ext uri="{FF2B5EF4-FFF2-40B4-BE49-F238E27FC236}">
-                <a16:creationId xmlns:a16="http://schemas.microsoft.com/office/drawing/2014/main" id="{C2FD0420-A520-42FC-AC8B-27B979B1B99F}"/>
+                <a16:creationId xmlns:a16="http://schemas.microsoft.com/office/drawing/2014/main" id="{D36BBDB6-019F-46BD-B4B9-408AB8C8CEBA}"/>
               </a:ext>
             </a:extLst>
           </p:cNvPr>
@@ -15983,7 +15903,7 @@
                 <a:ea typeface="PingFang SC"/>
                 <a:cs typeface="PingFang SC"/>
               </a:rPr>
-              <a:t>真实 LLM、流式响应、统计图表、权限细化都可在当前结构上继续扩展。</a:t>
+              <a:t>DeepSeek 适配层、流式响应、统计图表、权限细化都可在当前结构上继续扩展。</a:t>
             </a:r>
           </a:p>
         </p:txBody>
@@ -15993,7 +15913,7 @@
           <p:cNvPr id="30" name="">
             <a:extLst xmlns:a="http://schemas.openxmlformats.org/drawingml/2006/main">
               <a:ext uri="{FF2B5EF4-FFF2-40B4-BE49-F238E27FC236}">
-                <a16:creationId xmlns:a16="http://schemas.microsoft.com/office/drawing/2014/main" id="{DBDD1B56-CF2F-40DD-8748-34FFF5CB90FE}"/>
+                <a16:creationId xmlns:a16="http://schemas.microsoft.com/office/drawing/2014/main" id="{0485B139-49FF-4D6A-9570-B052D62A53FC}"/>
               </a:ext>
             </a:extLst>
           </p:cNvPr>
@@ -16057,7 +15977,7 @@
           <p:cNvPr id="31" name="">
             <a:extLst xmlns:a="http://schemas.openxmlformats.org/drawingml/2006/main">
               <a:ext uri="{FF2B5EF4-FFF2-40B4-BE49-F238E27FC236}">
-                <a16:creationId xmlns:a16="http://schemas.microsoft.com/office/drawing/2014/main" id="{61A51BD9-5120-4439-93F1-538F2EDB3930}"/>
+                <a16:creationId xmlns:a16="http://schemas.microsoft.com/office/drawing/2014/main" id="{06A8E0CB-5A8D-4D34-B6C5-FAFD76B316F5}"/>
               </a:ext>
             </a:extLst>
           </p:cNvPr>
@@ -16119,7 +16039,7 @@
     </p:spTree>
     <p:extLst>
       <p:ext uri="{BB962C8B-B14F-4D97-AF65-F5344CB8AC3E}">
-        <p14:creationId xmlns:p14="http://schemas.microsoft.com/office/powerpoint/2010/main" val="182568080"/>
+        <p14:creationId xmlns:p14="http://schemas.microsoft.com/office/powerpoint/2010/main" val="373757833"/>
       </p:ext>
     </p:extLst>
   </p:cSld>
@@ -16143,7 +16063,7 @@
           <p:cNvPr id="1" name="">
             <a:extLst xmlns:a="http://schemas.openxmlformats.org/drawingml/2006/main">
               <a:ext uri="{FF2B5EF4-FFF2-40B4-BE49-F238E27FC236}">
-                <a16:creationId xmlns:a16="http://schemas.microsoft.com/office/drawing/2014/main" id="{D525C239-73F9-46CB-804F-EC7130E71840}"/>
+                <a16:creationId xmlns:a16="http://schemas.microsoft.com/office/drawing/2014/main" id="{6DA1CCAD-E564-4AC3-A8E9-152D06751E96}"/>
               </a:ext>
             </a:extLst>
           </p:cNvPr>
@@ -16178,7 +16098,7 @@
           <p:cNvPr id="2" name="">
             <a:extLst xmlns:a="http://schemas.openxmlformats.org/drawingml/2006/main">
               <a:ext uri="{FF2B5EF4-FFF2-40B4-BE49-F238E27FC236}">
-                <a16:creationId xmlns:a16="http://schemas.microsoft.com/office/drawing/2014/main" id="{2CC6C9D1-29BC-4B48-A789-C3E2808365E6}"/>
+                <a16:creationId xmlns:a16="http://schemas.microsoft.com/office/drawing/2014/main" id="{EA4401D5-9067-4325-BB91-65AAE4D68C24}"/>
               </a:ext>
             </a:extLst>
           </p:cNvPr>
@@ -16213,7 +16133,7 @@
           <p:cNvPr id="3" name="">
             <a:extLst xmlns:a="http://schemas.openxmlformats.org/drawingml/2006/main">
               <a:ext uri="{FF2B5EF4-FFF2-40B4-BE49-F238E27FC236}">
-                <a16:creationId xmlns:a16="http://schemas.microsoft.com/office/drawing/2014/main" id="{365BD149-8A38-4AF8-9C8D-38C017F14AB8}"/>
+                <a16:creationId xmlns:a16="http://schemas.microsoft.com/office/drawing/2014/main" id="{A428E11C-F528-49A4-9921-430C03F1E60D}"/>
               </a:ext>
             </a:extLst>
           </p:cNvPr>
@@ -16248,7 +16168,7 @@
           <p:cNvPr id="4" name="">
             <a:extLst xmlns:a="http://schemas.openxmlformats.org/drawingml/2006/main">
               <a:ext uri="{FF2B5EF4-FFF2-40B4-BE49-F238E27FC236}">
-                <a16:creationId xmlns:a16="http://schemas.microsoft.com/office/drawing/2014/main" id="{FC42CE67-49F9-45F4-9DEC-D5F0DBD3BCFF}"/>
+                <a16:creationId xmlns:a16="http://schemas.microsoft.com/office/drawing/2014/main" id="{8FC30E70-EDC4-4001-B76C-0FB134492E3B}"/>
               </a:ext>
             </a:extLst>
           </p:cNvPr>
@@ -16312,7 +16232,7 @@
           <p:cNvPr id="5" name="">
             <a:extLst xmlns:a="http://schemas.openxmlformats.org/drawingml/2006/main">
               <a:ext uri="{FF2B5EF4-FFF2-40B4-BE49-F238E27FC236}">
-                <a16:creationId xmlns:a16="http://schemas.microsoft.com/office/drawing/2014/main" id="{DE373BD9-5231-4C70-99A1-807C88081DEF}"/>
+                <a16:creationId xmlns:a16="http://schemas.microsoft.com/office/drawing/2014/main" id="{4EF26BE1-53E2-4BEB-9E98-7051A7F69590}"/>
               </a:ext>
             </a:extLst>
           </p:cNvPr>
@@ -16376,7 +16296,7 @@
           <p:cNvPr id="6" name="">
             <a:extLst xmlns:a="http://schemas.openxmlformats.org/drawingml/2006/main">
               <a:ext uri="{FF2B5EF4-FFF2-40B4-BE49-F238E27FC236}">
-                <a16:creationId xmlns:a16="http://schemas.microsoft.com/office/drawing/2014/main" id="{ED35C2B6-787B-4160-BF97-9B4B0D8D2ED6}"/>
+                <a16:creationId xmlns:a16="http://schemas.microsoft.com/office/drawing/2014/main" id="{CA71154F-7670-45CE-82FE-C50B07089BDB}"/>
               </a:ext>
             </a:extLst>
           </p:cNvPr>
@@ -16409,7 +16329,7 @@
           <p:cNvPr id="7" name="">
             <a:extLst xmlns:a="http://schemas.openxmlformats.org/drawingml/2006/main">
               <a:ext uri="{FF2B5EF4-FFF2-40B4-BE49-F238E27FC236}">
-                <a16:creationId xmlns:a16="http://schemas.microsoft.com/office/drawing/2014/main" id="{D3D5724F-D707-43FD-98F3-A095B367F152}"/>
+                <a16:creationId xmlns:a16="http://schemas.microsoft.com/office/drawing/2014/main" id="{1B4E7B77-B44B-4D99-BAAC-B12CB71C6B4E}"/>
               </a:ext>
             </a:extLst>
           </p:cNvPr>
@@ -16444,7 +16364,7 @@
           <p:cNvPr id="8" name="">
             <a:extLst xmlns:a="http://schemas.openxmlformats.org/drawingml/2006/main">
               <a:ext uri="{FF2B5EF4-FFF2-40B4-BE49-F238E27FC236}">
-                <a16:creationId xmlns:a16="http://schemas.microsoft.com/office/drawing/2014/main" id="{75AEE9C9-D967-4E30-B60B-A491AE9F3818}"/>
+                <a16:creationId xmlns:a16="http://schemas.microsoft.com/office/drawing/2014/main" id="{364BC8CA-B97E-44D1-9A59-712D463D1AC0}"/>
               </a:ext>
             </a:extLst>
           </p:cNvPr>
@@ -16508,7 +16428,7 @@
           <p:cNvPr id="9" name="">
             <a:extLst xmlns:a="http://schemas.openxmlformats.org/drawingml/2006/main">
               <a:ext uri="{FF2B5EF4-FFF2-40B4-BE49-F238E27FC236}">
-                <a16:creationId xmlns:a16="http://schemas.microsoft.com/office/drawing/2014/main" id="{95B66952-EE76-42CA-96D7-E8BC1CEBC5C8}"/>
+                <a16:creationId xmlns:a16="http://schemas.microsoft.com/office/drawing/2014/main" id="{47BF7EB1-2F96-4569-B486-F14BFD354CFA}"/>
               </a:ext>
             </a:extLst>
           </p:cNvPr>
@@ -16543,7 +16463,7 @@
           <p:cNvPr id="10" name="">
             <a:extLst xmlns:a="http://schemas.openxmlformats.org/drawingml/2006/main">
               <a:ext uri="{FF2B5EF4-FFF2-40B4-BE49-F238E27FC236}">
-                <a16:creationId xmlns:a16="http://schemas.microsoft.com/office/drawing/2014/main" id="{74CE32CB-3EDD-4B38-9719-D96B1F9F3D9C}"/>
+                <a16:creationId xmlns:a16="http://schemas.microsoft.com/office/drawing/2014/main" id="{3547147B-CC3F-472E-B011-CFED26685E63}"/>
               </a:ext>
             </a:extLst>
           </p:cNvPr>
@@ -16607,7 +16527,7 @@
           <p:cNvPr id="11" name="">
             <a:extLst xmlns:a="http://schemas.openxmlformats.org/drawingml/2006/main">
               <a:ext uri="{FF2B5EF4-FFF2-40B4-BE49-F238E27FC236}">
-                <a16:creationId xmlns:a16="http://schemas.microsoft.com/office/drawing/2014/main" id="{BAE46B5D-F56C-4C71-91C1-5C443843C916}"/>
+                <a16:creationId xmlns:a16="http://schemas.microsoft.com/office/drawing/2014/main" id="{5653397E-E146-46ED-B66E-68C32D92AAEC}"/>
               </a:ext>
             </a:extLst>
           </p:cNvPr>
@@ -16642,7 +16562,7 @@
           <p:cNvPr id="12" name="">
             <a:extLst xmlns:a="http://schemas.openxmlformats.org/drawingml/2006/main">
               <a:ext uri="{FF2B5EF4-FFF2-40B4-BE49-F238E27FC236}">
-                <a16:creationId xmlns:a16="http://schemas.microsoft.com/office/drawing/2014/main" id="{B99C7EC3-4687-4342-B127-30BE9CAC11D6}"/>
+                <a16:creationId xmlns:a16="http://schemas.microsoft.com/office/drawing/2014/main" id="{5252B6AE-0C62-4E46-B944-B0D436D4DDDF}"/>
               </a:ext>
             </a:extLst>
           </p:cNvPr>
@@ -16706,7 +16626,7 @@
           <p:cNvPr id="13" name="">
             <a:extLst xmlns:a="http://schemas.openxmlformats.org/drawingml/2006/main">
               <a:ext uri="{FF2B5EF4-FFF2-40B4-BE49-F238E27FC236}">
-                <a16:creationId xmlns:a16="http://schemas.microsoft.com/office/drawing/2014/main" id="{EBE16C87-E786-4AF0-A734-1B3E8F260190}"/>
+                <a16:creationId xmlns:a16="http://schemas.microsoft.com/office/drawing/2014/main" id="{4179DA37-661F-41D5-814F-6EB345AC0CB5}"/>
               </a:ext>
             </a:extLst>
           </p:cNvPr>
@@ -16741,7 +16661,7 @@
           <p:cNvPr id="14" name="">
             <a:extLst xmlns:a="http://schemas.openxmlformats.org/drawingml/2006/main">
               <a:ext uri="{FF2B5EF4-FFF2-40B4-BE49-F238E27FC236}">
-                <a16:creationId xmlns:a16="http://schemas.microsoft.com/office/drawing/2014/main" id="{9CBB5854-5E57-4145-B346-A1E8837B9848}"/>
+                <a16:creationId xmlns:a16="http://schemas.microsoft.com/office/drawing/2014/main" id="{CC4A2975-E3B2-4C94-9C5A-EB196880C251}"/>
               </a:ext>
             </a:extLst>
           </p:cNvPr>
@@ -16795,7 +16715,7 @@
                 <a:ea typeface="PingFang SC"/>
                 <a:cs typeface="PingFang SC"/>
               </a:rPr>
-              <a:t>权限隔离：用户不能读取、收藏或反馈别人的消息；维护者不能进入管理员接口。</a:t>
+              <a:t>权限隔离：用户不能读取、收藏或反馈别人的消息；普通用户不能进入管理员接口。</a:t>
             </a:r>
           </a:p>
         </p:txBody>
@@ -16805,7 +16725,7 @@
           <p:cNvPr id="15" name="">
             <a:extLst xmlns:a="http://schemas.openxmlformats.org/drawingml/2006/main">
               <a:ext uri="{FF2B5EF4-FFF2-40B4-BE49-F238E27FC236}">
-                <a16:creationId xmlns:a16="http://schemas.microsoft.com/office/drawing/2014/main" id="{C8A4ABA1-9C03-457E-9674-905B0E8DCFC8}"/>
+                <a16:creationId xmlns:a16="http://schemas.microsoft.com/office/drawing/2014/main" id="{A0C89536-62F6-4886-ABAB-0FEE2ABAB3DA}"/>
               </a:ext>
             </a:extLst>
           </p:cNvPr>
@@ -16840,7 +16760,7 @@
           <p:cNvPr id="16" name="">
             <a:extLst xmlns:a="http://schemas.openxmlformats.org/drawingml/2006/main">
               <a:ext uri="{FF2B5EF4-FFF2-40B4-BE49-F238E27FC236}">
-                <a16:creationId xmlns:a16="http://schemas.microsoft.com/office/drawing/2014/main" id="{38F8DDE8-BA55-4E0E-90A9-4453325DD2B6}"/>
+                <a16:creationId xmlns:a16="http://schemas.microsoft.com/office/drawing/2014/main" id="{62BD8A80-49A2-49DE-A449-990D9417F767}"/>
               </a:ext>
             </a:extLst>
           </p:cNvPr>
@@ -16904,7 +16824,7 @@
           <p:cNvPr id="17" name="">
             <a:extLst xmlns:a="http://schemas.openxmlformats.org/drawingml/2006/main">
               <a:ext uri="{FF2B5EF4-FFF2-40B4-BE49-F238E27FC236}">
-                <a16:creationId xmlns:a16="http://schemas.microsoft.com/office/drawing/2014/main" id="{48C87B62-FB41-4B4D-9C3F-B2FDDE40939F}"/>
+                <a16:creationId xmlns:a16="http://schemas.microsoft.com/office/drawing/2014/main" id="{EB3342AE-210A-47C1-AF89-A2A919410977}"/>
               </a:ext>
             </a:extLst>
           </p:cNvPr>
@@ -16939,7 +16859,7 @@
           <p:cNvPr id="18" name="">
             <a:extLst xmlns:a="http://schemas.openxmlformats.org/drawingml/2006/main">
               <a:ext uri="{FF2B5EF4-FFF2-40B4-BE49-F238E27FC236}">
-                <a16:creationId xmlns:a16="http://schemas.microsoft.com/office/drawing/2014/main" id="{0013D217-BE04-4312-A0A6-962795C184E2}"/>
+                <a16:creationId xmlns:a16="http://schemas.microsoft.com/office/drawing/2014/main" id="{2F8B0EFD-494D-418E-AA05-EEC6D76590F6}"/>
               </a:ext>
             </a:extLst>
           </p:cNvPr>
@@ -16993,7 +16913,7 @@
                 <a:ea typeface="PingFang SC"/>
                 <a:cs typeface="PingFang SC"/>
               </a:rPr>
-              <a:t>登录提示时长缩短：成功消息 1 秒自动消失，避免挡住页面操作。</a:t>
+              <a:t>角色体系简化：移除独立角色维护者，保留普通用户和管理员两类身份。</a:t>
             </a:r>
           </a:p>
         </p:txBody>
@@ -17003,7 +16923,106 @@
           <p:cNvPr id="19" name="">
             <a:extLst xmlns:a="http://schemas.openxmlformats.org/drawingml/2006/main">
               <a:ext uri="{FF2B5EF4-FFF2-40B4-BE49-F238E27FC236}">
-                <a16:creationId xmlns:a16="http://schemas.microsoft.com/office/drawing/2014/main" id="{8EA7F200-2F65-4E73-9197-8301A5018AF9}"/>
+                <a16:creationId xmlns:a16="http://schemas.microsoft.com/office/drawing/2014/main" id="{C17E573D-66F8-4659-A0B7-C7E920E6D6CE}"/>
+              </a:ext>
+            </a:extLst>
+          </p:cNvPr>
+          <p:cNvSpPr>
+            <a:spLocks xmlns:a="http://schemas.openxmlformats.org/drawingml/2006/main" noGrp="1"/>
+          </p:cNvSpPr>
+          <p:nvPr/>
+        </p:nvSpPr>
+        <p:spPr>
+          <a:xfrm xmlns:a="http://schemas.openxmlformats.org/drawingml/2006/main">
+            <a:off x="1143000" y="4972050"/>
+            <a:ext cx="76200" cy="76200"/>
+          </a:xfrm>
+          <a:prstGeom xmlns:a="http://schemas.openxmlformats.org/drawingml/2006/main" prst="rect">
+            <a:avLst/>
+          </a:prstGeom>
+          <a:solidFill xmlns:a="http://schemas.openxmlformats.org/drawingml/2006/main">
+            <a:srgbClr val="2563EB"/>
+          </a:solidFill>
+          <a:ln xmlns:a="http://schemas.openxmlformats.org/drawingml/2006/main" w="0">
+            <a:solidFill>
+              <a:srgbClr val="000000">
+                <a:alpha val="0"/>
+              </a:srgbClr>
+            </a:solidFill>
+            <a:prstDash val="solid"/>
+          </a:ln>
+        </p:spPr>
+      </p:sp>
+      <p:sp>
+        <p:nvSpPr>
+          <p:cNvPr id="20" name="">
+            <a:extLst xmlns:a="http://schemas.openxmlformats.org/drawingml/2006/main">
+              <a:ext uri="{FF2B5EF4-FFF2-40B4-BE49-F238E27FC236}">
+                <a16:creationId xmlns:a16="http://schemas.microsoft.com/office/drawing/2014/main" id="{4540EE9E-E8F7-4A9B-A3DA-C3AD14207F98}"/>
+              </a:ext>
+            </a:extLst>
+          </p:cNvPr>
+          <p:cNvSpPr>
+            <a:spLocks xmlns:a="http://schemas.openxmlformats.org/drawingml/2006/main" noGrp="1"/>
+          </p:cNvSpPr>
+          <p:nvPr/>
+        </p:nvSpPr>
+        <p:spPr>
+          <a:xfrm xmlns:a="http://schemas.openxmlformats.org/drawingml/2006/main">
+            <a:off x="1371600" y="4905375"/>
+            <a:ext cx="9105900" cy="552450"/>
+          </a:xfrm>
+          <a:prstGeom xmlns:a="http://schemas.openxmlformats.org/drawingml/2006/main" prst="rect">
+            <a:avLst/>
+          </a:prstGeom>
+          <a:solidFill xmlns:a="http://schemas.openxmlformats.org/drawingml/2006/main">
+            <a:srgbClr val="000000">
+              <a:alpha val="0"/>
+            </a:srgbClr>
+          </a:solidFill>
+          <a:ln xmlns:a="http://schemas.openxmlformats.org/drawingml/2006/main" w="0">
+            <a:solidFill>
+              <a:srgbClr val="000000">
+                <a:alpha val="0"/>
+              </a:srgbClr>
+            </a:solidFill>
+            <a:prstDash val="solid"/>
+          </a:ln>
+        </p:spPr>
+        <p:txBody>
+          <a:bodyPr xmlns:a="http://schemas.openxmlformats.org/drawingml/2006/main" lIns="0" tIns="0" rIns="0" bIns="0" anchor="t"/>
+          <a:lstStyle xmlns:a="http://schemas.openxmlformats.org/drawingml/2006/main"/>
+          <a:p xmlns:a="http://schemas.openxmlformats.org/drawingml/2006/main">
+            <a:pPr algn="l">
+              <a:defRPr sz="1350" b="0">
+                <a:solidFill>
+                  <a:srgbClr val="111827"/>
+                </a:solidFill>
+                <a:latin typeface="PingFang SC"/>
+                <a:ea typeface="PingFang SC"/>
+                <a:cs typeface="PingFang SC"/>
+              </a:defRPr>
+            </a:pPr>
+            <a:r>
+              <a:rPr sz="1350" b="0">
+                <a:solidFill>
+                  <a:srgbClr val="111827"/>
+                </a:solidFill>
+                <a:latin typeface="PingFang SC"/>
+                <a:ea typeface="PingFang SC"/>
+                <a:cs typeface="PingFang SC"/>
+              </a:rPr>
+              <a:t>配置健壮性：DEBUG=release 可正常解析，DeepSeek 失败时回退模拟 AI。</a:t>
+            </a:r>
+          </a:p>
+        </p:txBody>
+      </p:sp>
+      <p:sp>
+        <p:nvSpPr>
+          <p:cNvPr id="21" name="">
+            <a:extLst xmlns:a="http://schemas.openxmlformats.org/drawingml/2006/main">
+              <a:ext uri="{FF2B5EF4-FFF2-40B4-BE49-F238E27FC236}">
+                <a16:creationId xmlns:a16="http://schemas.microsoft.com/office/drawing/2014/main" id="{11E2B082-A525-45F2-AD26-F37F5C07E029}"/>
               </a:ext>
             </a:extLst>
           </p:cNvPr>
@@ -17064,10 +17083,10 @@
       </p:sp>
       <p:sp>
         <p:nvSpPr>
-          <p:cNvPr id="20" name="">
-            <a:extLst xmlns:a="http://schemas.openxmlformats.org/drawingml/2006/main">
-              <a:ext uri="{FF2B5EF4-FFF2-40B4-BE49-F238E27FC236}">
-                <a16:creationId xmlns:a16="http://schemas.microsoft.com/office/drawing/2014/main" id="{A429929F-866C-4DF6-ABDD-34E446E0A82A}"/>
+          <p:cNvPr id="22" name="">
+            <a:extLst xmlns:a="http://schemas.openxmlformats.org/drawingml/2006/main">
+              <a:ext uri="{FF2B5EF4-FFF2-40B4-BE49-F238E27FC236}">
+                <a16:creationId xmlns:a16="http://schemas.microsoft.com/office/drawing/2014/main" id="{4DF9BF95-D98C-4601-8A28-20E6116E1220}"/>
               </a:ext>
             </a:extLst>
           </p:cNvPr>
@@ -17128,10 +17147,10 @@
       </p:sp>
       <p:sp>
         <p:nvSpPr>
-          <p:cNvPr id="21" name="">
-            <a:extLst xmlns:a="http://schemas.openxmlformats.org/drawingml/2006/main">
-              <a:ext uri="{FF2B5EF4-FFF2-40B4-BE49-F238E27FC236}">
-                <a16:creationId xmlns:a16="http://schemas.microsoft.com/office/drawing/2014/main" id="{490F0975-05F7-4030-9750-D96BD1221B4F}"/>
+          <p:cNvPr id="23" name="">
+            <a:extLst xmlns:a="http://schemas.openxmlformats.org/drawingml/2006/main">
+              <a:ext uri="{FF2B5EF4-FFF2-40B4-BE49-F238E27FC236}">
+                <a16:creationId xmlns:a16="http://schemas.microsoft.com/office/drawing/2014/main" id="{5787B623-4812-4940-88AD-A8ADDB3CB1A4}"/>
               </a:ext>
             </a:extLst>
           </p:cNvPr>
@@ -17193,7 +17212,7 @@
     </p:spTree>
     <p:extLst>
       <p:ext uri="{BB962C8B-B14F-4D97-AF65-F5344CB8AC3E}">
-        <p14:creationId xmlns:p14="http://schemas.microsoft.com/office/powerpoint/2010/main" val="2074061865"/>
+        <p14:creationId xmlns:p14="http://schemas.microsoft.com/office/powerpoint/2010/main" val="1397505576"/>
       </p:ext>
     </p:extLst>
   </p:cSld>

</xml_diff>